<commit_message>
Aula 2 de MD pt2
</commit_message>
<xml_diff>
--- a/UNIUBE-MD/Teoria_MD.pptx
+++ b/UNIUBE-MD/Teoria_MD.pptx
@@ -44,17 +44,17 @@
     <p:sldId id="316" r:id="rId35"/>
     <p:sldId id="317" r:id="rId36"/>
     <p:sldId id="320" r:id="rId37"/>
-    <p:sldId id="321" r:id="rId38"/>
-    <p:sldId id="322" r:id="rId39"/>
-    <p:sldId id="323" r:id="rId40"/>
-    <p:sldId id="324" r:id="rId41"/>
-    <p:sldId id="326" r:id="rId42"/>
-    <p:sldId id="325" r:id="rId43"/>
-    <p:sldId id="327" r:id="rId44"/>
-    <p:sldId id="328" r:id="rId45"/>
-    <p:sldId id="329" r:id="rId46"/>
-    <p:sldId id="330" r:id="rId47"/>
-    <p:sldId id="331" r:id="rId48"/>
+    <p:sldId id="322" r:id="rId38"/>
+    <p:sldId id="323" r:id="rId39"/>
+    <p:sldId id="324" r:id="rId40"/>
+    <p:sldId id="326" r:id="rId41"/>
+    <p:sldId id="325" r:id="rId42"/>
+    <p:sldId id="327" r:id="rId43"/>
+    <p:sldId id="328" r:id="rId44"/>
+    <p:sldId id="329" r:id="rId45"/>
+    <p:sldId id="330" r:id="rId46"/>
+    <p:sldId id="332" r:id="rId47"/>
+    <p:sldId id="321" r:id="rId48"/>
   </p:sldIdLst>
   <p:sldSz cx="12192000" cy="6858000"/>
   <p:notesSz cx="6858000" cy="9144000"/>
@@ -243,7 +243,7 @@
           <a:p>
             <a:fld id="{6ED03497-8374-466E-85FA-95E1138D8F6E}" type="datetimeFigureOut">
               <a:rPr lang="pt-BR" smtClean="0"/>
-              <a:t>08/08/2026</a:t>
+              <a:t>09/08/2026</a:t>
             </a:fld>
             <a:endParaRPr lang="pt-BR"/>
           </a:p>
@@ -4065,118 +4065,6 @@
         <p:cNvPr id="1" name="">
           <a:extLst>
             <a:ext uri="{FF2B5EF4-FFF2-40B4-BE49-F238E27FC236}">
-              <a16:creationId xmlns:a16="http://schemas.microsoft.com/office/drawing/2014/main" id="{45B0221E-6368-1C7D-9593-484248ACF94E}"/>
-            </a:ext>
-          </a:extLst>
-        </p:cNvPr>
-        <p:cNvGrpSpPr/>
-        <p:nvPr/>
-      </p:nvGrpSpPr>
-      <p:grpSpPr>
-        <a:xfrm>
-          <a:off x="0" y="0"/>
-          <a:ext cx="0" cy="0"/>
-          <a:chOff x="0" y="0"/>
-          <a:chExt cx="0" cy="0"/>
-        </a:xfrm>
-      </p:grpSpPr>
-      <p:sp>
-        <p:nvSpPr>
-          <p:cNvPr id="2" name="Espaço Reservado para Imagem de Slide 1">
-            <a:extLst>
-              <a:ext uri="{FF2B5EF4-FFF2-40B4-BE49-F238E27FC236}">
-                <a16:creationId xmlns:a16="http://schemas.microsoft.com/office/drawing/2014/main" id="{CD60B933-EE74-A667-09B1-66F8CCC1F8E6}"/>
-              </a:ext>
-            </a:extLst>
-          </p:cNvPr>
-          <p:cNvSpPr>
-            <a:spLocks noGrp="1" noRot="1" noChangeAspect="1"/>
-          </p:cNvSpPr>
-          <p:nvPr>
-            <p:ph type="sldImg"/>
-          </p:nvPr>
-        </p:nvSpPr>
-        <p:spPr/>
-      </p:sp>
-      <p:sp>
-        <p:nvSpPr>
-          <p:cNvPr id="3" name="Espaço Reservado para Anotações 2">
-            <a:extLst>
-              <a:ext uri="{FF2B5EF4-FFF2-40B4-BE49-F238E27FC236}">
-                <a16:creationId xmlns:a16="http://schemas.microsoft.com/office/drawing/2014/main" id="{C7F52DF8-BCEA-CDA9-5237-324EF1EE40C7}"/>
-              </a:ext>
-            </a:extLst>
-          </p:cNvPr>
-          <p:cNvSpPr>
-            <a:spLocks noGrp="1"/>
-          </p:cNvSpPr>
-          <p:nvPr>
-            <p:ph type="body" idx="1"/>
-          </p:nvPr>
-        </p:nvSpPr>
-        <p:spPr/>
-        <p:txBody>
-          <a:bodyPr/>
-          <a:lstStyle/>
-          <a:p>
-            <a:pPr marL="0" indent="0">
-              <a:buFontTx/>
-              <a:buNone/>
-            </a:pPr>
-            <a:endParaRPr lang="pt-BR" b="0" dirty="0"/>
-          </a:p>
-        </p:txBody>
-      </p:sp>
-      <p:sp>
-        <p:nvSpPr>
-          <p:cNvPr id="4" name="Espaço Reservado para Número de Slide 3">
-            <a:extLst>
-              <a:ext uri="{FF2B5EF4-FFF2-40B4-BE49-F238E27FC236}">
-                <a16:creationId xmlns:a16="http://schemas.microsoft.com/office/drawing/2014/main" id="{4A54C782-31C4-95EE-3CD4-D14A40A1035C}"/>
-              </a:ext>
-            </a:extLst>
-          </p:cNvPr>
-          <p:cNvSpPr>
-            <a:spLocks noGrp="1"/>
-          </p:cNvSpPr>
-          <p:nvPr>
-            <p:ph type="sldNum" sz="quarter" idx="5"/>
-          </p:nvPr>
-        </p:nvSpPr>
-        <p:spPr/>
-        <p:txBody>
-          <a:bodyPr/>
-          <a:lstStyle/>
-          <a:p>
-            <a:fld id="{80F36A49-A1DD-40F8-B8AD-E6F5365256CB}" type="slidenum">
-              <a:rPr lang="pt-BR" smtClean="0"/>
-              <a:t>36</a:t>
-            </a:fld>
-            <a:endParaRPr lang="pt-BR"/>
-          </a:p>
-        </p:txBody>
-      </p:sp>
-    </p:spTree>
-    <p:extLst>
-      <p:ext uri="{BB962C8B-B14F-4D97-AF65-F5344CB8AC3E}">
-        <p14:creationId xmlns:p14="http://schemas.microsoft.com/office/powerpoint/2010/main" val="1969739803"/>
-      </p:ext>
-    </p:extLst>
-  </p:cSld>
-  <p:clrMapOvr>
-    <a:masterClrMapping/>
-  </p:clrMapOvr>
-</p:notes>
-</file>
-
-<file path=ppt/notesSlides/notesSlide37.xml><?xml version="1.0" encoding="utf-8"?>
-<p:notes xmlns:a="http://schemas.openxmlformats.org/drawingml/2006/main" xmlns:r="http://schemas.openxmlformats.org/officeDocument/2006/relationships" xmlns:p="http://schemas.openxmlformats.org/presentationml/2006/main">
-  <p:cSld>
-    <p:spTree>
-      <p:nvGrpSpPr>
-        <p:cNvPr id="1" name="">
-          <a:extLst>
-            <a:ext uri="{FF2B5EF4-FFF2-40B4-BE49-F238E27FC236}">
               <a16:creationId xmlns:a16="http://schemas.microsoft.com/office/drawing/2014/main" id="{565217F2-0B57-A9D5-C01A-B725A7789E51}"/>
             </a:ext>
           </a:extLst>
@@ -4258,7 +4146,7 @@
           <a:p>
             <a:fld id="{80F36A49-A1DD-40F8-B8AD-E6F5365256CB}" type="slidenum">
               <a:rPr lang="pt-BR" smtClean="0"/>
-              <a:t>37</a:t>
+              <a:t>36</a:t>
             </a:fld>
             <a:endParaRPr lang="pt-BR"/>
           </a:p>
@@ -4277,7 +4165,7 @@
 </p:notes>
 </file>
 
-<file path=ppt/notesSlides/notesSlide38.xml><?xml version="1.0" encoding="utf-8"?>
+<file path=ppt/notesSlides/notesSlide37.xml><?xml version="1.0" encoding="utf-8"?>
 <p:notes xmlns:a="http://schemas.openxmlformats.org/drawingml/2006/main" xmlns:r="http://schemas.openxmlformats.org/officeDocument/2006/relationships" xmlns:p="http://schemas.openxmlformats.org/presentationml/2006/main">
   <p:cSld>
     <p:spTree>
@@ -4370,7 +4258,7 @@
           <a:p>
             <a:fld id="{80F36A49-A1DD-40F8-B8AD-E6F5365256CB}" type="slidenum">
               <a:rPr lang="pt-BR" smtClean="0"/>
-              <a:t>38</a:t>
+              <a:t>37</a:t>
             </a:fld>
             <a:endParaRPr lang="pt-BR"/>
           </a:p>
@@ -4389,7 +4277,7 @@
 </p:notes>
 </file>
 
-<file path=ppt/notesSlides/notesSlide39.xml><?xml version="1.0" encoding="utf-8"?>
+<file path=ppt/notesSlides/notesSlide38.xml><?xml version="1.0" encoding="utf-8"?>
 <p:notes xmlns:a="http://schemas.openxmlformats.org/drawingml/2006/main" xmlns:r="http://schemas.openxmlformats.org/officeDocument/2006/relationships" xmlns:p="http://schemas.openxmlformats.org/presentationml/2006/main">
   <p:cSld>
     <p:spTree>
@@ -4482,7 +4370,7 @@
           <a:p>
             <a:fld id="{80F36A49-A1DD-40F8-B8AD-E6F5365256CB}" type="slidenum">
               <a:rPr lang="pt-BR" smtClean="0"/>
-              <a:t>39</a:t>
+              <a:t>38</a:t>
             </a:fld>
             <a:endParaRPr lang="pt-BR"/>
           </a:p>
@@ -4492,6 +4380,118 @@
     <p:extLst>
       <p:ext uri="{BB962C8B-B14F-4D97-AF65-F5344CB8AC3E}">
         <p14:creationId xmlns:p14="http://schemas.microsoft.com/office/powerpoint/2010/main" val="4179539046"/>
+      </p:ext>
+    </p:extLst>
+  </p:cSld>
+  <p:clrMapOvr>
+    <a:masterClrMapping/>
+  </p:clrMapOvr>
+</p:notes>
+</file>
+
+<file path=ppt/notesSlides/notesSlide39.xml><?xml version="1.0" encoding="utf-8"?>
+<p:notes xmlns:a="http://schemas.openxmlformats.org/drawingml/2006/main" xmlns:r="http://schemas.openxmlformats.org/officeDocument/2006/relationships" xmlns:p="http://schemas.openxmlformats.org/presentationml/2006/main">
+  <p:cSld>
+    <p:spTree>
+      <p:nvGrpSpPr>
+        <p:cNvPr id="1" name="">
+          <a:extLst>
+            <a:ext uri="{FF2B5EF4-FFF2-40B4-BE49-F238E27FC236}">
+              <a16:creationId xmlns:a16="http://schemas.microsoft.com/office/drawing/2014/main" id="{1C426BE6-F997-1CA6-3303-6C5516021948}"/>
+            </a:ext>
+          </a:extLst>
+        </p:cNvPr>
+        <p:cNvGrpSpPr/>
+        <p:nvPr/>
+      </p:nvGrpSpPr>
+      <p:grpSpPr>
+        <a:xfrm>
+          <a:off x="0" y="0"/>
+          <a:ext cx="0" cy="0"/>
+          <a:chOff x="0" y="0"/>
+          <a:chExt cx="0" cy="0"/>
+        </a:xfrm>
+      </p:grpSpPr>
+      <p:sp>
+        <p:nvSpPr>
+          <p:cNvPr id="2" name="Espaço Reservado para Imagem de Slide 1">
+            <a:extLst>
+              <a:ext uri="{FF2B5EF4-FFF2-40B4-BE49-F238E27FC236}">
+                <a16:creationId xmlns:a16="http://schemas.microsoft.com/office/drawing/2014/main" id="{DA36A60B-2369-71F7-2B59-00B305607548}"/>
+              </a:ext>
+            </a:extLst>
+          </p:cNvPr>
+          <p:cNvSpPr>
+            <a:spLocks noGrp="1" noRot="1" noChangeAspect="1"/>
+          </p:cNvSpPr>
+          <p:nvPr>
+            <p:ph type="sldImg"/>
+          </p:nvPr>
+        </p:nvSpPr>
+        <p:spPr/>
+      </p:sp>
+      <p:sp>
+        <p:nvSpPr>
+          <p:cNvPr id="3" name="Espaço Reservado para Anotações 2">
+            <a:extLst>
+              <a:ext uri="{FF2B5EF4-FFF2-40B4-BE49-F238E27FC236}">
+                <a16:creationId xmlns:a16="http://schemas.microsoft.com/office/drawing/2014/main" id="{8AFCD7FD-0302-B9E7-E6C7-169D1D1458E9}"/>
+              </a:ext>
+            </a:extLst>
+          </p:cNvPr>
+          <p:cNvSpPr>
+            <a:spLocks noGrp="1"/>
+          </p:cNvSpPr>
+          <p:nvPr>
+            <p:ph type="body" idx="1"/>
+          </p:nvPr>
+        </p:nvSpPr>
+        <p:spPr/>
+        <p:txBody>
+          <a:bodyPr/>
+          <a:lstStyle/>
+          <a:p>
+            <a:pPr marL="0" indent="0">
+              <a:buFontTx/>
+              <a:buNone/>
+            </a:pPr>
+            <a:endParaRPr lang="pt-BR" b="0" dirty="0"/>
+          </a:p>
+        </p:txBody>
+      </p:sp>
+      <p:sp>
+        <p:nvSpPr>
+          <p:cNvPr id="4" name="Espaço Reservado para Número de Slide 3">
+            <a:extLst>
+              <a:ext uri="{FF2B5EF4-FFF2-40B4-BE49-F238E27FC236}">
+                <a16:creationId xmlns:a16="http://schemas.microsoft.com/office/drawing/2014/main" id="{31306875-CF96-FF47-32FF-0BDD0B2C40A6}"/>
+              </a:ext>
+            </a:extLst>
+          </p:cNvPr>
+          <p:cNvSpPr>
+            <a:spLocks noGrp="1"/>
+          </p:cNvSpPr>
+          <p:nvPr>
+            <p:ph type="sldNum" sz="quarter" idx="5"/>
+          </p:nvPr>
+        </p:nvSpPr>
+        <p:spPr/>
+        <p:txBody>
+          <a:bodyPr/>
+          <a:lstStyle/>
+          <a:p>
+            <a:fld id="{80F36A49-A1DD-40F8-B8AD-E6F5365256CB}" type="slidenum">
+              <a:rPr lang="pt-BR" smtClean="0"/>
+              <a:t>39</a:t>
+            </a:fld>
+            <a:endParaRPr lang="pt-BR"/>
+          </a:p>
+        </p:txBody>
+      </p:sp>
+    </p:spTree>
+    <p:extLst>
+      <p:ext uri="{BB962C8B-B14F-4D97-AF65-F5344CB8AC3E}">
+        <p14:creationId xmlns:p14="http://schemas.microsoft.com/office/powerpoint/2010/main" val="3977978615"/>
       </p:ext>
     </p:extLst>
   </p:cSld>
@@ -4617,118 +4617,6 @@
         <p:cNvPr id="1" name="">
           <a:extLst>
             <a:ext uri="{FF2B5EF4-FFF2-40B4-BE49-F238E27FC236}">
-              <a16:creationId xmlns:a16="http://schemas.microsoft.com/office/drawing/2014/main" id="{1C426BE6-F997-1CA6-3303-6C5516021948}"/>
-            </a:ext>
-          </a:extLst>
-        </p:cNvPr>
-        <p:cNvGrpSpPr/>
-        <p:nvPr/>
-      </p:nvGrpSpPr>
-      <p:grpSpPr>
-        <a:xfrm>
-          <a:off x="0" y="0"/>
-          <a:ext cx="0" cy="0"/>
-          <a:chOff x="0" y="0"/>
-          <a:chExt cx="0" cy="0"/>
-        </a:xfrm>
-      </p:grpSpPr>
-      <p:sp>
-        <p:nvSpPr>
-          <p:cNvPr id="2" name="Espaço Reservado para Imagem de Slide 1">
-            <a:extLst>
-              <a:ext uri="{FF2B5EF4-FFF2-40B4-BE49-F238E27FC236}">
-                <a16:creationId xmlns:a16="http://schemas.microsoft.com/office/drawing/2014/main" id="{DA36A60B-2369-71F7-2B59-00B305607548}"/>
-              </a:ext>
-            </a:extLst>
-          </p:cNvPr>
-          <p:cNvSpPr>
-            <a:spLocks noGrp="1" noRot="1" noChangeAspect="1"/>
-          </p:cNvSpPr>
-          <p:nvPr>
-            <p:ph type="sldImg"/>
-          </p:nvPr>
-        </p:nvSpPr>
-        <p:spPr/>
-      </p:sp>
-      <p:sp>
-        <p:nvSpPr>
-          <p:cNvPr id="3" name="Espaço Reservado para Anotações 2">
-            <a:extLst>
-              <a:ext uri="{FF2B5EF4-FFF2-40B4-BE49-F238E27FC236}">
-                <a16:creationId xmlns:a16="http://schemas.microsoft.com/office/drawing/2014/main" id="{8AFCD7FD-0302-B9E7-E6C7-169D1D1458E9}"/>
-              </a:ext>
-            </a:extLst>
-          </p:cNvPr>
-          <p:cNvSpPr>
-            <a:spLocks noGrp="1"/>
-          </p:cNvSpPr>
-          <p:nvPr>
-            <p:ph type="body" idx="1"/>
-          </p:nvPr>
-        </p:nvSpPr>
-        <p:spPr/>
-        <p:txBody>
-          <a:bodyPr/>
-          <a:lstStyle/>
-          <a:p>
-            <a:pPr marL="0" indent="0">
-              <a:buFontTx/>
-              <a:buNone/>
-            </a:pPr>
-            <a:endParaRPr lang="pt-BR" b="0" dirty="0"/>
-          </a:p>
-        </p:txBody>
-      </p:sp>
-      <p:sp>
-        <p:nvSpPr>
-          <p:cNvPr id="4" name="Espaço Reservado para Número de Slide 3">
-            <a:extLst>
-              <a:ext uri="{FF2B5EF4-FFF2-40B4-BE49-F238E27FC236}">
-                <a16:creationId xmlns:a16="http://schemas.microsoft.com/office/drawing/2014/main" id="{31306875-CF96-FF47-32FF-0BDD0B2C40A6}"/>
-              </a:ext>
-            </a:extLst>
-          </p:cNvPr>
-          <p:cNvSpPr>
-            <a:spLocks noGrp="1"/>
-          </p:cNvSpPr>
-          <p:nvPr>
-            <p:ph type="sldNum" sz="quarter" idx="5"/>
-          </p:nvPr>
-        </p:nvSpPr>
-        <p:spPr/>
-        <p:txBody>
-          <a:bodyPr/>
-          <a:lstStyle/>
-          <a:p>
-            <a:fld id="{80F36A49-A1DD-40F8-B8AD-E6F5365256CB}" type="slidenum">
-              <a:rPr lang="pt-BR" smtClean="0"/>
-              <a:t>40</a:t>
-            </a:fld>
-            <a:endParaRPr lang="pt-BR"/>
-          </a:p>
-        </p:txBody>
-      </p:sp>
-    </p:spTree>
-    <p:extLst>
-      <p:ext uri="{BB962C8B-B14F-4D97-AF65-F5344CB8AC3E}">
-        <p14:creationId xmlns:p14="http://schemas.microsoft.com/office/powerpoint/2010/main" val="3977978615"/>
-      </p:ext>
-    </p:extLst>
-  </p:cSld>
-  <p:clrMapOvr>
-    <a:masterClrMapping/>
-  </p:clrMapOvr>
-</p:notes>
-</file>
-
-<file path=ppt/notesSlides/notesSlide41.xml><?xml version="1.0" encoding="utf-8"?>
-<p:notes xmlns:a="http://schemas.openxmlformats.org/drawingml/2006/main" xmlns:r="http://schemas.openxmlformats.org/officeDocument/2006/relationships" xmlns:p="http://schemas.openxmlformats.org/presentationml/2006/main">
-  <p:cSld>
-    <p:spTree>
-      <p:nvGrpSpPr>
-        <p:cNvPr id="1" name="">
-          <a:extLst>
-            <a:ext uri="{FF2B5EF4-FFF2-40B4-BE49-F238E27FC236}">
               <a16:creationId xmlns:a16="http://schemas.microsoft.com/office/drawing/2014/main" id="{E2D447BD-775A-0524-8020-12254EF082A0}"/>
             </a:ext>
           </a:extLst>
@@ -4814,7 +4702,7 @@
           <a:p>
             <a:fld id="{80F36A49-A1DD-40F8-B8AD-E6F5365256CB}" type="slidenum">
               <a:rPr lang="pt-BR" smtClean="0"/>
-              <a:t>41</a:t>
+              <a:t>40</a:t>
             </a:fld>
             <a:endParaRPr lang="pt-BR"/>
           </a:p>
@@ -4833,7 +4721,7 @@
 </p:notes>
 </file>
 
-<file path=ppt/notesSlides/notesSlide42.xml><?xml version="1.0" encoding="utf-8"?>
+<file path=ppt/notesSlides/notesSlide41.xml><?xml version="1.0" encoding="utf-8"?>
 <p:notes xmlns:a="http://schemas.openxmlformats.org/drawingml/2006/main" xmlns:r="http://schemas.openxmlformats.org/officeDocument/2006/relationships" xmlns:p="http://schemas.openxmlformats.org/presentationml/2006/main">
   <p:cSld>
     <p:spTree>
@@ -4926,7 +4814,7 @@
           <a:p>
             <a:fld id="{80F36A49-A1DD-40F8-B8AD-E6F5365256CB}" type="slidenum">
               <a:rPr lang="pt-BR" smtClean="0"/>
-              <a:t>42</a:t>
+              <a:t>41</a:t>
             </a:fld>
             <a:endParaRPr lang="pt-BR"/>
           </a:p>
@@ -4945,7 +4833,7 @@
 </p:notes>
 </file>
 
-<file path=ppt/notesSlides/notesSlide43.xml><?xml version="1.0" encoding="utf-8"?>
+<file path=ppt/notesSlides/notesSlide42.xml><?xml version="1.0" encoding="utf-8"?>
 <p:notes xmlns:a="http://schemas.openxmlformats.org/drawingml/2006/main" xmlns:r="http://schemas.openxmlformats.org/officeDocument/2006/relationships" xmlns:p="http://schemas.openxmlformats.org/presentationml/2006/main">
   <p:cSld>
     <p:spTree>
@@ -5038,7 +4926,7 @@
           <a:p>
             <a:fld id="{80F36A49-A1DD-40F8-B8AD-E6F5365256CB}" type="slidenum">
               <a:rPr lang="pt-BR" smtClean="0"/>
-              <a:t>43</a:t>
+              <a:t>42</a:t>
             </a:fld>
             <a:endParaRPr lang="pt-BR"/>
           </a:p>
@@ -5057,7 +4945,7 @@
 </p:notes>
 </file>
 
-<file path=ppt/notesSlides/notesSlide44.xml><?xml version="1.0" encoding="utf-8"?>
+<file path=ppt/notesSlides/notesSlide43.xml><?xml version="1.0" encoding="utf-8"?>
 <p:notes xmlns:a="http://schemas.openxmlformats.org/drawingml/2006/main" xmlns:r="http://schemas.openxmlformats.org/officeDocument/2006/relationships" xmlns:p="http://schemas.openxmlformats.org/presentationml/2006/main">
   <p:cSld>
     <p:spTree>
@@ -5150,7 +5038,7 @@
           <a:p>
             <a:fld id="{80F36A49-A1DD-40F8-B8AD-E6F5365256CB}" type="slidenum">
               <a:rPr lang="pt-BR" smtClean="0"/>
-              <a:t>44</a:t>
+              <a:t>43</a:t>
             </a:fld>
             <a:endParaRPr lang="pt-BR"/>
           </a:p>
@@ -5169,7 +5057,7 @@
 </p:notes>
 </file>
 
-<file path=ppt/notesSlides/notesSlide45.xml><?xml version="1.0" encoding="utf-8"?>
+<file path=ppt/notesSlides/notesSlide44.xml><?xml version="1.0" encoding="utf-8"?>
 <p:notes xmlns:a="http://schemas.openxmlformats.org/drawingml/2006/main" xmlns:r="http://schemas.openxmlformats.org/officeDocument/2006/relationships" xmlns:p="http://schemas.openxmlformats.org/presentationml/2006/main">
   <p:cSld>
     <p:spTree>
@@ -5262,7 +5150,7 @@
           <a:p>
             <a:fld id="{80F36A49-A1DD-40F8-B8AD-E6F5365256CB}" type="slidenum">
               <a:rPr lang="pt-BR" smtClean="0"/>
-              <a:t>45</a:t>
+              <a:t>44</a:t>
             </a:fld>
             <a:endParaRPr lang="pt-BR"/>
           </a:p>
@@ -5272,6 +5160,118 @@
     <p:extLst>
       <p:ext uri="{BB962C8B-B14F-4D97-AF65-F5344CB8AC3E}">
         <p14:creationId xmlns:p14="http://schemas.microsoft.com/office/powerpoint/2010/main" val="2174368228"/>
+      </p:ext>
+    </p:extLst>
+  </p:cSld>
+  <p:clrMapOvr>
+    <a:masterClrMapping/>
+  </p:clrMapOvr>
+</p:notes>
+</file>
+
+<file path=ppt/notesSlides/notesSlide45.xml><?xml version="1.0" encoding="utf-8"?>
+<p:notes xmlns:a="http://schemas.openxmlformats.org/drawingml/2006/main" xmlns:r="http://schemas.openxmlformats.org/officeDocument/2006/relationships" xmlns:p="http://schemas.openxmlformats.org/presentationml/2006/main">
+  <p:cSld>
+    <p:spTree>
+      <p:nvGrpSpPr>
+        <p:cNvPr id="1" name="">
+          <a:extLst>
+            <a:ext uri="{FF2B5EF4-FFF2-40B4-BE49-F238E27FC236}">
+              <a16:creationId xmlns:a16="http://schemas.microsoft.com/office/drawing/2014/main" id="{3447ACEF-7662-3572-6FF3-5FDA5CC7A5A0}"/>
+            </a:ext>
+          </a:extLst>
+        </p:cNvPr>
+        <p:cNvGrpSpPr/>
+        <p:nvPr/>
+      </p:nvGrpSpPr>
+      <p:grpSpPr>
+        <a:xfrm>
+          <a:off x="0" y="0"/>
+          <a:ext cx="0" cy="0"/>
+          <a:chOff x="0" y="0"/>
+          <a:chExt cx="0" cy="0"/>
+        </a:xfrm>
+      </p:grpSpPr>
+      <p:sp>
+        <p:nvSpPr>
+          <p:cNvPr id="2" name="Espaço Reservado para Imagem de Slide 1">
+            <a:extLst>
+              <a:ext uri="{FF2B5EF4-FFF2-40B4-BE49-F238E27FC236}">
+                <a16:creationId xmlns:a16="http://schemas.microsoft.com/office/drawing/2014/main" id="{861DCEF8-047A-86CB-ACE6-7166B440A9FF}"/>
+              </a:ext>
+            </a:extLst>
+          </p:cNvPr>
+          <p:cNvSpPr>
+            <a:spLocks noGrp="1" noRot="1" noChangeAspect="1"/>
+          </p:cNvSpPr>
+          <p:nvPr>
+            <p:ph type="sldImg"/>
+          </p:nvPr>
+        </p:nvSpPr>
+        <p:spPr/>
+      </p:sp>
+      <p:sp>
+        <p:nvSpPr>
+          <p:cNvPr id="3" name="Espaço Reservado para Anotações 2">
+            <a:extLst>
+              <a:ext uri="{FF2B5EF4-FFF2-40B4-BE49-F238E27FC236}">
+                <a16:creationId xmlns:a16="http://schemas.microsoft.com/office/drawing/2014/main" id="{53684A89-F8F8-C3ED-5A48-75E6297CE0B6}"/>
+              </a:ext>
+            </a:extLst>
+          </p:cNvPr>
+          <p:cNvSpPr>
+            <a:spLocks noGrp="1"/>
+          </p:cNvSpPr>
+          <p:nvPr>
+            <p:ph type="body" idx="1"/>
+          </p:nvPr>
+        </p:nvSpPr>
+        <p:spPr/>
+        <p:txBody>
+          <a:bodyPr/>
+          <a:lstStyle/>
+          <a:p>
+            <a:pPr marL="0" indent="0">
+              <a:buFontTx/>
+              <a:buNone/>
+            </a:pPr>
+            <a:endParaRPr lang="pt-BR" b="0" dirty="0"/>
+          </a:p>
+        </p:txBody>
+      </p:sp>
+      <p:sp>
+        <p:nvSpPr>
+          <p:cNvPr id="4" name="Espaço Reservado para Número de Slide 3">
+            <a:extLst>
+              <a:ext uri="{FF2B5EF4-FFF2-40B4-BE49-F238E27FC236}">
+                <a16:creationId xmlns:a16="http://schemas.microsoft.com/office/drawing/2014/main" id="{4FDFBD8B-1D78-FE31-4731-495437C61892}"/>
+              </a:ext>
+            </a:extLst>
+          </p:cNvPr>
+          <p:cNvSpPr>
+            <a:spLocks noGrp="1"/>
+          </p:cNvSpPr>
+          <p:nvPr>
+            <p:ph type="sldNum" sz="quarter" idx="5"/>
+          </p:nvPr>
+        </p:nvSpPr>
+        <p:spPr/>
+        <p:txBody>
+          <a:bodyPr/>
+          <a:lstStyle/>
+          <a:p>
+            <a:fld id="{80F36A49-A1DD-40F8-B8AD-E6F5365256CB}" type="slidenum">
+              <a:rPr lang="pt-BR" smtClean="0"/>
+              <a:t>45</a:t>
+            </a:fld>
+            <a:endParaRPr lang="pt-BR"/>
+          </a:p>
+        </p:txBody>
+      </p:sp>
+    </p:spTree>
+    <p:extLst>
+      <p:ext uri="{BB962C8B-B14F-4D97-AF65-F5344CB8AC3E}">
+        <p14:creationId xmlns:p14="http://schemas.microsoft.com/office/powerpoint/2010/main" val="1051098388"/>
       </p:ext>
     </p:extLst>
   </p:cSld>
@@ -5289,7 +5289,7 @@
         <p:cNvPr id="1" name="">
           <a:extLst>
             <a:ext uri="{FF2B5EF4-FFF2-40B4-BE49-F238E27FC236}">
-              <a16:creationId xmlns:a16="http://schemas.microsoft.com/office/drawing/2014/main" id="{DF1EA0EC-1AE0-7B8D-CA9F-BE1A631FDB15}"/>
+              <a16:creationId xmlns:a16="http://schemas.microsoft.com/office/drawing/2014/main" id="{45B0221E-6368-1C7D-9593-484248ACF94E}"/>
             </a:ext>
           </a:extLst>
         </p:cNvPr>
@@ -5309,7 +5309,7 @@
           <p:cNvPr id="2" name="Espaço Reservado para Imagem de Slide 1">
             <a:extLst>
               <a:ext uri="{FF2B5EF4-FFF2-40B4-BE49-F238E27FC236}">
-                <a16:creationId xmlns:a16="http://schemas.microsoft.com/office/drawing/2014/main" id="{25D3AEBD-196D-8C33-6AA6-9A70342D1148}"/>
+                <a16:creationId xmlns:a16="http://schemas.microsoft.com/office/drawing/2014/main" id="{CD60B933-EE74-A667-09B1-66F8CCC1F8E6}"/>
               </a:ext>
             </a:extLst>
           </p:cNvPr>
@@ -5327,7 +5327,7 @@
           <p:cNvPr id="3" name="Espaço Reservado para Anotações 2">
             <a:extLst>
               <a:ext uri="{FF2B5EF4-FFF2-40B4-BE49-F238E27FC236}">
-                <a16:creationId xmlns:a16="http://schemas.microsoft.com/office/drawing/2014/main" id="{B0676F3F-2008-541F-A711-45583A0DBC84}"/>
+                <a16:creationId xmlns:a16="http://schemas.microsoft.com/office/drawing/2014/main" id="{C7F52DF8-BCEA-CDA9-5237-324EF1EE40C7}"/>
               </a:ext>
             </a:extLst>
           </p:cNvPr>
@@ -5356,7 +5356,7 @@
           <p:cNvPr id="4" name="Espaço Reservado para Número de Slide 3">
             <a:extLst>
               <a:ext uri="{FF2B5EF4-FFF2-40B4-BE49-F238E27FC236}">
-                <a16:creationId xmlns:a16="http://schemas.microsoft.com/office/drawing/2014/main" id="{F708A587-FF16-C95E-D376-CB2103DF0933}"/>
+                <a16:creationId xmlns:a16="http://schemas.microsoft.com/office/drawing/2014/main" id="{4A54C782-31C4-95EE-3CD4-D14A40A1035C}"/>
               </a:ext>
             </a:extLst>
           </p:cNvPr>
@@ -5383,7 +5383,7 @@
     </p:spTree>
     <p:extLst>
       <p:ext uri="{BB962C8B-B14F-4D97-AF65-F5344CB8AC3E}">
-        <p14:creationId xmlns:p14="http://schemas.microsoft.com/office/powerpoint/2010/main" val="1855636676"/>
+        <p14:creationId xmlns:p14="http://schemas.microsoft.com/office/powerpoint/2010/main" val="1969739803"/>
       </p:ext>
     </p:extLst>
   </p:cSld>
@@ -6173,7 +6173,7 @@
           <a:p>
             <a:fld id="{A87E3B6E-8316-4A1C-BADA-DB7F3456EEF1}" type="datetimeFigureOut">
               <a:rPr lang="pt-BR" smtClean="0"/>
-              <a:t>08/08/2026</a:t>
+              <a:t>09/08/2026</a:t>
             </a:fld>
             <a:endParaRPr lang="pt-BR"/>
           </a:p>
@@ -6371,7 +6371,7 @@
           <a:p>
             <a:fld id="{A87E3B6E-8316-4A1C-BADA-DB7F3456EEF1}" type="datetimeFigureOut">
               <a:rPr lang="pt-BR" smtClean="0"/>
-              <a:t>08/08/2026</a:t>
+              <a:t>09/08/2026</a:t>
             </a:fld>
             <a:endParaRPr lang="pt-BR"/>
           </a:p>
@@ -6579,7 +6579,7 @@
           <a:p>
             <a:fld id="{A87E3B6E-8316-4A1C-BADA-DB7F3456EEF1}" type="datetimeFigureOut">
               <a:rPr lang="pt-BR" smtClean="0"/>
-              <a:t>08/08/2026</a:t>
+              <a:t>09/08/2026</a:t>
             </a:fld>
             <a:endParaRPr lang="pt-BR"/>
           </a:p>
@@ -6815,7 +6815,7 @@
           <a:p>
             <a:fld id="{A87E3B6E-8316-4A1C-BADA-DB7F3456EEF1}" type="datetimeFigureOut">
               <a:rPr lang="pt-BR" smtClean="0"/>
-              <a:t>08/08/2026</a:t>
+              <a:t>09/08/2026</a:t>
             </a:fld>
             <a:endParaRPr lang="pt-BR"/>
           </a:p>
@@ -6985,7 +6985,7 @@
           <a:p>
             <a:fld id="{A87E3B6E-8316-4A1C-BADA-DB7F3456EEF1}" type="datetimeFigureOut">
               <a:rPr lang="pt-BR" smtClean="0"/>
-              <a:t>08/08/2026</a:t>
+              <a:t>09/08/2026</a:t>
             </a:fld>
             <a:endParaRPr lang="pt-BR"/>
           </a:p>
@@ -7253,7 +7253,7 @@
           <a:p>
             <a:fld id="{A87E3B6E-8316-4A1C-BADA-DB7F3456EEF1}" type="datetimeFigureOut">
               <a:rPr lang="pt-BR" smtClean="0"/>
-              <a:t>08/08/2026</a:t>
+              <a:t>09/08/2026</a:t>
             </a:fld>
             <a:endParaRPr lang="pt-BR"/>
           </a:p>
@@ -7485,7 +7485,7 @@
           <a:p>
             <a:fld id="{A87E3B6E-8316-4A1C-BADA-DB7F3456EEF1}" type="datetimeFigureOut">
               <a:rPr lang="pt-BR" smtClean="0"/>
-              <a:t>08/08/2026</a:t>
+              <a:t>09/08/2026</a:t>
             </a:fld>
             <a:endParaRPr lang="pt-BR"/>
           </a:p>
@@ -7840,7 +7840,7 @@
           <a:p>
             <a:fld id="{A87E3B6E-8316-4A1C-BADA-DB7F3456EEF1}" type="datetimeFigureOut">
               <a:rPr lang="pt-BR" smtClean="0"/>
-              <a:t>08/08/2026</a:t>
+              <a:t>09/08/2026</a:t>
             </a:fld>
             <a:endParaRPr lang="pt-BR"/>
           </a:p>
@@ -7981,7 +7981,7 @@
           <a:p>
             <a:fld id="{A87E3B6E-8316-4A1C-BADA-DB7F3456EEF1}" type="datetimeFigureOut">
               <a:rPr lang="pt-BR" smtClean="0"/>
-              <a:t>08/08/2026</a:t>
+              <a:t>09/08/2026</a:t>
             </a:fld>
             <a:endParaRPr lang="pt-BR"/>
           </a:p>
@@ -8076,7 +8076,7 @@
           <a:p>
             <a:fld id="{A87E3B6E-8316-4A1C-BADA-DB7F3456EEF1}" type="datetimeFigureOut">
               <a:rPr lang="pt-BR" smtClean="0"/>
-              <a:t>08/08/2026</a:t>
+              <a:t>09/08/2026</a:t>
             </a:fld>
             <a:endParaRPr lang="pt-BR"/>
           </a:p>
@@ -8433,7 +8433,7 @@
           <a:p>
             <a:fld id="{A87E3B6E-8316-4A1C-BADA-DB7F3456EEF1}" type="datetimeFigureOut">
               <a:rPr lang="pt-BR" smtClean="0"/>
-              <a:t>08/08/2026</a:t>
+              <a:t>09/08/2026</a:t>
             </a:fld>
             <a:endParaRPr lang="pt-BR"/>
           </a:p>
@@ -8634,7 +8634,7 @@
           <a:p>
             <a:fld id="{A87E3B6E-8316-4A1C-BADA-DB7F3456EEF1}" type="datetimeFigureOut">
               <a:rPr lang="pt-BR" smtClean="0"/>
-              <a:t>08/08/2026</a:t>
+              <a:t>09/08/2026</a:t>
             </a:fld>
             <a:endParaRPr lang="pt-BR"/>
           </a:p>
@@ -8987,7 +8987,7 @@
           <a:p>
             <a:fld id="{A87E3B6E-8316-4A1C-BADA-DB7F3456EEF1}" type="datetimeFigureOut">
               <a:rPr lang="pt-BR" smtClean="0"/>
-              <a:t>08/08/2026</a:t>
+              <a:t>09/08/2026</a:t>
             </a:fld>
             <a:endParaRPr lang="pt-BR"/>
           </a:p>
@@ -9172,7 +9172,7 @@
           <a:p>
             <a:fld id="{A87E3B6E-8316-4A1C-BADA-DB7F3456EEF1}" type="datetimeFigureOut">
               <a:rPr lang="pt-BR" smtClean="0"/>
-              <a:t>08/08/2026</a:t>
+              <a:t>09/08/2026</a:t>
             </a:fld>
             <a:endParaRPr lang="pt-BR"/>
           </a:p>
@@ -9352,7 +9352,7 @@
           <a:p>
             <a:fld id="{A87E3B6E-8316-4A1C-BADA-DB7F3456EEF1}" type="datetimeFigureOut">
               <a:rPr lang="pt-BR" smtClean="0"/>
-              <a:t>08/08/2026</a:t>
+              <a:t>09/08/2026</a:t>
             </a:fld>
             <a:endParaRPr lang="pt-BR"/>
           </a:p>
@@ -9615,7 +9615,7 @@
           <a:p>
             <a:fld id="{A87E3B6E-8316-4A1C-BADA-DB7F3456EEF1}" type="datetimeFigureOut">
               <a:rPr lang="pt-BR" smtClean="0"/>
-              <a:t>08/08/2026</a:t>
+              <a:t>09/08/2026</a:t>
             </a:fld>
             <a:endParaRPr lang="pt-BR"/>
           </a:p>
@@ -9880,7 +9880,7 @@
           <a:p>
             <a:fld id="{A87E3B6E-8316-4A1C-BADA-DB7F3456EEF1}" type="datetimeFigureOut">
               <a:rPr lang="pt-BR" smtClean="0"/>
-              <a:t>08/08/2026</a:t>
+              <a:t>09/08/2026</a:t>
             </a:fld>
             <a:endParaRPr lang="pt-BR"/>
           </a:p>
@@ -10292,7 +10292,7 @@
           <a:p>
             <a:fld id="{A87E3B6E-8316-4A1C-BADA-DB7F3456EEF1}" type="datetimeFigureOut">
               <a:rPr lang="pt-BR" smtClean="0"/>
-              <a:t>08/08/2026</a:t>
+              <a:t>09/08/2026</a:t>
             </a:fld>
             <a:endParaRPr lang="pt-BR"/>
           </a:p>
@@ -10433,7 +10433,7 @@
           <a:p>
             <a:fld id="{A87E3B6E-8316-4A1C-BADA-DB7F3456EEF1}" type="datetimeFigureOut">
               <a:rPr lang="pt-BR" smtClean="0"/>
-              <a:t>08/08/2026</a:t>
+              <a:t>09/08/2026</a:t>
             </a:fld>
             <a:endParaRPr lang="pt-BR"/>
           </a:p>
@@ -10546,7 +10546,7 @@
           <a:p>
             <a:fld id="{A87E3B6E-8316-4A1C-BADA-DB7F3456EEF1}" type="datetimeFigureOut">
               <a:rPr lang="pt-BR" smtClean="0"/>
-              <a:t>08/08/2026</a:t>
+              <a:t>09/08/2026</a:t>
             </a:fld>
             <a:endParaRPr lang="pt-BR"/>
           </a:p>
@@ -10857,7 +10857,7 @@
           <a:p>
             <a:fld id="{A87E3B6E-8316-4A1C-BADA-DB7F3456EEF1}" type="datetimeFigureOut">
               <a:rPr lang="pt-BR" smtClean="0"/>
-              <a:t>08/08/2026</a:t>
+              <a:t>09/08/2026</a:t>
             </a:fld>
             <a:endParaRPr lang="pt-BR"/>
           </a:p>
@@ -11145,7 +11145,7 @@
           <a:p>
             <a:fld id="{A87E3B6E-8316-4A1C-BADA-DB7F3456EEF1}" type="datetimeFigureOut">
               <a:rPr lang="pt-BR" smtClean="0"/>
-              <a:t>08/08/2026</a:t>
+              <a:t>09/08/2026</a:t>
             </a:fld>
             <a:endParaRPr lang="pt-BR"/>
           </a:p>
@@ -11386,7 +11386,7 @@
           <a:p>
             <a:fld id="{A87E3B6E-8316-4A1C-BADA-DB7F3456EEF1}" type="datetimeFigureOut">
               <a:rPr lang="pt-BR" smtClean="0"/>
-              <a:t>08/08/2026</a:t>
+              <a:t>09/08/2026</a:t>
             </a:fld>
             <a:endParaRPr lang="pt-BR"/>
           </a:p>
@@ -11950,7 +11950,7 @@
           <a:p>
             <a:fld id="{A87E3B6E-8316-4A1C-BADA-DB7F3456EEF1}" type="datetimeFigureOut">
               <a:rPr lang="pt-BR" smtClean="0"/>
-              <a:t>08/08/2026</a:t>
+              <a:t>09/08/2026</a:t>
             </a:fld>
             <a:endParaRPr lang="pt-BR"/>
           </a:p>
@@ -23430,215 +23430,6 @@
         <p:cNvPr id="1" name="">
           <a:extLst>
             <a:ext uri="{FF2B5EF4-FFF2-40B4-BE49-F238E27FC236}">
-              <a16:creationId xmlns:a16="http://schemas.microsoft.com/office/drawing/2014/main" id="{247ACADE-A840-3BE9-33C2-2379B4027FDA}"/>
-            </a:ext>
-          </a:extLst>
-        </p:cNvPr>
-        <p:cNvGrpSpPr/>
-        <p:nvPr/>
-      </p:nvGrpSpPr>
-      <p:grpSpPr>
-        <a:xfrm>
-          <a:off x="0" y="0"/>
-          <a:ext cx="0" cy="0"/>
-          <a:chOff x="0" y="0"/>
-          <a:chExt cx="0" cy="0"/>
-        </a:xfrm>
-      </p:grpSpPr>
-      <p:sp>
-        <p:nvSpPr>
-          <p:cNvPr id="5" name="Retângulo 4">
-            <a:extLst>
-              <a:ext uri="{FF2B5EF4-FFF2-40B4-BE49-F238E27FC236}">
-                <a16:creationId xmlns:a16="http://schemas.microsoft.com/office/drawing/2014/main" id="{5D6F4223-B114-1B64-C5A5-94547D50A986}"/>
-              </a:ext>
-            </a:extLst>
-          </p:cNvPr>
-          <p:cNvSpPr/>
-          <p:nvPr/>
-        </p:nvSpPr>
-        <p:spPr>
-          <a:xfrm>
-            <a:off x="0" y="-2"/>
-            <a:ext cx="12192000" cy="1325563"/>
-          </a:xfrm>
-          <a:prstGeom prst="rect">
-            <a:avLst/>
-          </a:prstGeom>
-          <a:solidFill>
-            <a:schemeClr val="accent2"/>
-          </a:solidFill>
-          <a:ln>
-            <a:solidFill>
-              <a:srgbClr val="418AB3"/>
-            </a:solidFill>
-          </a:ln>
-        </p:spPr>
-        <p:style>
-          <a:lnRef idx="2">
-            <a:schemeClr val="accent1">
-              <a:shade val="15000"/>
-            </a:schemeClr>
-          </a:lnRef>
-          <a:fillRef idx="1">
-            <a:schemeClr val="accent1"/>
-          </a:fillRef>
-          <a:effectRef idx="0">
-            <a:schemeClr val="accent1"/>
-          </a:effectRef>
-          <a:fontRef idx="minor">
-            <a:schemeClr val="lt1"/>
-          </a:fontRef>
-        </p:style>
-        <p:txBody>
-          <a:bodyPr rtlCol="0" anchor="ctr"/>
-          <a:lstStyle/>
-          <a:p>
-            <a:pPr algn="ctr"/>
-            <a:endParaRPr lang="pt-BR" dirty="0"/>
-          </a:p>
-        </p:txBody>
-      </p:sp>
-      <p:sp>
-        <p:nvSpPr>
-          <p:cNvPr id="2" name="Título 1">
-            <a:extLst>
-              <a:ext uri="{FF2B5EF4-FFF2-40B4-BE49-F238E27FC236}">
-                <a16:creationId xmlns:a16="http://schemas.microsoft.com/office/drawing/2014/main" id="{A8DB634D-98C2-7C53-CE8C-88718DA1DEDA}"/>
-              </a:ext>
-            </a:extLst>
-          </p:cNvPr>
-          <p:cNvSpPr>
-            <a:spLocks noGrp="1"/>
-          </p:cNvSpPr>
-          <p:nvPr>
-            <p:ph type="title"/>
-          </p:nvPr>
-        </p:nvSpPr>
-        <p:spPr>
-          <a:xfrm>
-            <a:off x="0" y="-1"/>
-            <a:ext cx="12192000" cy="1325563"/>
-          </a:xfrm>
-        </p:spPr>
-        <p:txBody>
-          <a:bodyPr/>
-          <a:lstStyle/>
-          <a:p>
-            <a:pPr algn="ctr"/>
-            <a:r>
-              <a:rPr lang="pt-BR" dirty="0">
-                <a:solidFill>
-                  <a:schemeClr val="bg1"/>
-                </a:solidFill>
-              </a:rPr>
-              <a:t>FIXAÇÃO - DESAFIO</a:t>
-            </a:r>
-          </a:p>
-        </p:txBody>
-      </p:sp>
-      <p:sp>
-        <p:nvSpPr>
-          <p:cNvPr id="6" name="Espaço Reservado para Conteúdo 5">
-            <a:extLst>
-              <a:ext uri="{FF2B5EF4-FFF2-40B4-BE49-F238E27FC236}">
-                <a16:creationId xmlns:a16="http://schemas.microsoft.com/office/drawing/2014/main" id="{D169E136-FFE4-8C03-85FE-9C8A6D6859BD}"/>
-              </a:ext>
-            </a:extLst>
-          </p:cNvPr>
-          <p:cNvSpPr>
-            <a:spLocks noGrp="1"/>
-          </p:cNvSpPr>
-          <p:nvPr>
-            <p:ph idx="1"/>
-          </p:nvPr>
-        </p:nvSpPr>
-        <p:spPr>
-          <a:xfrm>
-            <a:off x="1758950" y="1817914"/>
-            <a:ext cx="8888997" cy="4669971"/>
-          </a:xfrm>
-        </p:spPr>
-        <p:txBody>
-          <a:bodyPr>
-            <a:normAutofit/>
-          </a:bodyPr>
-          <a:lstStyle/>
-          <a:p>
-            <a:pPr marL="457200" indent="-457200" algn="just">
-              <a:buFont typeface="+mj-lt"/>
-              <a:buAutoNum type="arabicPeriod"/>
-            </a:pPr>
-            <a:r>
-              <a:rPr lang="pt-BR" sz="2400" dirty="0"/>
-              <a:t>Considerando que a logica proposicional trabalha essencialmente com conjunções, disjunções e negações. Como poderíamos representar a </a:t>
-            </a:r>
-            <a:r>
-              <a:rPr lang="pt-BR" sz="2400" b="1" dirty="0"/>
-              <a:t>condicional</a:t>
-            </a:r>
-            <a:r>
-              <a:rPr lang="pt-BR" sz="2400" dirty="0"/>
-              <a:t>, a </a:t>
-            </a:r>
-            <a:r>
-              <a:rPr lang="pt-BR" sz="2400" b="1" dirty="0" err="1"/>
-              <a:t>bi-condicional</a:t>
-            </a:r>
-            <a:r>
-              <a:rPr lang="pt-BR" sz="2400" dirty="0"/>
-              <a:t> e a </a:t>
-            </a:r>
-            <a:r>
-              <a:rPr lang="pt-BR" sz="2400" b="1" dirty="0"/>
-              <a:t>disjunção exclusiva</a:t>
-            </a:r>
-            <a:r>
-              <a:rPr lang="pt-BR" sz="2400" dirty="0"/>
-              <a:t>, dentro das formas normais? </a:t>
-            </a:r>
-          </a:p>
-          <a:p>
-            <a:pPr marL="457200" indent="-457200" algn="just">
-              <a:buFont typeface="+mj-lt"/>
-              <a:buAutoNum type="arabicPeriod"/>
-            </a:pPr>
-            <a:endParaRPr lang="pt-BR" sz="2400" dirty="0"/>
-          </a:p>
-          <a:p>
-            <a:pPr marL="457200" indent="-457200" algn="just">
-              <a:buFont typeface="+mj-lt"/>
-              <a:buAutoNum type="arabicPeriod"/>
-            </a:pPr>
-            <a:r>
-              <a:rPr lang="pt-BR" sz="2400" dirty="0"/>
-              <a:t>Como podemos garantir que o valor lógico seja o mesmo em ambas as formas normais conjuntivas e disjuntivas?</a:t>
-            </a:r>
-            <a:endParaRPr lang="pt-BR" sz="2000" dirty="0"/>
-          </a:p>
-        </p:txBody>
-      </p:sp>
-    </p:spTree>
-    <p:extLst>
-      <p:ext uri="{BB962C8B-B14F-4D97-AF65-F5344CB8AC3E}">
-        <p14:creationId xmlns:p14="http://schemas.microsoft.com/office/powerpoint/2010/main" val="3630648018"/>
-      </p:ext>
-    </p:extLst>
-  </p:cSld>
-  <p:clrMapOvr>
-    <a:masterClrMapping/>
-  </p:clrMapOvr>
-</p:sld>
-</file>
-
-<file path=ppt/slides/slide37.xml><?xml version="1.0" encoding="utf-8"?>
-<p:sld xmlns:a="http://schemas.openxmlformats.org/drawingml/2006/main" xmlns:r="http://schemas.openxmlformats.org/officeDocument/2006/relationships" xmlns:p="http://schemas.openxmlformats.org/presentationml/2006/main">
-  <p:cSld>
-    <p:spTree>
-      <p:nvGrpSpPr>
-        <p:cNvPr id="1" name="">
-          <a:extLst>
-            <a:ext uri="{FF2B5EF4-FFF2-40B4-BE49-F238E27FC236}">
               <a16:creationId xmlns:a16="http://schemas.microsoft.com/office/drawing/2014/main" id="{C0D1F0B2-845E-21C3-0F3D-D7EBCC078502}"/>
             </a:ext>
           </a:extLst>
@@ -23793,7 +23584,7 @@
 </p:sld>
 </file>
 
-<file path=ppt/slides/slide38.xml><?xml version="1.0" encoding="utf-8"?>
+<file path=ppt/slides/slide37.xml><?xml version="1.0" encoding="utf-8"?>
 <p:sld xmlns:a="http://schemas.openxmlformats.org/drawingml/2006/main" xmlns:r="http://schemas.openxmlformats.org/officeDocument/2006/relationships" xmlns:p="http://schemas.openxmlformats.org/presentationml/2006/main">
   <p:cSld>
     <p:spTree>
@@ -23988,15 +23779,7 @@
                 </a:pPr>
                 <a:r>
                   <a:rPr lang="pt-BR" sz="2200" dirty="0"/>
-                  <a:t>A partir daí, são </a:t>
-                </a:r>
-                <a:r>
-                  <a:rPr lang="pt-BR" sz="2200" dirty="0" err="1"/>
-                  <a:t>definadas</a:t>
-                </a:r>
-                <a:r>
-                  <a:rPr lang="pt-BR" sz="2200" dirty="0"/>
-                  <a:t> ferramentas para transformar e simplificar expressões sem alterar seu significado lógico.</a:t>
+                  <a:t>A partir daí, são definidas ferramentas para transformar e simplificar expressões sem alterar seu significado lógico.</a:t>
                 </a:r>
               </a:p>
               <a:p>
@@ -24181,7 +23964,7 @@
 </p:sld>
 </file>
 
-<file path=ppt/slides/slide39.xml><?xml version="1.0" encoding="utf-8"?>
+<file path=ppt/slides/slide38.xml><?xml version="1.0" encoding="utf-8"?>
 <p:sld xmlns:a="http://schemas.openxmlformats.org/drawingml/2006/main" xmlns:r="http://schemas.openxmlformats.org/officeDocument/2006/relationships" xmlns:p="http://schemas.openxmlformats.org/presentationml/2006/main">
   <p:cSld>
     <p:spTree>
@@ -24296,8 +24079,8 @@
           </a:p>
         </p:txBody>
       </p:sp>
-      <mc:AlternateContent xmlns:mc="http://schemas.openxmlformats.org/markup-compatibility/2006">
-        <mc:Choice xmlns:a14="http://schemas.microsoft.com/office/drawing/2010/main" Requires="a14">
+      <mc:AlternateContent xmlns:mc="http://schemas.openxmlformats.org/markup-compatibility/2006" xmlns:a14="http://schemas.microsoft.com/office/drawing/2010/main">
+        <mc:Choice Requires="a14">
           <p:sp>
             <p:nvSpPr>
               <p:cNvPr id="6" name="Espaço Reservado para Conteúdo 5">
@@ -24488,7 +24271,7 @@
                     <m:d>
                       <m:dPr>
                         <m:ctrlPr>
-                          <a:rPr lang="pt-BR" b="1" i="0" dirty="0" smtClean="0">
+                          <a:rPr lang="pt-BR" b="1" i="1" dirty="0" smtClean="0">
                             <a:latin typeface="Cambria Math" panose="02040503050406030204" pitchFamily="18" charset="0"/>
                           </a:rPr>
                         </m:ctrlPr>
@@ -24582,7 +24365,7 @@
             </p:txBody>
           </p:sp>
         </mc:Choice>
-        <mc:Fallback>
+        <mc:Fallback xmlns="">
           <p:sp>
             <p:nvSpPr>
               <p:cNvPr id="6" name="Espaço Reservado para Conteúdo 5">
@@ -24711,7 +24494,7 @@
 </p:sld>
 </file>
 
-<file path=ppt/slides/slide4.xml><?xml version="1.0" encoding="utf-8"?>
+<file path=ppt/slides/slide39.xml><?xml version="1.0" encoding="utf-8"?>
 <p:sld xmlns:a="http://schemas.openxmlformats.org/drawingml/2006/main" xmlns:r="http://schemas.openxmlformats.org/officeDocument/2006/relationships" xmlns:p="http://schemas.openxmlformats.org/presentationml/2006/main">
   <p:cSld>
     <p:spTree>
@@ -24719,7 +24502,7 @@
         <p:cNvPr id="1" name="">
           <a:extLst>
             <a:ext uri="{FF2B5EF4-FFF2-40B4-BE49-F238E27FC236}">
-              <a16:creationId xmlns:a16="http://schemas.microsoft.com/office/drawing/2014/main" id="{3E98EFC3-284D-D3E8-E50A-9E8782F149E5}"/>
+              <a16:creationId xmlns:a16="http://schemas.microsoft.com/office/drawing/2014/main" id="{6D1847F7-ABB7-B16F-C6D2-C1C625EB776C}"/>
             </a:ext>
           </a:extLst>
         </p:cNvPr>
@@ -24739,7 +24522,7 @@
           <p:cNvPr id="5" name="Retângulo 4">
             <a:extLst>
               <a:ext uri="{FF2B5EF4-FFF2-40B4-BE49-F238E27FC236}">
-                <a16:creationId xmlns:a16="http://schemas.microsoft.com/office/drawing/2014/main" id="{B1CC91A5-617B-F614-3886-EF59D2171B4E}"/>
+                <a16:creationId xmlns:a16="http://schemas.microsoft.com/office/drawing/2014/main" id="{8EF3F73D-222C-BBEA-C05E-4D4A8A45B37B}"/>
               </a:ext>
             </a:extLst>
           </p:cNvPr>
@@ -24793,7 +24576,7 @@
           <p:cNvPr id="2" name="Título 1">
             <a:extLst>
               <a:ext uri="{FF2B5EF4-FFF2-40B4-BE49-F238E27FC236}">
-                <a16:creationId xmlns:a16="http://schemas.microsoft.com/office/drawing/2014/main" id="{D778D71A-5EF8-AADA-8ACC-9C2D89EE5258}"/>
+                <a16:creationId xmlns:a16="http://schemas.microsoft.com/office/drawing/2014/main" id="{3D26EF6E-CABF-F4E9-1F51-A3402B73D54B}"/>
               </a:ext>
             </a:extLst>
           </p:cNvPr>
@@ -24821,294 +24604,13 @@
                   <a:schemeClr val="bg1"/>
                 </a:solidFill>
               </a:rPr>
-              <a:t>Bibliografia</a:t>
-            </a:r>
-          </a:p>
-        </p:txBody>
-      </p:sp>
-      <p:sp>
-        <p:nvSpPr>
-          <p:cNvPr id="12" name="AutoShape 6" descr="Lógica Proposicional x Lógica de Argumento ⋆ Colaborae">
-            <a:extLst>
-              <a:ext uri="{FF2B5EF4-FFF2-40B4-BE49-F238E27FC236}">
-                <a16:creationId xmlns:a16="http://schemas.microsoft.com/office/drawing/2014/main" id="{ED9276FC-2835-8FCA-9E06-6FEFA248BD66}"/>
-              </a:ext>
-            </a:extLst>
-          </p:cNvPr>
-          <p:cNvSpPr>
-            <a:spLocks noChangeAspect="1" noChangeArrowheads="1"/>
-          </p:cNvSpPr>
-          <p:nvPr/>
-        </p:nvSpPr>
-        <p:spPr bwMode="auto">
-          <a:xfrm>
-            <a:off x="5943600" y="-1707776"/>
-            <a:ext cx="5289176" cy="5289176"/>
-          </a:xfrm>
-          <a:prstGeom prst="rect">
-            <a:avLst/>
-          </a:prstGeom>
-          <a:noFill/>
-          <a:extLst>
-            <a:ext uri="{909E8E84-426E-40DD-AFC4-6F175D3DCCD1}">
-              <a14:hiddenFill xmlns:a14="http://schemas.microsoft.com/office/drawing/2010/main">
-                <a:solidFill>
-                  <a:srgbClr val="FFFFFF"/>
-                </a:solidFill>
-              </a14:hiddenFill>
-            </a:ext>
-          </a:extLst>
-        </p:spPr>
-        <p:txBody>
-          <a:bodyPr vert="horz" wrap="square" lIns="91440" tIns="45720" rIns="91440" bIns="45720" numCol="1" anchor="t" anchorCtr="0" compatLnSpc="1">
-            <a:prstTxWarp prst="textNoShape">
-              <a:avLst/>
-            </a:prstTxWarp>
-          </a:bodyPr>
-          <a:lstStyle/>
-          <a:p>
-            <a:endParaRPr lang="pt-BR"/>
-          </a:p>
-        </p:txBody>
-      </p:sp>
-      <p:sp>
-        <p:nvSpPr>
-          <p:cNvPr id="6" name="Espaço Reservado para Conteúdo 5">
-            <a:extLst>
-              <a:ext uri="{FF2B5EF4-FFF2-40B4-BE49-F238E27FC236}">
-                <a16:creationId xmlns:a16="http://schemas.microsoft.com/office/drawing/2014/main" id="{E0EE607F-D9F4-7951-D428-ABA18E81EE79}"/>
-              </a:ext>
-            </a:extLst>
-          </p:cNvPr>
-          <p:cNvSpPr>
-            <a:spLocks noGrp="1"/>
-          </p:cNvSpPr>
-          <p:nvPr>
-            <p:ph idx="1"/>
-          </p:nvPr>
-        </p:nvSpPr>
-        <p:spPr>
-          <a:xfrm>
-            <a:off x="1486540" y="1804575"/>
-            <a:ext cx="9297574" cy="4746632"/>
-          </a:xfrm>
-        </p:spPr>
-        <p:txBody>
-          <a:bodyPr/>
-          <a:lstStyle/>
-          <a:p>
-            <a:r>
-              <a:rPr lang="pt-BR" sz="2400" b="1" dirty="0"/>
-              <a:t>Básica</a:t>
-            </a:r>
-          </a:p>
-          <a:p>
-            <a:pPr lvl="1"/>
-            <a:endParaRPr lang="pt-BR" sz="2200" dirty="0"/>
-          </a:p>
-          <a:p>
-            <a:pPr lvl="1"/>
-            <a:r>
-              <a:rPr lang="pt-BR" sz="2200" dirty="0"/>
-              <a:t>Matemática Discreta para Computação e Informática – PAULO MENEZES</a:t>
-            </a:r>
-          </a:p>
-          <a:p>
-            <a:pPr lvl="1"/>
-            <a:r>
-              <a:rPr lang="pt-BR" sz="2200" dirty="0"/>
-              <a:t>Matemática Discreta – THAMARA PETROLI</a:t>
-            </a:r>
-          </a:p>
-          <a:p>
-            <a:pPr lvl="1"/>
-            <a:r>
-              <a:rPr lang="pt-BR" sz="2200" dirty="0"/>
-              <a:t>Matemática discreta para ciência da computação – CLIFFORD STEIN</a:t>
-            </a:r>
-          </a:p>
-          <a:p>
-            <a:pPr lvl="1"/>
-            <a:endParaRPr lang="pt-BR" sz="2400" dirty="0"/>
-          </a:p>
-          <a:p>
-            <a:r>
-              <a:rPr lang="pt-BR" sz="2400" b="1" dirty="0"/>
-              <a:t>Complementar</a:t>
-            </a:r>
-          </a:p>
-          <a:p>
-            <a:pPr lvl="1"/>
-            <a:endParaRPr lang="pt-BR" sz="2000" dirty="0"/>
-          </a:p>
-          <a:p>
-            <a:pPr lvl="1"/>
-            <a:r>
-              <a:rPr lang="pt-BR" sz="2200" dirty="0" err="1"/>
-              <a:t>Discrete</a:t>
-            </a:r>
-            <a:r>
-              <a:rPr lang="pt-BR" sz="2200" dirty="0"/>
-              <a:t> </a:t>
-            </a:r>
-            <a:r>
-              <a:rPr lang="pt-BR" sz="2200" dirty="0" err="1"/>
-              <a:t>Mathematics</a:t>
-            </a:r>
-            <a:r>
-              <a:rPr lang="pt-BR" sz="2200" dirty="0"/>
-              <a:t> </a:t>
-            </a:r>
-            <a:r>
-              <a:rPr lang="pt-BR" sz="2200" dirty="0" err="1"/>
-              <a:t>Applications</a:t>
-            </a:r>
-            <a:r>
-              <a:rPr lang="pt-BR" sz="2200" dirty="0"/>
-              <a:t> – KENNETH ROSEN </a:t>
-            </a:r>
-          </a:p>
-          <a:p>
-            <a:endParaRPr lang="pt-BR" sz="2400" dirty="0"/>
-          </a:p>
-          <a:p>
-            <a:endParaRPr lang="pt-BR" sz="2400" dirty="0"/>
-          </a:p>
-          <a:p>
-            <a:endParaRPr lang="pt-BR" dirty="0"/>
-          </a:p>
-        </p:txBody>
-      </p:sp>
-    </p:spTree>
-    <p:extLst>
-      <p:ext uri="{BB962C8B-B14F-4D97-AF65-F5344CB8AC3E}">
-        <p14:creationId xmlns:p14="http://schemas.microsoft.com/office/powerpoint/2010/main" val="1994978664"/>
-      </p:ext>
-    </p:extLst>
-  </p:cSld>
-  <p:clrMapOvr>
-    <a:masterClrMapping/>
-  </p:clrMapOvr>
-</p:sld>
-</file>
-
-<file path=ppt/slides/slide40.xml><?xml version="1.0" encoding="utf-8"?>
-<p:sld xmlns:a="http://schemas.openxmlformats.org/drawingml/2006/main" xmlns:r="http://schemas.openxmlformats.org/officeDocument/2006/relationships" xmlns:p="http://schemas.openxmlformats.org/presentationml/2006/main">
-  <p:cSld>
-    <p:spTree>
-      <p:nvGrpSpPr>
-        <p:cNvPr id="1" name="">
-          <a:extLst>
-            <a:ext uri="{FF2B5EF4-FFF2-40B4-BE49-F238E27FC236}">
-              <a16:creationId xmlns:a16="http://schemas.microsoft.com/office/drawing/2014/main" id="{6D1847F7-ABB7-B16F-C6D2-C1C625EB776C}"/>
-            </a:ext>
-          </a:extLst>
-        </p:cNvPr>
-        <p:cNvGrpSpPr/>
-        <p:nvPr/>
-      </p:nvGrpSpPr>
-      <p:grpSpPr>
-        <a:xfrm>
-          <a:off x="0" y="0"/>
-          <a:ext cx="0" cy="0"/>
-          <a:chOff x="0" y="0"/>
-          <a:chExt cx="0" cy="0"/>
-        </a:xfrm>
-      </p:grpSpPr>
-      <p:sp>
-        <p:nvSpPr>
-          <p:cNvPr id="5" name="Retângulo 4">
-            <a:extLst>
-              <a:ext uri="{FF2B5EF4-FFF2-40B4-BE49-F238E27FC236}">
-                <a16:creationId xmlns:a16="http://schemas.microsoft.com/office/drawing/2014/main" id="{8EF3F73D-222C-BBEA-C05E-4D4A8A45B37B}"/>
-              </a:ext>
-            </a:extLst>
-          </p:cNvPr>
-          <p:cNvSpPr/>
-          <p:nvPr/>
-        </p:nvSpPr>
-        <p:spPr>
-          <a:xfrm>
-            <a:off x="0" y="-2"/>
-            <a:ext cx="12192000" cy="1325563"/>
-          </a:xfrm>
-          <a:prstGeom prst="rect">
-            <a:avLst/>
-          </a:prstGeom>
-          <a:solidFill>
-            <a:schemeClr val="accent2"/>
-          </a:solidFill>
-          <a:ln>
-            <a:solidFill>
-              <a:srgbClr val="418AB3"/>
-            </a:solidFill>
-          </a:ln>
-        </p:spPr>
-        <p:style>
-          <a:lnRef idx="2">
-            <a:schemeClr val="accent1">
-              <a:shade val="15000"/>
-            </a:schemeClr>
-          </a:lnRef>
-          <a:fillRef idx="1">
-            <a:schemeClr val="accent1"/>
-          </a:fillRef>
-          <a:effectRef idx="0">
-            <a:schemeClr val="accent1"/>
-          </a:effectRef>
-          <a:fontRef idx="minor">
-            <a:schemeClr val="lt1"/>
-          </a:fontRef>
-        </p:style>
-        <p:txBody>
-          <a:bodyPr rtlCol="0" anchor="ctr"/>
-          <a:lstStyle/>
-          <a:p>
-            <a:pPr algn="ctr"/>
-            <a:endParaRPr lang="pt-BR" dirty="0"/>
-          </a:p>
-        </p:txBody>
-      </p:sp>
-      <p:sp>
-        <p:nvSpPr>
-          <p:cNvPr id="2" name="Título 1">
-            <a:extLst>
-              <a:ext uri="{FF2B5EF4-FFF2-40B4-BE49-F238E27FC236}">
-                <a16:creationId xmlns:a16="http://schemas.microsoft.com/office/drawing/2014/main" id="{3D26EF6E-CABF-F4E9-1F51-A3402B73D54B}"/>
-              </a:ext>
-            </a:extLst>
-          </p:cNvPr>
-          <p:cNvSpPr>
-            <a:spLocks noGrp="1"/>
-          </p:cNvSpPr>
-          <p:nvPr>
-            <p:ph type="title"/>
-          </p:nvPr>
-        </p:nvSpPr>
-        <p:spPr>
-          <a:xfrm>
-            <a:off x="0" y="-1"/>
-            <a:ext cx="12192000" cy="1325563"/>
-          </a:xfrm>
-        </p:spPr>
-        <p:txBody>
-          <a:bodyPr/>
-          <a:lstStyle/>
-          <a:p>
-            <a:pPr algn="ctr"/>
-            <a:r>
-              <a:rPr lang="pt-BR" dirty="0">
-                <a:solidFill>
-                  <a:schemeClr val="bg1"/>
-                </a:solidFill>
-              </a:rPr>
               <a:t>PROPRIEDADE DA ABSORÇÃO</a:t>
             </a:r>
           </a:p>
         </p:txBody>
       </p:sp>
-      <mc:AlternateContent xmlns:mc="http://schemas.openxmlformats.org/markup-compatibility/2006">
-        <mc:Choice xmlns:a14="http://schemas.microsoft.com/office/drawing/2010/main" Requires="a14">
+      <mc:AlternateContent xmlns:mc="http://schemas.openxmlformats.org/markup-compatibility/2006" xmlns:a14="http://schemas.microsoft.com/office/drawing/2010/main">
+        <mc:Choice Requires="a14">
           <p:sp>
             <p:nvSpPr>
               <p:cNvPr id="6" name="Espaço Reservado para Conteúdo 5">
@@ -25238,7 +24740,7 @@
             </p:txBody>
           </p:sp>
         </mc:Choice>
-        <mc:Fallback>
+        <mc:Fallback xmlns="">
           <p:sp>
             <p:nvSpPr>
               <p:cNvPr id="6" name="Espaço Reservado para Conteúdo 5">
@@ -25282,8 +24784,8 @@
           </p:sp>
         </mc:Fallback>
       </mc:AlternateContent>
-      <mc:AlternateContent xmlns:mc="http://schemas.openxmlformats.org/markup-compatibility/2006">
-        <mc:Choice xmlns:a14="http://schemas.microsoft.com/office/drawing/2010/main" Requires="a14">
+      <mc:AlternateContent xmlns:mc="http://schemas.openxmlformats.org/markup-compatibility/2006" xmlns:a14="http://schemas.microsoft.com/office/drawing/2010/main">
+        <mc:Choice Requires="a14">
           <p:graphicFrame>
             <p:nvGraphicFramePr>
               <p:cNvPr id="4" name="Tabela 3">
@@ -25746,7 +25248,7 @@
             </a:graphic>
           </p:graphicFrame>
         </mc:Choice>
-        <mc:Fallback>
+        <mc:Fallback xmlns="">
           <p:graphicFrame>
             <p:nvGraphicFramePr>
               <p:cNvPr id="4" name="Tabela 3">
@@ -26281,7 +25783,7 @@
 </p:sld>
 </file>
 
-<file path=ppt/slides/slide41.xml><?xml version="1.0" encoding="utf-8"?>
+<file path=ppt/slides/slide4.xml><?xml version="1.0" encoding="utf-8"?>
 <p:sld xmlns:a="http://schemas.openxmlformats.org/drawingml/2006/main" xmlns:r="http://schemas.openxmlformats.org/officeDocument/2006/relationships" xmlns:p="http://schemas.openxmlformats.org/presentationml/2006/main">
   <p:cSld>
     <p:spTree>
@@ -26289,7 +25791,7 @@
         <p:cNvPr id="1" name="">
           <a:extLst>
             <a:ext uri="{FF2B5EF4-FFF2-40B4-BE49-F238E27FC236}">
-              <a16:creationId xmlns:a16="http://schemas.microsoft.com/office/drawing/2014/main" id="{4F969A63-3C4F-8F03-7D1C-97603B7143A0}"/>
+              <a16:creationId xmlns:a16="http://schemas.microsoft.com/office/drawing/2014/main" id="{3E98EFC3-284D-D3E8-E50A-9E8782F149E5}"/>
             </a:ext>
           </a:extLst>
         </p:cNvPr>
@@ -26309,7 +25811,7 @@
           <p:cNvPr id="5" name="Retângulo 4">
             <a:extLst>
               <a:ext uri="{FF2B5EF4-FFF2-40B4-BE49-F238E27FC236}">
-                <a16:creationId xmlns:a16="http://schemas.microsoft.com/office/drawing/2014/main" id="{553FE7C8-676D-2F29-8CD2-0E8814A2D4FA}"/>
+                <a16:creationId xmlns:a16="http://schemas.microsoft.com/office/drawing/2014/main" id="{B1CC91A5-617B-F614-3886-EF59D2171B4E}"/>
               </a:ext>
             </a:extLst>
           </p:cNvPr>
@@ -26363,7 +25865,7 @@
           <p:cNvPr id="2" name="Título 1">
             <a:extLst>
               <a:ext uri="{FF2B5EF4-FFF2-40B4-BE49-F238E27FC236}">
-                <a16:creationId xmlns:a16="http://schemas.microsoft.com/office/drawing/2014/main" id="{51F66993-6C95-A6E7-4C0D-4B3CF013E591}"/>
+                <a16:creationId xmlns:a16="http://schemas.microsoft.com/office/drawing/2014/main" id="{D778D71A-5EF8-AADA-8ACC-9C2D89EE5258}"/>
               </a:ext>
             </a:extLst>
           </p:cNvPr>
@@ -26391,13 +25893,294 @@
                   <a:schemeClr val="bg1"/>
                 </a:solidFill>
               </a:rPr>
+              <a:t>Bibliografia</a:t>
+            </a:r>
+          </a:p>
+        </p:txBody>
+      </p:sp>
+      <p:sp>
+        <p:nvSpPr>
+          <p:cNvPr id="12" name="AutoShape 6" descr="Lógica Proposicional x Lógica de Argumento ⋆ Colaborae">
+            <a:extLst>
+              <a:ext uri="{FF2B5EF4-FFF2-40B4-BE49-F238E27FC236}">
+                <a16:creationId xmlns:a16="http://schemas.microsoft.com/office/drawing/2014/main" id="{ED9276FC-2835-8FCA-9E06-6FEFA248BD66}"/>
+              </a:ext>
+            </a:extLst>
+          </p:cNvPr>
+          <p:cNvSpPr>
+            <a:spLocks noChangeAspect="1" noChangeArrowheads="1"/>
+          </p:cNvSpPr>
+          <p:nvPr/>
+        </p:nvSpPr>
+        <p:spPr bwMode="auto">
+          <a:xfrm>
+            <a:off x="5943600" y="-1707776"/>
+            <a:ext cx="5289176" cy="5289176"/>
+          </a:xfrm>
+          <a:prstGeom prst="rect">
+            <a:avLst/>
+          </a:prstGeom>
+          <a:noFill/>
+          <a:extLst>
+            <a:ext uri="{909E8E84-426E-40DD-AFC4-6F175D3DCCD1}">
+              <a14:hiddenFill xmlns:a14="http://schemas.microsoft.com/office/drawing/2010/main">
+                <a:solidFill>
+                  <a:srgbClr val="FFFFFF"/>
+                </a:solidFill>
+              </a14:hiddenFill>
+            </a:ext>
+          </a:extLst>
+        </p:spPr>
+        <p:txBody>
+          <a:bodyPr vert="horz" wrap="square" lIns="91440" tIns="45720" rIns="91440" bIns="45720" numCol="1" anchor="t" anchorCtr="0" compatLnSpc="1">
+            <a:prstTxWarp prst="textNoShape">
+              <a:avLst/>
+            </a:prstTxWarp>
+          </a:bodyPr>
+          <a:lstStyle/>
+          <a:p>
+            <a:endParaRPr lang="pt-BR"/>
+          </a:p>
+        </p:txBody>
+      </p:sp>
+      <p:sp>
+        <p:nvSpPr>
+          <p:cNvPr id="6" name="Espaço Reservado para Conteúdo 5">
+            <a:extLst>
+              <a:ext uri="{FF2B5EF4-FFF2-40B4-BE49-F238E27FC236}">
+                <a16:creationId xmlns:a16="http://schemas.microsoft.com/office/drawing/2014/main" id="{E0EE607F-D9F4-7951-D428-ABA18E81EE79}"/>
+              </a:ext>
+            </a:extLst>
+          </p:cNvPr>
+          <p:cNvSpPr>
+            <a:spLocks noGrp="1"/>
+          </p:cNvSpPr>
+          <p:nvPr>
+            <p:ph idx="1"/>
+          </p:nvPr>
+        </p:nvSpPr>
+        <p:spPr>
+          <a:xfrm>
+            <a:off x="1486540" y="1804575"/>
+            <a:ext cx="9297574" cy="4746632"/>
+          </a:xfrm>
+        </p:spPr>
+        <p:txBody>
+          <a:bodyPr/>
+          <a:lstStyle/>
+          <a:p>
+            <a:r>
+              <a:rPr lang="pt-BR" sz="2400" b="1" dirty="0"/>
+              <a:t>Básica</a:t>
+            </a:r>
+          </a:p>
+          <a:p>
+            <a:pPr lvl="1"/>
+            <a:endParaRPr lang="pt-BR" sz="2200" dirty="0"/>
+          </a:p>
+          <a:p>
+            <a:pPr lvl="1"/>
+            <a:r>
+              <a:rPr lang="pt-BR" sz="2200" dirty="0"/>
+              <a:t>Matemática Discreta para Computação e Informática – PAULO MENEZES</a:t>
+            </a:r>
+          </a:p>
+          <a:p>
+            <a:pPr lvl="1"/>
+            <a:r>
+              <a:rPr lang="pt-BR" sz="2200" dirty="0"/>
+              <a:t>Matemática Discreta – THAMARA PETROLI</a:t>
+            </a:r>
+          </a:p>
+          <a:p>
+            <a:pPr lvl="1"/>
+            <a:r>
+              <a:rPr lang="pt-BR" sz="2200" dirty="0"/>
+              <a:t>Matemática discreta para ciência da computação – CLIFFORD STEIN</a:t>
+            </a:r>
+          </a:p>
+          <a:p>
+            <a:pPr lvl="1"/>
+            <a:endParaRPr lang="pt-BR" sz="2400" dirty="0"/>
+          </a:p>
+          <a:p>
+            <a:r>
+              <a:rPr lang="pt-BR" sz="2400" b="1" dirty="0"/>
+              <a:t>Complementar</a:t>
+            </a:r>
+          </a:p>
+          <a:p>
+            <a:pPr lvl="1"/>
+            <a:endParaRPr lang="pt-BR" sz="2000" dirty="0"/>
+          </a:p>
+          <a:p>
+            <a:pPr lvl="1"/>
+            <a:r>
+              <a:rPr lang="pt-BR" sz="2200" dirty="0" err="1"/>
+              <a:t>Discrete</a:t>
+            </a:r>
+            <a:r>
+              <a:rPr lang="pt-BR" sz="2200" dirty="0"/>
+              <a:t> </a:t>
+            </a:r>
+            <a:r>
+              <a:rPr lang="pt-BR" sz="2200" dirty="0" err="1"/>
+              <a:t>Mathematics</a:t>
+            </a:r>
+            <a:r>
+              <a:rPr lang="pt-BR" sz="2200" dirty="0"/>
+              <a:t> </a:t>
+            </a:r>
+            <a:r>
+              <a:rPr lang="pt-BR" sz="2200" dirty="0" err="1"/>
+              <a:t>Applications</a:t>
+            </a:r>
+            <a:r>
+              <a:rPr lang="pt-BR" sz="2200" dirty="0"/>
+              <a:t> – KENNETH ROSEN </a:t>
+            </a:r>
+          </a:p>
+          <a:p>
+            <a:endParaRPr lang="pt-BR" sz="2400" dirty="0"/>
+          </a:p>
+          <a:p>
+            <a:endParaRPr lang="pt-BR" sz="2400" dirty="0"/>
+          </a:p>
+          <a:p>
+            <a:endParaRPr lang="pt-BR" dirty="0"/>
+          </a:p>
+        </p:txBody>
+      </p:sp>
+    </p:spTree>
+    <p:extLst>
+      <p:ext uri="{BB962C8B-B14F-4D97-AF65-F5344CB8AC3E}">
+        <p14:creationId xmlns:p14="http://schemas.microsoft.com/office/powerpoint/2010/main" val="1994978664"/>
+      </p:ext>
+    </p:extLst>
+  </p:cSld>
+  <p:clrMapOvr>
+    <a:masterClrMapping/>
+  </p:clrMapOvr>
+</p:sld>
+</file>
+
+<file path=ppt/slides/slide40.xml><?xml version="1.0" encoding="utf-8"?>
+<p:sld xmlns:a="http://schemas.openxmlformats.org/drawingml/2006/main" xmlns:r="http://schemas.openxmlformats.org/officeDocument/2006/relationships" xmlns:p="http://schemas.openxmlformats.org/presentationml/2006/main">
+  <p:cSld>
+    <p:spTree>
+      <p:nvGrpSpPr>
+        <p:cNvPr id="1" name="">
+          <a:extLst>
+            <a:ext uri="{FF2B5EF4-FFF2-40B4-BE49-F238E27FC236}">
+              <a16:creationId xmlns:a16="http://schemas.microsoft.com/office/drawing/2014/main" id="{4F969A63-3C4F-8F03-7D1C-97603B7143A0}"/>
+            </a:ext>
+          </a:extLst>
+        </p:cNvPr>
+        <p:cNvGrpSpPr/>
+        <p:nvPr/>
+      </p:nvGrpSpPr>
+      <p:grpSpPr>
+        <a:xfrm>
+          <a:off x="0" y="0"/>
+          <a:ext cx="0" cy="0"/>
+          <a:chOff x="0" y="0"/>
+          <a:chExt cx="0" cy="0"/>
+        </a:xfrm>
+      </p:grpSpPr>
+      <p:sp>
+        <p:nvSpPr>
+          <p:cNvPr id="5" name="Retângulo 4">
+            <a:extLst>
+              <a:ext uri="{FF2B5EF4-FFF2-40B4-BE49-F238E27FC236}">
+                <a16:creationId xmlns:a16="http://schemas.microsoft.com/office/drawing/2014/main" id="{553FE7C8-676D-2F29-8CD2-0E8814A2D4FA}"/>
+              </a:ext>
+            </a:extLst>
+          </p:cNvPr>
+          <p:cNvSpPr/>
+          <p:nvPr/>
+        </p:nvSpPr>
+        <p:spPr>
+          <a:xfrm>
+            <a:off x="0" y="-2"/>
+            <a:ext cx="12192000" cy="1325563"/>
+          </a:xfrm>
+          <a:prstGeom prst="rect">
+            <a:avLst/>
+          </a:prstGeom>
+          <a:solidFill>
+            <a:schemeClr val="accent2"/>
+          </a:solidFill>
+          <a:ln>
+            <a:solidFill>
+              <a:srgbClr val="418AB3"/>
+            </a:solidFill>
+          </a:ln>
+        </p:spPr>
+        <p:style>
+          <a:lnRef idx="2">
+            <a:schemeClr val="accent1">
+              <a:shade val="15000"/>
+            </a:schemeClr>
+          </a:lnRef>
+          <a:fillRef idx="1">
+            <a:schemeClr val="accent1"/>
+          </a:fillRef>
+          <a:effectRef idx="0">
+            <a:schemeClr val="accent1"/>
+          </a:effectRef>
+          <a:fontRef idx="minor">
+            <a:schemeClr val="lt1"/>
+          </a:fontRef>
+        </p:style>
+        <p:txBody>
+          <a:bodyPr rtlCol="0" anchor="ctr"/>
+          <a:lstStyle/>
+          <a:p>
+            <a:pPr algn="ctr"/>
+            <a:endParaRPr lang="pt-BR" dirty="0"/>
+          </a:p>
+        </p:txBody>
+      </p:sp>
+      <p:sp>
+        <p:nvSpPr>
+          <p:cNvPr id="2" name="Título 1">
+            <a:extLst>
+              <a:ext uri="{FF2B5EF4-FFF2-40B4-BE49-F238E27FC236}">
+                <a16:creationId xmlns:a16="http://schemas.microsoft.com/office/drawing/2014/main" id="{51F66993-6C95-A6E7-4C0D-4B3CF013E591}"/>
+              </a:ext>
+            </a:extLst>
+          </p:cNvPr>
+          <p:cNvSpPr>
+            <a:spLocks noGrp="1"/>
+          </p:cNvSpPr>
+          <p:nvPr>
+            <p:ph type="title"/>
+          </p:nvPr>
+        </p:nvSpPr>
+        <p:spPr>
+          <a:xfrm>
+            <a:off x="0" y="-1"/>
+            <a:ext cx="12192000" cy="1325563"/>
+          </a:xfrm>
+        </p:spPr>
+        <p:txBody>
+          <a:bodyPr/>
+          <a:lstStyle/>
+          <a:p>
+            <a:pPr algn="ctr"/>
+            <a:r>
+              <a:rPr lang="pt-BR" dirty="0">
+                <a:solidFill>
+                  <a:schemeClr val="bg1"/>
+                </a:solidFill>
+              </a:rPr>
               <a:t>PROPRIEDADE DA ABSORÇÃO</a:t>
             </a:r>
           </a:p>
         </p:txBody>
       </p:sp>
-      <mc:AlternateContent xmlns:mc="http://schemas.openxmlformats.org/markup-compatibility/2006">
-        <mc:Choice xmlns:a14="http://schemas.microsoft.com/office/drawing/2010/main" Requires="a14">
+      <mc:AlternateContent xmlns:mc="http://schemas.openxmlformats.org/markup-compatibility/2006" xmlns:a14="http://schemas.microsoft.com/office/drawing/2010/main">
+        <mc:Choice Requires="a14">
           <p:sp>
             <p:nvSpPr>
               <p:cNvPr id="6" name="Espaço Reservado para Conteúdo 5">
@@ -26515,7 +26298,7 @@
             </p:txBody>
           </p:sp>
         </mc:Choice>
-        <mc:Fallback>
+        <mc:Fallback xmlns="">
           <p:sp>
             <p:nvSpPr>
               <p:cNvPr id="6" name="Espaço Reservado para Conteúdo 5">
@@ -26559,8 +26342,8 @@
           </p:sp>
         </mc:Fallback>
       </mc:AlternateContent>
-      <mc:AlternateContent xmlns:mc="http://schemas.openxmlformats.org/markup-compatibility/2006">
-        <mc:Choice xmlns:a14="http://schemas.microsoft.com/office/drawing/2010/main" Requires="a14">
+      <mc:AlternateContent xmlns:mc="http://schemas.openxmlformats.org/markup-compatibility/2006" xmlns:a14="http://schemas.microsoft.com/office/drawing/2010/main">
+        <mc:Choice Requires="a14">
           <p:graphicFrame>
             <p:nvGraphicFramePr>
               <p:cNvPr id="4" name="Tabela 3">
@@ -27023,7 +26806,7 @@
             </a:graphic>
           </p:graphicFrame>
         </mc:Choice>
-        <mc:Fallback>
+        <mc:Fallback xmlns="">
           <p:graphicFrame>
             <p:nvGraphicFramePr>
               <p:cNvPr id="4" name="Tabela 3">
@@ -27558,7 +27341,7 @@
 </p:sld>
 </file>
 
-<file path=ppt/slides/slide42.xml><?xml version="1.0" encoding="utf-8"?>
+<file path=ppt/slides/slide41.xml><?xml version="1.0" encoding="utf-8"?>
 <p:sld xmlns:a="http://schemas.openxmlformats.org/drawingml/2006/main" xmlns:r="http://schemas.openxmlformats.org/officeDocument/2006/relationships" xmlns:p="http://schemas.openxmlformats.org/presentationml/2006/main">
   <p:cSld>
     <p:spTree>
@@ -27673,8 +27456,8 @@
           </a:p>
         </p:txBody>
       </p:sp>
-      <mc:AlternateContent xmlns:mc="http://schemas.openxmlformats.org/markup-compatibility/2006">
-        <mc:Choice xmlns:a14="http://schemas.microsoft.com/office/drawing/2010/main" Requires="a14">
+      <mc:AlternateContent xmlns:mc="http://schemas.openxmlformats.org/markup-compatibility/2006" xmlns:a14="http://schemas.microsoft.com/office/drawing/2010/main">
+        <mc:Choice Requires="a14">
           <p:sp>
             <p:nvSpPr>
               <p:cNvPr id="6" name="Espaço Reservado para Conteúdo 5">
@@ -27879,6 +27662,7 @@
                     </m:r>
                   </m:oMath>
                 </a14:m>
+                <a:endParaRPr lang="pt-BR" sz="2200" dirty="0"/>
               </a:p>
               <a:p>
                 <a:pPr algn="just"/>
@@ -28022,7 +27806,7 @@
             </p:txBody>
           </p:sp>
         </mc:Choice>
-        <mc:Fallback>
+        <mc:Fallback xmlns="">
           <p:sp>
             <p:nvSpPr>
               <p:cNvPr id="6" name="Espaço Reservado para Conteúdo 5">
@@ -28079,7 +27863,7 @@
 </p:sld>
 </file>
 
-<file path=ppt/slides/slide43.xml><?xml version="1.0" encoding="utf-8"?>
+<file path=ppt/slides/slide42.xml><?xml version="1.0" encoding="utf-8"?>
 <p:sld xmlns:a="http://schemas.openxmlformats.org/drawingml/2006/main" xmlns:r="http://schemas.openxmlformats.org/officeDocument/2006/relationships" xmlns:p="http://schemas.openxmlformats.org/presentationml/2006/main">
   <p:cSld>
     <p:spTree>
@@ -28194,8 +27978,8 @@
           </a:p>
         </p:txBody>
       </p:sp>
-      <mc:AlternateContent xmlns:mc="http://schemas.openxmlformats.org/markup-compatibility/2006">
-        <mc:Choice xmlns:a14="http://schemas.microsoft.com/office/drawing/2010/main" Requires="a14">
+      <mc:AlternateContent xmlns:mc="http://schemas.openxmlformats.org/markup-compatibility/2006" xmlns:a14="http://schemas.microsoft.com/office/drawing/2010/main">
+        <mc:Choice Requires="a14">
           <p:sp>
             <p:nvSpPr>
               <p:cNvPr id="6" name="Espaço Reservado para Conteúdo 5">
@@ -28663,7 +28447,7 @@
             </p:txBody>
           </p:sp>
         </mc:Choice>
-        <mc:Fallback>
+        <mc:Fallback xmlns="">
           <p:sp>
             <p:nvSpPr>
               <p:cNvPr id="6" name="Espaço Reservado para Conteúdo 5">
@@ -28707,8 +28491,8 @@
           </p:sp>
         </mc:Fallback>
       </mc:AlternateContent>
-      <mc:AlternateContent xmlns:mc="http://schemas.openxmlformats.org/markup-compatibility/2006">
-        <mc:Choice xmlns:a14="http://schemas.microsoft.com/office/drawing/2010/main" Requires="a14">
+      <mc:AlternateContent xmlns:mc="http://schemas.openxmlformats.org/markup-compatibility/2006" xmlns:a14="http://schemas.microsoft.com/office/drawing/2010/main">
+        <mc:Choice Requires="a14">
           <p:sp>
             <p:nvSpPr>
               <p:cNvPr id="3" name="Espaço Reservado para Conteúdo 5">
@@ -29226,7 +29010,7 @@
             </p:txBody>
           </p:sp>
         </mc:Choice>
-        <mc:Fallback>
+        <mc:Fallback xmlns="">
           <p:sp>
             <p:nvSpPr>
               <p:cNvPr id="3" name="Espaço Reservado para Conteúdo 5">
@@ -29284,7 +29068,7 @@
 </p:sld>
 </file>
 
-<file path=ppt/slides/slide44.xml><?xml version="1.0" encoding="utf-8"?>
+<file path=ppt/slides/slide43.xml><?xml version="1.0" encoding="utf-8"?>
 <p:sld xmlns:a="http://schemas.openxmlformats.org/drawingml/2006/main" xmlns:r="http://schemas.openxmlformats.org/officeDocument/2006/relationships" xmlns:p="http://schemas.openxmlformats.org/presentationml/2006/main">
   <p:cSld>
     <p:spTree>
@@ -29630,7 +29414,7 @@
 </p:sld>
 </file>
 
-<file path=ppt/slides/slide45.xml><?xml version="1.0" encoding="utf-8"?>
+<file path=ppt/slides/slide44.xml><?xml version="1.0" encoding="utf-8"?>
 <p:sld xmlns:a="http://schemas.openxmlformats.org/drawingml/2006/main" xmlns:r="http://schemas.openxmlformats.org/officeDocument/2006/relationships" xmlns:p="http://schemas.openxmlformats.org/presentationml/2006/main">
   <p:cSld>
     <p:spTree>
@@ -29745,8 +29529,8 @@
           </a:p>
         </p:txBody>
       </p:sp>
-      <mc:AlternateContent xmlns:mc="http://schemas.openxmlformats.org/markup-compatibility/2006">
-        <mc:Choice xmlns:a14="http://schemas.microsoft.com/office/drawing/2010/main" Requires="a14">
+      <mc:AlternateContent xmlns:mc="http://schemas.openxmlformats.org/markup-compatibility/2006" xmlns:a14="http://schemas.microsoft.com/office/drawing/2010/main">
+        <mc:Choice Requires="a14">
           <p:sp>
             <p:nvSpPr>
               <p:cNvPr id="6" name="Espaço Reservado para Conteúdo 5">
@@ -29939,7 +29723,6 @@
                   </a:rPr>
                   <a:t>Isolamos o P por meio da distributiva</a:t>
                 </a:r>
-                <a14:m/>
               </a:p>
               <a:p>
                 <a:pPr lvl="1">
@@ -30059,7 +29842,6 @@
                   </a:rPr>
                   <a:t>é sempre VERDADEIRO</a:t>
                 </a:r>
-                <a14:m/>
               </a:p>
               <a:p>
                 <a:pPr lvl="1">
@@ -30192,6 +29974,7 @@
                     </m:r>
                   </m:oMath>
                 </a14:m>
+                <a:endParaRPr lang="pt-BR" sz="2400" dirty="0"/>
               </a:p>
               <a:p>
                 <a:pPr>
@@ -30204,7 +29987,9 @@
               </a:p>
               <a:p>
                 <a:pPr lvl="1" algn="just"/>
-                <a14:m/>
+                <a:endParaRPr lang="pt-BR" sz="2400" i="1" dirty="0">
+                  <a:latin typeface="Cambria Math" panose="02040503050406030204" pitchFamily="18" charset="0"/>
+                </a:endParaRPr>
               </a:p>
               <a:p>
                 <a:pPr lvl="1" algn="just"/>
@@ -30250,7 +30035,7 @@
             </p:txBody>
           </p:sp>
         </mc:Choice>
-        <mc:Fallback>
+        <mc:Fallback xmlns="">
           <p:sp>
             <p:nvSpPr>
               <p:cNvPr id="6" name="Espaço Reservado para Conteúdo 5">
@@ -30307,7 +30092,7 @@
 </p:sld>
 </file>
 
-<file path=ppt/slides/slide46.xml><?xml version="1.0" encoding="utf-8"?>
+<file path=ppt/slides/slide45.xml><?xml version="1.0" encoding="utf-8"?>
 <p:sld xmlns:a="http://schemas.openxmlformats.org/drawingml/2006/main" xmlns:r="http://schemas.openxmlformats.org/officeDocument/2006/relationships" xmlns:p="http://schemas.openxmlformats.org/presentationml/2006/main">
   <p:cSld>
     <p:spTree>
@@ -30315,7 +30100,7 @@
         <p:cNvPr id="1" name="">
           <a:extLst>
             <a:ext uri="{FF2B5EF4-FFF2-40B4-BE49-F238E27FC236}">
-              <a16:creationId xmlns:a16="http://schemas.microsoft.com/office/drawing/2014/main" id="{D6B94E6A-0EEF-F348-D2EF-79A05EF2C227}"/>
+              <a16:creationId xmlns:a16="http://schemas.microsoft.com/office/drawing/2014/main" id="{B01657AE-307F-BF7B-83B5-E5EEE20D7C6E}"/>
             </a:ext>
           </a:extLst>
         </p:cNvPr>
@@ -30335,7 +30120,7 @@
           <p:cNvPr id="5" name="Retângulo 4">
             <a:extLst>
               <a:ext uri="{FF2B5EF4-FFF2-40B4-BE49-F238E27FC236}">
-                <a16:creationId xmlns:a16="http://schemas.microsoft.com/office/drawing/2014/main" id="{68F443BA-6232-25BE-E9B9-4905AF5B5555}"/>
+                <a16:creationId xmlns:a16="http://schemas.microsoft.com/office/drawing/2014/main" id="{C7AABB55-32D7-5660-1B7B-37FCB61F6EFF}"/>
               </a:ext>
             </a:extLst>
           </p:cNvPr>
@@ -30389,7 +30174,7 @@
           <p:cNvPr id="2" name="Título 1">
             <a:extLst>
               <a:ext uri="{FF2B5EF4-FFF2-40B4-BE49-F238E27FC236}">
-                <a16:creationId xmlns:a16="http://schemas.microsoft.com/office/drawing/2014/main" id="{75377FAC-4736-6A56-2EEA-7362B8B30386}"/>
+                <a16:creationId xmlns:a16="http://schemas.microsoft.com/office/drawing/2014/main" id="{AD1260A6-3C07-1BE4-AB53-24D1107EAA53}"/>
               </a:ext>
             </a:extLst>
           </p:cNvPr>
@@ -30417,7 +30202,7 @@
                   <a:schemeClr val="bg1"/>
                 </a:solidFill>
               </a:rPr>
-              <a:t>FIXAÇÃO</a:t>
+              <a:t>ALGEBRA BOOLEANA (INTRO)</a:t>
             </a:r>
           </a:p>
         </p:txBody>
@@ -30429,7 +30214,7 @@
               <p:cNvPr id="6" name="Espaço Reservado para Conteúdo 5">
                 <a:extLst>
                   <a:ext uri="{FF2B5EF4-FFF2-40B4-BE49-F238E27FC236}">
-                    <a16:creationId xmlns:a16="http://schemas.microsoft.com/office/drawing/2014/main" id="{F33A672B-D691-E420-A36D-1AC05AA591C1}"/>
+                    <a16:creationId xmlns:a16="http://schemas.microsoft.com/office/drawing/2014/main" id="{39DDE79E-1CD0-DFFD-47FD-D9A2F01FE0F0}"/>
                   </a:ext>
                 </a:extLst>
               </p:cNvPr>
@@ -30442,8 +30227,8 @@
             </p:nvSpPr>
             <p:spPr>
               <a:xfrm>
-                <a:off x="1273629" y="1655775"/>
-                <a:ext cx="9644742" cy="4942113"/>
+                <a:off x="1674394" y="1672390"/>
+                <a:ext cx="8843212" cy="4872789"/>
               </a:xfrm>
             </p:spPr>
             <p:txBody>
@@ -30454,150 +30239,239 @@
               <a:p>
                 <a:r>
                   <a:rPr lang="pt-BR" sz="2400" dirty="0"/>
-                  <a:t>Simplificação das expressões: </a:t>
+                  <a:t>A álgebra booleana é um sistema matemático criado por </a:t>
+                </a:r>
+                <a:r>
+                  <a:rPr lang="pt-BR" sz="2400" i="1" dirty="0"/>
+                  <a:t>George </a:t>
+                </a:r>
+                <a:r>
+                  <a:rPr lang="pt-BR" sz="2400" i="1" dirty="0" err="1"/>
+                  <a:t>Boole</a:t>
+                </a:r>
+                <a:r>
+                  <a:rPr lang="pt-BR" sz="2400" dirty="0"/>
+                  <a:t>, que serve de base para a </a:t>
+                </a:r>
+                <a:r>
+                  <a:rPr lang="pt-BR" sz="2400" b="1" dirty="0"/>
+                  <a:t>lógica digital</a:t>
+                </a:r>
+                <a:r>
+                  <a:rPr lang="pt-BR" sz="2400" dirty="0"/>
+                  <a:t>, a </a:t>
+                </a:r>
+                <a:r>
+                  <a:rPr lang="pt-BR" sz="2400" b="1" dirty="0"/>
+                  <a:t>programação</a:t>
+                </a:r>
+                <a:r>
+                  <a:rPr lang="pt-BR" sz="2400" dirty="0"/>
+                  <a:t> e o funcionamento dos computadores modernos.</a:t>
                 </a:r>
               </a:p>
               <a:p>
-                <a:pPr lvl="1"/>
-                <a:endParaRPr lang="pt-BR" sz="2200" i="1" dirty="0">
-                  <a:latin typeface="Cambria Math" panose="02040503050406030204" pitchFamily="18" charset="0"/>
+                <a:endParaRPr lang="pt-BR" sz="2400" dirty="0"/>
+              </a:p>
+              <a:p>
+                <a:pPr lvl="1">
+                  <a:buFont typeface="Courier New" panose="02070309020205020404" pitchFamily="49" charset="0"/>
+                  <a:buChar char="o"/>
+                </a:pPr>
+                <a:r>
+                  <a:rPr lang="pt-BR" sz="2000" dirty="0"/>
+                  <a:t>Verdadeiro </a:t>
+                </a:r>
+                <a:r>
+                  <a:rPr lang="pt-BR" sz="2000" dirty="0">
+                    <a:sym typeface="Wingdings" panose="05000000000000000000" pitchFamily="2" charset="2"/>
+                  </a:rPr>
+                  <a:t> 1</a:t>
+                </a:r>
+                <a:endParaRPr lang="pt-BR" sz="2000" dirty="0"/>
+              </a:p>
+              <a:p>
+                <a:pPr lvl="1">
+                  <a:buFont typeface="Courier New" panose="02070309020205020404" pitchFamily="49" charset="0"/>
+                  <a:buChar char="o"/>
+                </a:pPr>
+                <a:r>
+                  <a:rPr lang="pt-BR" sz="2000" dirty="0">
+                    <a:sym typeface="Wingdings" panose="05000000000000000000" pitchFamily="2" charset="2"/>
+                  </a:rPr>
+                  <a:t>Falso  0</a:t>
+                </a:r>
+              </a:p>
+              <a:p>
+                <a:pPr lvl="1">
+                  <a:buFont typeface="Courier New" panose="02070309020205020404" pitchFamily="49" charset="0"/>
+                  <a:buChar char="o"/>
+                </a:pPr>
+                <a:r>
+                  <a:rPr lang="pt-BR" sz="2000" dirty="0">
+                    <a:sym typeface="Wingdings" panose="05000000000000000000" pitchFamily="2" charset="2"/>
+                  </a:rPr>
+                  <a:t>Conjunção   + (Soma)</a:t>
+                </a:r>
+              </a:p>
+              <a:p>
+                <a:pPr lvl="1">
+                  <a:buFont typeface="Courier New" panose="02070309020205020404" pitchFamily="49" charset="0"/>
+                  <a:buChar char="o"/>
+                </a:pPr>
+                <a:r>
+                  <a:rPr lang="pt-BR" sz="2000" dirty="0">
+                    <a:sym typeface="Wingdings" panose="05000000000000000000" pitchFamily="2" charset="2"/>
+                  </a:rPr>
+                  <a:t>Disjunção  * (Multiplicação)</a:t>
+                </a:r>
+              </a:p>
+              <a:p>
+                <a:pPr lvl="1">
+                  <a:buFont typeface="Courier New" panose="02070309020205020404" pitchFamily="49" charset="0"/>
+                  <a:buChar char="o"/>
+                </a:pPr>
+                <a:r>
+                  <a:rPr lang="pt-BR" sz="2000" dirty="0">
+                    <a:sym typeface="Wingdings" panose="05000000000000000000" pitchFamily="2" charset="2"/>
+                  </a:rPr>
+                  <a:t>Negação   </a:t>
+                </a:r>
+                <a:r>
+                  <a:rPr lang="pt-BR" sz="2000" dirty="0">
+                    <a:latin typeface="Calibri" panose="020F0502020204030204" pitchFamily="34" charset="0"/>
+                    <a:ea typeface="Calibri" panose="020F0502020204030204" pitchFamily="34" charset="0"/>
+                    <a:cs typeface="Calibri" panose="020F0502020204030204" pitchFamily="34" charset="0"/>
+                    <a:sym typeface="Wingdings" panose="05000000000000000000" pitchFamily="2" charset="2"/>
+                  </a:rPr>
+                  <a:t>─ (Barrado)</a:t>
+                </a:r>
+              </a:p>
+              <a:p>
+                <a:pPr lvl="1">
+                  <a:buFont typeface="Courier New" panose="02070309020205020404" pitchFamily="49" charset="0"/>
+                  <a:buChar char="o"/>
+                </a:pPr>
+                <a:endParaRPr lang="pt-BR" sz="2000" dirty="0">
+                  <a:latin typeface="Calibri" panose="020F0502020204030204" pitchFamily="34" charset="0"/>
+                  <a:ea typeface="Calibri" panose="020F0502020204030204" pitchFamily="34" charset="0"/>
+                  <a:cs typeface="Calibri" panose="020F0502020204030204" pitchFamily="34" charset="0"/>
+                  <a:sym typeface="Wingdings" panose="05000000000000000000" pitchFamily="2" charset="2"/>
                 </a:endParaRPr>
               </a:p>
               <a:p>
-                <a:pPr lvl="1"/>
-                <a:endParaRPr lang="pt-BR" sz="2200" i="1" dirty="0">
-                  <a:latin typeface="Cambria Math" panose="02040503050406030204" pitchFamily="18" charset="0"/>
-                </a:endParaRPr>
-              </a:p>
-              <a:p>
-                <a:pPr lvl="1"/>
-                <a14:m/>
-              </a:p>
-              <a:p>
-                <a:pPr lvl="1"/>
-                <a:endParaRPr lang="pt-BR" sz="2200" i="1" dirty="0">
-                  <a:latin typeface="Cambria Math" panose="02040503050406030204" pitchFamily="18" charset="0"/>
-                </a:endParaRPr>
-              </a:p>
-              <a:p>
-                <a:pPr lvl="1"/>
-                <a14:m/>
-              </a:p>
-              <a:p>
-                <a:pPr lvl="1"/>
-                <a:endParaRPr lang="pt-BR" sz="2200" dirty="0"/>
-              </a:p>
-              <a:p>
-                <a:pPr lvl="1"/>
+                <a:pPr lvl="1">
+                  <a:buFont typeface="Courier New" panose="02070309020205020404" pitchFamily="49" charset="0"/>
+                  <a:buChar char="o"/>
+                </a:pPr>
+                <a:r>
+                  <a:rPr lang="pt-BR" sz="2000" dirty="0">
+                    <a:latin typeface="Calibri" panose="020F0502020204030204" pitchFamily="34" charset="0"/>
+                    <a:ea typeface="Calibri" panose="020F0502020204030204" pitchFamily="34" charset="0"/>
+                    <a:cs typeface="Calibri" panose="020F0502020204030204" pitchFamily="34" charset="0"/>
+                    <a:sym typeface="Wingdings" panose="05000000000000000000" pitchFamily="2" charset="2"/>
+                  </a:rPr>
+                  <a:t>Exemplo: </a:t>
+                </a:r>
                 <a14:m>
                   <m:oMath xmlns:m="http://schemas.openxmlformats.org/officeDocument/2006/math">
                     <m:r>
-                      <a:rPr lang="pt-BR" sz="2200" i="1" dirty="0" smtClean="0">
+                      <a:rPr lang="pt-BR" sz="2000" b="1" i="1" dirty="0" smtClean="0">
                         <a:latin typeface="Cambria Math" panose="02040503050406030204" pitchFamily="18" charset="0"/>
                       </a:rPr>
-                      <m:t>[(</m:t>
+                      <m:t>𝑷</m:t>
                     </m:r>
                     <m:r>
-                      <a:rPr lang="pt-BR" sz="2200" i="1" dirty="0" smtClean="0">
-                        <a:latin typeface="Cambria Math" panose="02040503050406030204" pitchFamily="18" charset="0"/>
-                      </a:rPr>
-                      <m:t>𝑃</m:t>
-                    </m:r>
-                    <m:r>
-                      <a:rPr lang="pt-BR" sz="2200" i="1" dirty="0" smtClean="0">
-                        <a:latin typeface="Cambria Math" panose="02040503050406030204" pitchFamily="18" charset="0"/>
-                      </a:rPr>
-                      <m:t>∧</m:t>
-                    </m:r>
-                    <m:r>
-                      <a:rPr lang="pt-BR" sz="2200" i="1" dirty="0" smtClean="0">
-                        <a:latin typeface="Cambria Math" panose="02040503050406030204" pitchFamily="18" charset="0"/>
-                      </a:rPr>
-                      <m:t>𝑄</m:t>
-                    </m:r>
-                    <m:r>
-                      <a:rPr lang="pt-BR" sz="2200" i="1" dirty="0" smtClean="0">
-                        <a:latin typeface="Cambria Math" panose="02040503050406030204" pitchFamily="18" charset="0"/>
-                      </a:rPr>
-                      <m:t>)∨(</m:t>
-                    </m:r>
-                    <m:r>
-                      <a:rPr lang="pt-BR" sz="2200" i="1" dirty="0" smtClean="0">
-                        <a:latin typeface="Cambria Math" panose="02040503050406030204" pitchFamily="18" charset="0"/>
-                      </a:rPr>
-                      <m:t>𝑃</m:t>
-                    </m:r>
-                    <m:r>
-                      <a:rPr lang="pt-BR" sz="2200" i="1" dirty="0" smtClean="0">
+                      <a:rPr lang="pt-BR" sz="2000" b="1" i="1" dirty="0">
                         <a:latin typeface="Cambria Math" panose="02040503050406030204" pitchFamily="18" charset="0"/>
                       </a:rPr>
                       <m:t>∧¬</m:t>
                     </m:r>
                     <m:r>
-                      <a:rPr lang="pt-BR" sz="2200" i="1" dirty="0" smtClean="0">
+                      <a:rPr lang="pt-BR" sz="2000" b="1" i="1" dirty="0">
                         <a:latin typeface="Cambria Math" panose="02040503050406030204" pitchFamily="18" charset="0"/>
                       </a:rPr>
-                      <m:t>𝑄</m:t>
+                      <m:t>𝑸</m:t>
                     </m:r>
                     <m:r>
-                      <a:rPr lang="pt-BR" sz="2200" i="1" dirty="0" smtClean="0">
+                      <a:rPr lang="pt-BR" sz="2000" b="1" i="1" dirty="0" smtClean="0">
                         <a:latin typeface="Cambria Math" panose="02040503050406030204" pitchFamily="18" charset="0"/>
                       </a:rPr>
-                      <m:t>)]∧[(</m:t>
+                      <m:t>=</m:t>
                     </m:r>
                     <m:r>
-                      <a:rPr lang="pt-BR" sz="2200" i="1" dirty="0" smtClean="0">
+                      <a:rPr lang="pt-BR" sz="2000" b="1" i="1" dirty="0" smtClean="0">
                         <a:latin typeface="Cambria Math" panose="02040503050406030204" pitchFamily="18" charset="0"/>
                       </a:rPr>
-                      <m:t>𝑃</m:t>
+                      <m:t>𝑨</m:t>
                     </m:r>
-                    <m:r>
-                      <a:rPr lang="pt-BR" sz="2200" i="1" dirty="0" smtClean="0">
-                        <a:latin typeface="Cambria Math" panose="02040503050406030204" pitchFamily="18" charset="0"/>
-                      </a:rPr>
-                      <m:t>∨</m:t>
-                    </m:r>
-                    <m:r>
-                      <a:rPr lang="pt-BR" sz="2200" i="1" dirty="0" smtClean="0">
-                        <a:latin typeface="Cambria Math" panose="02040503050406030204" pitchFamily="18" charset="0"/>
-                      </a:rPr>
-                      <m:t>𝑅</m:t>
-                    </m:r>
-                    <m:r>
-                      <a:rPr lang="pt-BR" sz="2200" i="1" dirty="0" smtClean="0">
-                        <a:latin typeface="Cambria Math" panose="02040503050406030204" pitchFamily="18" charset="0"/>
-                      </a:rPr>
-                      <m:t>)∧(</m:t>
-                    </m:r>
-                    <m:r>
-                      <a:rPr lang="pt-BR" sz="2200" i="1" dirty="0" smtClean="0">
-                        <a:latin typeface="Cambria Math" panose="02040503050406030204" pitchFamily="18" charset="0"/>
-                      </a:rPr>
-                      <m:t>𝑃</m:t>
-                    </m:r>
-                    <m:r>
-                      <a:rPr lang="pt-BR" sz="2200" i="1" dirty="0" smtClean="0">
-                        <a:latin typeface="Cambria Math" panose="02040503050406030204" pitchFamily="18" charset="0"/>
-                      </a:rPr>
-                      <m:t>∨¬</m:t>
-                    </m:r>
-                    <m:r>
-                      <a:rPr lang="pt-BR" sz="2200" i="1" dirty="0" smtClean="0">
-                        <a:latin typeface="Cambria Math" panose="02040503050406030204" pitchFamily="18" charset="0"/>
-                      </a:rPr>
-                      <m:t>𝑅</m:t>
-                    </m:r>
-                    <m:r>
-                      <a:rPr lang="pt-BR" sz="2200" i="1" dirty="0" smtClean="0">
-                        <a:latin typeface="Cambria Math" panose="02040503050406030204" pitchFamily="18" charset="0"/>
-                      </a:rPr>
-                      <m:t>)]</m:t>
-                    </m:r>
+                    <m:acc>
+                      <m:accPr>
+                        <m:chr m:val="̅"/>
+                        <m:ctrlPr>
+                          <a:rPr lang="pt-BR" sz="2000" b="1" i="1" dirty="0" smtClean="0">
+                            <a:latin typeface="Cambria Math" panose="02040503050406030204" pitchFamily="18" charset="0"/>
+                          </a:rPr>
+                        </m:ctrlPr>
+                      </m:accPr>
+                      <m:e>
+                        <m:r>
+                          <a:rPr lang="pt-BR" sz="2000" b="1" i="1" dirty="0" smtClean="0">
+                            <a:latin typeface="Cambria Math" panose="02040503050406030204" pitchFamily="18" charset="0"/>
+                          </a:rPr>
+                          <m:t>𝑩</m:t>
+                        </m:r>
+                      </m:e>
+                    </m:acc>
                   </m:oMath>
                 </a14:m>
+                <a:endParaRPr lang="pt-BR" sz="2200" dirty="0">
+                  <a:sym typeface="Wingdings" panose="05000000000000000000" pitchFamily="2" charset="2"/>
+                </a:endParaRPr>
               </a:p>
               <a:p>
+                <a:pPr marL="0" indent="0" algn="just">
+                  <a:buNone/>
+                </a:pPr>
+                <a:r>
+                  <a:rPr lang="pt-BR" sz="2400" dirty="0"/>
+                  <a:t>	</a:t>
+                </a:r>
+              </a:p>
+              <a:p>
+                <a:pPr marL="0" indent="0" algn="just">
+                  <a:buNone/>
+                </a:pPr>
                 <a:endParaRPr lang="pt-BR" sz="2400" dirty="0"/>
+              </a:p>
+              <a:p>
+                <a:pPr algn="just"/>
+                <a:endParaRPr lang="pt-BR" sz="2200" dirty="0"/>
+              </a:p>
+              <a:p>
+                <a:pPr lvl="1" algn="just"/>
+                <a:endParaRPr lang="pt-BR" sz="2000" dirty="0"/>
+              </a:p>
+              <a:p>
+                <a:pPr marL="914400" lvl="1" indent="-457200" algn="just">
+                  <a:buFont typeface="+mj-lt"/>
+                  <a:buAutoNum type="arabicPeriod"/>
+                </a:pPr>
+                <a:endParaRPr lang="pt-BR" b="1" i="1" dirty="0">
+                  <a:latin typeface="Cambria Math" panose="02040503050406030204" pitchFamily="18" charset="0"/>
+                </a:endParaRPr>
+              </a:p>
+              <a:p>
+                <a:pPr marL="457200" lvl="1" indent="0" algn="just">
+                  <a:buNone/>
+                </a:pPr>
+                <a:endParaRPr lang="pt-BR" b="1" dirty="0"/>
+              </a:p>
+              <a:p>
+                <a:pPr marL="457200" lvl="1" indent="0" algn="just">
+                  <a:buNone/>
+                </a:pPr>
+                <a:endParaRPr lang="pt-BR" b="1" dirty="0"/>
               </a:p>
             </p:txBody>
           </p:sp>
@@ -30608,7 +30482,7 @@
               <p:cNvPr id="6" name="Espaço Reservado para Conteúdo 5">
                 <a:extLst>
                   <a:ext uri="{FF2B5EF4-FFF2-40B4-BE49-F238E27FC236}">
-                    <a16:creationId xmlns:a16="http://schemas.microsoft.com/office/drawing/2014/main" id="{F33A672B-D691-E420-A36D-1AC05AA591C1}"/>
+                    <a16:creationId xmlns:a16="http://schemas.microsoft.com/office/drawing/2014/main" id="{39DDE79E-1CD0-DFFD-47FD-D9A2F01FE0F0}"/>
                   </a:ext>
                 </a:extLst>
               </p:cNvPr>
@@ -30621,13 +30495,13 @@
             </p:nvSpPr>
             <p:spPr>
               <a:xfrm>
-                <a:off x="1273629" y="1655775"/>
-                <a:ext cx="9644742" cy="4942113"/>
+                <a:off x="1674394" y="1672390"/>
+                <a:ext cx="8843212" cy="4872789"/>
               </a:xfrm>
               <a:blipFill>
                 <a:blip r:embed="rId3"/>
                 <a:stretch>
-                  <a:fillRect l="-885" t="-1728"/>
+                  <a:fillRect l="-966" t="-1750"/>
                 </a:stretch>
               </a:blipFill>
             </p:spPr>
@@ -30649,7 +30523,254 @@
     </p:spTree>
     <p:extLst>
       <p:ext uri="{BB962C8B-B14F-4D97-AF65-F5344CB8AC3E}">
-        <p14:creationId xmlns:p14="http://schemas.microsoft.com/office/powerpoint/2010/main" val="1991209999"/>
+        <p14:creationId xmlns:p14="http://schemas.microsoft.com/office/powerpoint/2010/main" val="339704320"/>
+      </p:ext>
+    </p:extLst>
+  </p:cSld>
+  <p:clrMapOvr>
+    <a:masterClrMapping/>
+  </p:clrMapOvr>
+</p:sld>
+</file>
+
+<file path=ppt/slides/slide46.xml><?xml version="1.0" encoding="utf-8"?>
+<p:sld xmlns:a="http://schemas.openxmlformats.org/drawingml/2006/main" xmlns:r="http://schemas.openxmlformats.org/officeDocument/2006/relationships" xmlns:p="http://schemas.openxmlformats.org/presentationml/2006/main">
+  <p:cSld>
+    <p:spTree>
+      <p:nvGrpSpPr>
+        <p:cNvPr id="1" name="">
+          <a:extLst>
+            <a:ext uri="{FF2B5EF4-FFF2-40B4-BE49-F238E27FC236}">
+              <a16:creationId xmlns:a16="http://schemas.microsoft.com/office/drawing/2014/main" id="{247ACADE-A840-3BE9-33C2-2379B4027FDA}"/>
+            </a:ext>
+          </a:extLst>
+        </p:cNvPr>
+        <p:cNvGrpSpPr/>
+        <p:nvPr/>
+      </p:nvGrpSpPr>
+      <p:grpSpPr>
+        <a:xfrm>
+          <a:off x="0" y="0"/>
+          <a:ext cx="0" cy="0"/>
+          <a:chOff x="0" y="0"/>
+          <a:chExt cx="0" cy="0"/>
+        </a:xfrm>
+      </p:grpSpPr>
+      <p:sp>
+        <p:nvSpPr>
+          <p:cNvPr id="5" name="Retângulo 4">
+            <a:extLst>
+              <a:ext uri="{FF2B5EF4-FFF2-40B4-BE49-F238E27FC236}">
+                <a16:creationId xmlns:a16="http://schemas.microsoft.com/office/drawing/2014/main" id="{5D6F4223-B114-1B64-C5A5-94547D50A986}"/>
+              </a:ext>
+            </a:extLst>
+          </p:cNvPr>
+          <p:cNvSpPr/>
+          <p:nvPr/>
+        </p:nvSpPr>
+        <p:spPr>
+          <a:xfrm>
+            <a:off x="0" y="-2"/>
+            <a:ext cx="12192000" cy="1325563"/>
+          </a:xfrm>
+          <a:prstGeom prst="rect">
+            <a:avLst/>
+          </a:prstGeom>
+          <a:solidFill>
+            <a:schemeClr val="accent2"/>
+          </a:solidFill>
+          <a:ln>
+            <a:solidFill>
+              <a:srgbClr val="418AB3"/>
+            </a:solidFill>
+          </a:ln>
+        </p:spPr>
+        <p:style>
+          <a:lnRef idx="2">
+            <a:schemeClr val="accent1">
+              <a:shade val="15000"/>
+            </a:schemeClr>
+          </a:lnRef>
+          <a:fillRef idx="1">
+            <a:schemeClr val="accent1"/>
+          </a:fillRef>
+          <a:effectRef idx="0">
+            <a:schemeClr val="accent1"/>
+          </a:effectRef>
+          <a:fontRef idx="minor">
+            <a:schemeClr val="lt1"/>
+          </a:fontRef>
+        </p:style>
+        <p:txBody>
+          <a:bodyPr rtlCol="0" anchor="ctr"/>
+          <a:lstStyle/>
+          <a:p>
+            <a:pPr algn="ctr"/>
+            <a:endParaRPr lang="pt-BR" dirty="0"/>
+          </a:p>
+        </p:txBody>
+      </p:sp>
+      <p:sp>
+        <p:nvSpPr>
+          <p:cNvPr id="2" name="Título 1">
+            <a:extLst>
+              <a:ext uri="{FF2B5EF4-FFF2-40B4-BE49-F238E27FC236}">
+                <a16:creationId xmlns:a16="http://schemas.microsoft.com/office/drawing/2014/main" id="{A8DB634D-98C2-7C53-CE8C-88718DA1DEDA}"/>
+              </a:ext>
+            </a:extLst>
+          </p:cNvPr>
+          <p:cNvSpPr>
+            <a:spLocks noGrp="1"/>
+          </p:cNvSpPr>
+          <p:nvPr>
+            <p:ph type="title"/>
+          </p:nvPr>
+        </p:nvSpPr>
+        <p:spPr>
+          <a:xfrm>
+            <a:off x="0" y="-1"/>
+            <a:ext cx="12192000" cy="1325563"/>
+          </a:xfrm>
+        </p:spPr>
+        <p:txBody>
+          <a:bodyPr/>
+          <a:lstStyle/>
+          <a:p>
+            <a:pPr algn="ctr"/>
+            <a:r>
+              <a:rPr lang="pt-BR" dirty="0">
+                <a:solidFill>
+                  <a:schemeClr val="bg1"/>
+                </a:solidFill>
+              </a:rPr>
+              <a:t>FIXAÇÃO - DESAFIO</a:t>
+            </a:r>
+          </a:p>
+        </p:txBody>
+      </p:sp>
+      <p:sp>
+        <p:nvSpPr>
+          <p:cNvPr id="6" name="Espaço Reservado para Conteúdo 5">
+            <a:extLst>
+              <a:ext uri="{FF2B5EF4-FFF2-40B4-BE49-F238E27FC236}">
+                <a16:creationId xmlns:a16="http://schemas.microsoft.com/office/drawing/2014/main" id="{D169E136-FFE4-8C03-85FE-9C8A6D6859BD}"/>
+              </a:ext>
+            </a:extLst>
+          </p:cNvPr>
+          <p:cNvSpPr>
+            <a:spLocks noGrp="1"/>
+          </p:cNvSpPr>
+          <p:nvPr>
+            <p:ph idx="1"/>
+          </p:nvPr>
+        </p:nvSpPr>
+        <p:spPr>
+          <a:xfrm>
+            <a:off x="1758950" y="1817914"/>
+            <a:ext cx="8888997" cy="4669971"/>
+          </a:xfrm>
+        </p:spPr>
+        <p:txBody>
+          <a:bodyPr>
+            <a:normAutofit/>
+          </a:bodyPr>
+          <a:lstStyle/>
+          <a:p>
+            <a:pPr marL="457200" indent="-457200" algn="just">
+              <a:buFont typeface="+mj-lt"/>
+              <a:buAutoNum type="arabicPeriod"/>
+            </a:pPr>
+            <a:r>
+              <a:rPr lang="pt-BR" sz="2400" dirty="0"/>
+              <a:t>Considerando que a logica proposicional trabalha essencialmente com conjunções, disjunções e negações. Como poderíamos representar a </a:t>
+            </a:r>
+            <a:r>
+              <a:rPr lang="pt-BR" sz="2400" b="1" dirty="0"/>
+              <a:t>condicional</a:t>
+            </a:r>
+            <a:r>
+              <a:rPr lang="pt-BR" sz="2400" dirty="0"/>
+              <a:t>, a </a:t>
+            </a:r>
+            <a:r>
+              <a:rPr lang="pt-BR" sz="2400" b="1" dirty="0" err="1"/>
+              <a:t>bi-condicional</a:t>
+            </a:r>
+            <a:r>
+              <a:rPr lang="pt-BR" sz="2400" dirty="0"/>
+              <a:t> e a </a:t>
+            </a:r>
+            <a:r>
+              <a:rPr lang="pt-BR" sz="2400" b="1" dirty="0"/>
+              <a:t>disjunção exclusiva</a:t>
+            </a:r>
+            <a:r>
+              <a:rPr lang="pt-BR" sz="2400" dirty="0"/>
+              <a:t>, dentro das formas normais?</a:t>
+            </a:r>
+          </a:p>
+          <a:p>
+            <a:pPr marL="457200" indent="-457200" algn="just">
+              <a:buFont typeface="+mj-lt"/>
+              <a:buAutoNum type="arabicPeriod"/>
+            </a:pPr>
+            <a:endParaRPr lang="pt-BR" sz="2400" dirty="0"/>
+          </a:p>
+          <a:p>
+            <a:pPr marL="457200" indent="-457200" algn="just">
+              <a:buFont typeface="+mj-lt"/>
+              <a:buAutoNum type="arabicPeriod"/>
+            </a:pPr>
+            <a:r>
+              <a:rPr lang="pt-BR" sz="2400" dirty="0"/>
+              <a:t>Simplifique as expressões:</a:t>
+            </a:r>
+          </a:p>
+          <a:p>
+            <a:pPr marL="0" indent="0" algn="just">
+              <a:buNone/>
+            </a:pPr>
+            <a:r>
+              <a:rPr lang="pt-BR" sz="2400" dirty="0"/>
+              <a:t> </a:t>
+            </a:r>
+          </a:p>
+        </p:txBody>
+      </p:sp>
+      <p:pic>
+        <p:nvPicPr>
+          <p:cNvPr id="3" name="Imagem 2">
+            <a:extLst>
+              <a:ext uri="{FF2B5EF4-FFF2-40B4-BE49-F238E27FC236}">
+                <a16:creationId xmlns:a16="http://schemas.microsoft.com/office/drawing/2014/main" id="{47F2354F-9002-B04F-3F3B-CD5583E0DED6}"/>
+              </a:ext>
+            </a:extLst>
+          </p:cNvPr>
+          <p:cNvPicPr>
+            <a:picLocks noChangeAspect="1"/>
+          </p:cNvPicPr>
+          <p:nvPr/>
+        </p:nvPicPr>
+        <p:blipFill>
+          <a:blip r:embed="rId3"/>
+          <a:stretch>
+            <a:fillRect/>
+          </a:stretch>
+        </p:blipFill>
+        <p:spPr>
+          <a:xfrm>
+            <a:off x="2455673" y="4412643"/>
+            <a:ext cx="7495550" cy="2445357"/>
+          </a:xfrm>
+          <a:prstGeom prst="rect">
+            <a:avLst/>
+          </a:prstGeom>
+        </p:spPr>
+      </p:pic>
+    </p:spTree>
+    <p:extLst>
+      <p:ext uri="{BB962C8B-B14F-4D97-AF65-F5344CB8AC3E}">
+        <p14:creationId xmlns:p14="http://schemas.microsoft.com/office/powerpoint/2010/main" val="3630648018"/>
       </p:ext>
     </p:extLst>
   </p:cSld>

</xml_diff>

<commit_message>
Atualização de aulas de MD 14/08
</commit_message>
<xml_diff>
--- a/UNIUBE-MD/Teoria_MD.pptx
+++ b/UNIUBE-MD/Teoria_MD.pptx
@@ -6,7 +6,7 @@
     <p:sldMasterId id="2147483684" r:id="rId2"/>
   </p:sldMasterIdLst>
   <p:notesMasterIdLst>
-    <p:notesMasterId r:id="rId45"/>
+    <p:notesMasterId r:id="rId52"/>
   </p:notesMasterIdLst>
   <p:sldIdLst>
     <p:sldId id="256" r:id="rId3"/>
@@ -49,8 +49,15 @@
     <p:sldId id="328" r:id="rId40"/>
     <p:sldId id="329" r:id="rId41"/>
     <p:sldId id="330" r:id="rId42"/>
-    <p:sldId id="332" r:id="rId43"/>
-    <p:sldId id="321" r:id="rId44"/>
+    <p:sldId id="321" r:id="rId43"/>
+    <p:sldId id="333" r:id="rId44"/>
+    <p:sldId id="334" r:id="rId45"/>
+    <p:sldId id="332" r:id="rId46"/>
+    <p:sldId id="335" r:id="rId47"/>
+    <p:sldId id="336" r:id="rId48"/>
+    <p:sldId id="337" r:id="rId49"/>
+    <p:sldId id="338" r:id="rId50"/>
+    <p:sldId id="339" r:id="rId51"/>
   </p:sldIdLst>
   <p:sldSz cx="12192000" cy="6858000"/>
   <p:notesSz cx="6858000" cy="9144000"/>
@@ -239,7 +246,7 @@
           <a:p>
             <a:fld id="{6ED03497-8374-466E-85FA-95E1138D8F6E}" type="datetimeFigureOut">
               <a:rPr lang="pt-BR" smtClean="0"/>
-              <a:t>11/08/2026</a:t>
+              <a:t>14/08/2026</a:t>
             </a:fld>
             <a:endParaRPr lang="pt-BR"/>
           </a:p>
@@ -534,6 +541,13 @@
           </p:nvPr>
         </p:nvSpPr>
         <p:spPr/>
+        <p:txBody>
+          <a:bodyPr/>
+          <a:lstStyle/>
+          <a:p>
+            <a:endParaRPr lang="pt-BR"/>
+          </a:p>
+        </p:txBody>
       </p:sp>
       <p:sp>
         <p:nvSpPr>
@@ -630,6 +644,13 @@
           </p:nvPr>
         </p:nvSpPr>
         <p:spPr/>
+        <p:txBody>
+          <a:bodyPr/>
+          <a:lstStyle/>
+          <a:p>
+            <a:endParaRPr lang="pt-BR"/>
+          </a:p>
+        </p:txBody>
       </p:sp>
       <p:sp>
         <p:nvSpPr>
@@ -742,6 +763,13 @@
           </p:nvPr>
         </p:nvSpPr>
         <p:spPr/>
+        <p:txBody>
+          <a:bodyPr/>
+          <a:lstStyle/>
+          <a:p>
+            <a:endParaRPr lang="pt-BR"/>
+          </a:p>
+        </p:txBody>
       </p:sp>
       <p:sp>
         <p:nvSpPr>
@@ -854,6 +882,13 @@
           </p:nvPr>
         </p:nvSpPr>
         <p:spPr/>
+        <p:txBody>
+          <a:bodyPr/>
+          <a:lstStyle/>
+          <a:p>
+            <a:endParaRPr lang="pt-BR"/>
+          </a:p>
+        </p:txBody>
       </p:sp>
       <p:sp>
         <p:nvSpPr>
@@ -1035,6 +1070,13 @@
           </p:nvPr>
         </p:nvSpPr>
         <p:spPr/>
+        <p:txBody>
+          <a:bodyPr/>
+          <a:lstStyle/>
+          <a:p>
+            <a:endParaRPr lang="pt-BR"/>
+          </a:p>
+        </p:txBody>
       </p:sp>
       <p:sp>
         <p:nvSpPr>
@@ -1155,6 +1197,13 @@
           </p:nvPr>
         </p:nvSpPr>
         <p:spPr/>
+        <p:txBody>
+          <a:bodyPr/>
+          <a:lstStyle/>
+          <a:p>
+            <a:endParaRPr lang="pt-BR"/>
+          </a:p>
+        </p:txBody>
       </p:sp>
       <p:sp>
         <p:nvSpPr>
@@ -1267,6 +1316,13 @@
           </p:nvPr>
         </p:nvSpPr>
         <p:spPr/>
+        <p:txBody>
+          <a:bodyPr/>
+          <a:lstStyle/>
+          <a:p>
+            <a:endParaRPr lang="pt-BR"/>
+          </a:p>
+        </p:txBody>
       </p:sp>
       <p:sp>
         <p:nvSpPr>
@@ -1379,6 +1435,13 @@
           </p:nvPr>
         </p:nvSpPr>
         <p:spPr/>
+        <p:txBody>
+          <a:bodyPr/>
+          <a:lstStyle/>
+          <a:p>
+            <a:endParaRPr lang="pt-BR"/>
+          </a:p>
+        </p:txBody>
       </p:sp>
       <p:sp>
         <p:nvSpPr>
@@ -1491,6 +1554,13 @@
           </p:nvPr>
         </p:nvSpPr>
         <p:spPr/>
+        <p:txBody>
+          <a:bodyPr/>
+          <a:lstStyle/>
+          <a:p>
+            <a:endParaRPr lang="pt-BR"/>
+          </a:p>
+        </p:txBody>
       </p:sp>
       <p:sp>
         <p:nvSpPr>
@@ -1603,6 +1673,13 @@
           </p:nvPr>
         </p:nvSpPr>
         <p:spPr/>
+        <p:txBody>
+          <a:bodyPr/>
+          <a:lstStyle/>
+          <a:p>
+            <a:endParaRPr lang="pt-BR"/>
+          </a:p>
+        </p:txBody>
       </p:sp>
       <p:sp>
         <p:nvSpPr>
@@ -1715,6 +1792,13 @@
           </p:nvPr>
         </p:nvSpPr>
         <p:spPr/>
+        <p:txBody>
+          <a:bodyPr/>
+          <a:lstStyle/>
+          <a:p>
+            <a:endParaRPr lang="pt-BR"/>
+          </a:p>
+        </p:txBody>
       </p:sp>
       <p:sp>
         <p:nvSpPr>
@@ -1891,6 +1975,13 @@
           </p:nvPr>
         </p:nvSpPr>
         <p:spPr/>
+        <p:txBody>
+          <a:bodyPr/>
+          <a:lstStyle/>
+          <a:p>
+            <a:endParaRPr lang="pt-BR"/>
+          </a:p>
+        </p:txBody>
       </p:sp>
       <p:sp>
         <p:nvSpPr>
@@ -2025,6 +2116,13 @@
           </p:nvPr>
         </p:nvSpPr>
         <p:spPr/>
+        <p:txBody>
+          <a:bodyPr/>
+          <a:lstStyle/>
+          <a:p>
+            <a:endParaRPr lang="pt-BR"/>
+          </a:p>
+        </p:txBody>
       </p:sp>
       <p:sp>
         <p:nvSpPr>
@@ -2190,6 +2288,13 @@
           </p:nvPr>
         </p:nvSpPr>
         <p:spPr/>
+        <p:txBody>
+          <a:bodyPr/>
+          <a:lstStyle/>
+          <a:p>
+            <a:endParaRPr lang="pt-BR"/>
+          </a:p>
+        </p:txBody>
       </p:sp>
       <p:sp>
         <p:nvSpPr>
@@ -2302,6 +2407,13 @@
           </p:nvPr>
         </p:nvSpPr>
         <p:spPr/>
+        <p:txBody>
+          <a:bodyPr/>
+          <a:lstStyle/>
+          <a:p>
+            <a:endParaRPr lang="pt-BR"/>
+          </a:p>
+        </p:txBody>
       </p:sp>
       <p:sp>
         <p:nvSpPr>
@@ -2414,6 +2526,13 @@
           </p:nvPr>
         </p:nvSpPr>
         <p:spPr/>
+        <p:txBody>
+          <a:bodyPr/>
+          <a:lstStyle/>
+          <a:p>
+            <a:endParaRPr lang="pt-BR"/>
+          </a:p>
+        </p:txBody>
       </p:sp>
       <p:sp>
         <p:nvSpPr>
@@ -2533,6 +2652,13 @@
           </p:nvPr>
         </p:nvSpPr>
         <p:spPr/>
+        <p:txBody>
+          <a:bodyPr/>
+          <a:lstStyle/>
+          <a:p>
+            <a:endParaRPr lang="pt-BR"/>
+          </a:p>
+        </p:txBody>
       </p:sp>
       <p:sp>
         <p:nvSpPr>
@@ -2645,6 +2771,13 @@
           </p:nvPr>
         </p:nvSpPr>
         <p:spPr/>
+        <p:txBody>
+          <a:bodyPr/>
+          <a:lstStyle/>
+          <a:p>
+            <a:endParaRPr lang="pt-BR"/>
+          </a:p>
+        </p:txBody>
       </p:sp>
       <p:sp>
         <p:nvSpPr>
@@ -2757,6 +2890,13 @@
           </p:nvPr>
         </p:nvSpPr>
         <p:spPr/>
+        <p:txBody>
+          <a:bodyPr/>
+          <a:lstStyle/>
+          <a:p>
+            <a:endParaRPr lang="pt-BR"/>
+          </a:p>
+        </p:txBody>
       </p:sp>
       <p:sp>
         <p:nvSpPr>
@@ -2907,6 +3047,13 @@
           </p:nvPr>
         </p:nvSpPr>
         <p:spPr/>
+        <p:txBody>
+          <a:bodyPr/>
+          <a:lstStyle/>
+          <a:p>
+            <a:endParaRPr lang="pt-BR"/>
+          </a:p>
+        </p:txBody>
       </p:sp>
       <p:sp>
         <p:nvSpPr>
@@ -3057,6 +3204,13 @@
           </p:nvPr>
         </p:nvSpPr>
         <p:spPr/>
+        <p:txBody>
+          <a:bodyPr/>
+          <a:lstStyle/>
+          <a:p>
+            <a:endParaRPr lang="pt-BR"/>
+          </a:p>
+        </p:txBody>
       </p:sp>
       <p:sp>
         <p:nvSpPr>
@@ -3172,6 +3326,13 @@
           </p:nvPr>
         </p:nvSpPr>
         <p:spPr/>
+        <p:txBody>
+          <a:bodyPr/>
+          <a:lstStyle/>
+          <a:p>
+            <a:endParaRPr lang="pt-BR"/>
+          </a:p>
+        </p:txBody>
       </p:sp>
       <p:sp>
         <p:nvSpPr>
@@ -3284,6 +3445,13 @@
           </p:nvPr>
         </p:nvSpPr>
         <p:spPr/>
+        <p:txBody>
+          <a:bodyPr/>
+          <a:lstStyle/>
+          <a:p>
+            <a:endParaRPr lang="pt-BR"/>
+          </a:p>
+        </p:txBody>
       </p:sp>
       <p:sp>
         <p:nvSpPr>
@@ -3396,6 +3564,13 @@
           </p:nvPr>
         </p:nvSpPr>
         <p:spPr/>
+        <p:txBody>
+          <a:bodyPr/>
+          <a:lstStyle/>
+          <a:p>
+            <a:endParaRPr lang="pt-BR"/>
+          </a:p>
+        </p:txBody>
       </p:sp>
       <p:sp>
         <p:nvSpPr>
@@ -3508,6 +3683,13 @@
           </p:nvPr>
         </p:nvSpPr>
         <p:spPr/>
+        <p:txBody>
+          <a:bodyPr/>
+          <a:lstStyle/>
+          <a:p>
+            <a:endParaRPr lang="pt-BR"/>
+          </a:p>
+        </p:txBody>
       </p:sp>
       <p:sp>
         <p:nvSpPr>
@@ -3620,6 +3802,13 @@
           </p:nvPr>
         </p:nvSpPr>
         <p:spPr/>
+        <p:txBody>
+          <a:bodyPr/>
+          <a:lstStyle/>
+          <a:p>
+            <a:endParaRPr lang="pt-BR"/>
+          </a:p>
+        </p:txBody>
       </p:sp>
       <p:sp>
         <p:nvSpPr>
@@ -3728,6 +3917,13 @@
           </p:nvPr>
         </p:nvSpPr>
         <p:spPr/>
+        <p:txBody>
+          <a:bodyPr/>
+          <a:lstStyle/>
+          <a:p>
+            <a:endParaRPr lang="pt-BR"/>
+          </a:p>
+        </p:txBody>
       </p:sp>
       <p:sp>
         <p:nvSpPr>
@@ -3840,6 +4036,13 @@
           </p:nvPr>
         </p:nvSpPr>
         <p:spPr/>
+        <p:txBody>
+          <a:bodyPr/>
+          <a:lstStyle/>
+          <a:p>
+            <a:endParaRPr lang="pt-BR"/>
+          </a:p>
+        </p:txBody>
       </p:sp>
       <p:sp>
         <p:nvSpPr>
@@ -3952,6 +4155,13 @@
           </p:nvPr>
         </p:nvSpPr>
         <p:spPr/>
+        <p:txBody>
+          <a:bodyPr/>
+          <a:lstStyle/>
+          <a:p>
+            <a:endParaRPr lang="pt-BR"/>
+          </a:p>
+        </p:txBody>
       </p:sp>
       <p:sp>
         <p:nvSpPr>
@@ -4064,6 +4274,13 @@
           </p:nvPr>
         </p:nvSpPr>
         <p:spPr/>
+        <p:txBody>
+          <a:bodyPr/>
+          <a:lstStyle/>
+          <a:p>
+            <a:endParaRPr lang="pt-BR"/>
+          </a:p>
+        </p:txBody>
       </p:sp>
       <p:sp>
         <p:nvSpPr>
@@ -4176,6 +4393,13 @@
           </p:nvPr>
         </p:nvSpPr>
         <p:spPr/>
+        <p:txBody>
+          <a:bodyPr/>
+          <a:lstStyle/>
+          <a:p>
+            <a:endParaRPr lang="pt-BR"/>
+          </a:p>
+        </p:txBody>
       </p:sp>
       <p:sp>
         <p:nvSpPr>
@@ -4288,6 +4512,13 @@
           </p:nvPr>
         </p:nvSpPr>
         <p:spPr/>
+        <p:txBody>
+          <a:bodyPr/>
+          <a:lstStyle/>
+          <a:p>
+            <a:endParaRPr lang="pt-BR"/>
+          </a:p>
+        </p:txBody>
       </p:sp>
       <p:sp>
         <p:nvSpPr>
@@ -4400,6 +4631,13 @@
           </p:nvPr>
         </p:nvSpPr>
         <p:spPr/>
+        <p:txBody>
+          <a:bodyPr/>
+          <a:lstStyle/>
+          <a:p>
+            <a:endParaRPr lang="pt-BR"/>
+          </a:p>
+        </p:txBody>
       </p:sp>
       <p:sp>
         <p:nvSpPr>
@@ -4512,6 +4750,13 @@
           </p:nvPr>
         </p:nvSpPr>
         <p:spPr/>
+        <p:txBody>
+          <a:bodyPr/>
+          <a:lstStyle/>
+          <a:p>
+            <a:endParaRPr lang="pt-BR"/>
+          </a:p>
+        </p:txBody>
       </p:sp>
       <p:sp>
         <p:nvSpPr>
@@ -4703,6 +4948,13 @@
           </p:nvPr>
         </p:nvSpPr>
         <p:spPr/>
+        <p:txBody>
+          <a:bodyPr/>
+          <a:lstStyle/>
+          <a:p>
+            <a:endParaRPr lang="pt-BR"/>
+          </a:p>
+        </p:txBody>
       </p:sp>
       <p:sp>
         <p:nvSpPr>
@@ -4776,6 +5028,359 @@
 </file>
 
 <file path=ppt/notesSlides/notesSlide41.xml><?xml version="1.0" encoding="utf-8"?>
+<p:notes xmlns:a="http://schemas.openxmlformats.org/drawingml/2006/main" xmlns:r="http://schemas.openxmlformats.org/officeDocument/2006/relationships" xmlns:p="http://schemas.openxmlformats.org/presentationml/2006/main">
+  <p:cSld>
+    <p:spTree>
+      <p:nvGrpSpPr>
+        <p:cNvPr id="1" name="">
+          <a:extLst>
+            <a:ext uri="{FF2B5EF4-FFF2-40B4-BE49-F238E27FC236}">
+              <a16:creationId xmlns:a16="http://schemas.microsoft.com/office/drawing/2014/main" id="{45B0221E-6368-1C7D-9593-484248ACF94E}"/>
+            </a:ext>
+          </a:extLst>
+        </p:cNvPr>
+        <p:cNvGrpSpPr/>
+        <p:nvPr/>
+      </p:nvGrpSpPr>
+      <p:grpSpPr>
+        <a:xfrm>
+          <a:off x="0" y="0"/>
+          <a:ext cx="0" cy="0"/>
+          <a:chOff x="0" y="0"/>
+          <a:chExt cx="0" cy="0"/>
+        </a:xfrm>
+      </p:grpSpPr>
+      <p:sp>
+        <p:nvSpPr>
+          <p:cNvPr id="2" name="Espaço Reservado para Imagem de Slide 1">
+            <a:extLst>
+              <a:ext uri="{FF2B5EF4-FFF2-40B4-BE49-F238E27FC236}">
+                <a16:creationId xmlns:a16="http://schemas.microsoft.com/office/drawing/2014/main" id="{CD60B933-EE74-A667-09B1-66F8CCC1F8E6}"/>
+              </a:ext>
+            </a:extLst>
+          </p:cNvPr>
+          <p:cNvSpPr>
+            <a:spLocks noGrp="1" noRot="1" noChangeAspect="1"/>
+          </p:cNvSpPr>
+          <p:nvPr>
+            <p:ph type="sldImg"/>
+          </p:nvPr>
+        </p:nvSpPr>
+        <p:spPr/>
+        <p:txBody>
+          <a:bodyPr/>
+          <a:lstStyle/>
+          <a:p>
+            <a:endParaRPr lang="pt-BR"/>
+          </a:p>
+        </p:txBody>
+      </p:sp>
+      <p:sp>
+        <p:nvSpPr>
+          <p:cNvPr id="3" name="Espaço Reservado para Anotações 2">
+            <a:extLst>
+              <a:ext uri="{FF2B5EF4-FFF2-40B4-BE49-F238E27FC236}">
+                <a16:creationId xmlns:a16="http://schemas.microsoft.com/office/drawing/2014/main" id="{C7F52DF8-BCEA-CDA9-5237-324EF1EE40C7}"/>
+              </a:ext>
+            </a:extLst>
+          </p:cNvPr>
+          <p:cNvSpPr>
+            <a:spLocks noGrp="1"/>
+          </p:cNvSpPr>
+          <p:nvPr>
+            <p:ph type="body" idx="1"/>
+          </p:nvPr>
+        </p:nvSpPr>
+        <p:spPr/>
+        <p:txBody>
+          <a:bodyPr/>
+          <a:lstStyle/>
+          <a:p>
+            <a:pPr marL="0" indent="0">
+              <a:buFontTx/>
+              <a:buNone/>
+            </a:pPr>
+            <a:endParaRPr lang="pt-BR" b="0" dirty="0"/>
+          </a:p>
+        </p:txBody>
+      </p:sp>
+      <p:sp>
+        <p:nvSpPr>
+          <p:cNvPr id="4" name="Espaço Reservado para Número de Slide 3">
+            <a:extLst>
+              <a:ext uri="{FF2B5EF4-FFF2-40B4-BE49-F238E27FC236}">
+                <a16:creationId xmlns:a16="http://schemas.microsoft.com/office/drawing/2014/main" id="{4A54C782-31C4-95EE-3CD4-D14A40A1035C}"/>
+              </a:ext>
+            </a:extLst>
+          </p:cNvPr>
+          <p:cNvSpPr>
+            <a:spLocks noGrp="1"/>
+          </p:cNvSpPr>
+          <p:nvPr>
+            <p:ph type="sldNum" sz="quarter" idx="5"/>
+          </p:nvPr>
+        </p:nvSpPr>
+        <p:spPr/>
+        <p:txBody>
+          <a:bodyPr/>
+          <a:lstStyle/>
+          <a:p>
+            <a:fld id="{80F36A49-A1DD-40F8-B8AD-E6F5365256CB}" type="slidenum">
+              <a:rPr lang="pt-BR" smtClean="0"/>
+              <a:t>41</a:t>
+            </a:fld>
+            <a:endParaRPr lang="pt-BR"/>
+          </a:p>
+        </p:txBody>
+      </p:sp>
+    </p:spTree>
+    <p:extLst>
+      <p:ext uri="{BB962C8B-B14F-4D97-AF65-F5344CB8AC3E}">
+        <p14:creationId xmlns:p14="http://schemas.microsoft.com/office/powerpoint/2010/main" val="1969739803"/>
+      </p:ext>
+    </p:extLst>
+  </p:cSld>
+  <p:clrMapOvr>
+    <a:masterClrMapping/>
+  </p:clrMapOvr>
+</p:notes>
+</file>
+
+<file path=ppt/notesSlides/notesSlide42.xml><?xml version="1.0" encoding="utf-8"?>
+<p:notes xmlns:a="http://schemas.openxmlformats.org/drawingml/2006/main" xmlns:r="http://schemas.openxmlformats.org/officeDocument/2006/relationships" xmlns:p="http://schemas.openxmlformats.org/presentationml/2006/main">
+  <p:cSld>
+    <p:spTree>
+      <p:nvGrpSpPr>
+        <p:cNvPr id="1" name="">
+          <a:extLst>
+            <a:ext uri="{FF2B5EF4-FFF2-40B4-BE49-F238E27FC236}">
+              <a16:creationId xmlns:a16="http://schemas.microsoft.com/office/drawing/2014/main" id="{A58F6697-C208-5BBC-94E9-543DF8621BFD}"/>
+            </a:ext>
+          </a:extLst>
+        </p:cNvPr>
+        <p:cNvGrpSpPr/>
+        <p:nvPr/>
+      </p:nvGrpSpPr>
+      <p:grpSpPr>
+        <a:xfrm>
+          <a:off x="0" y="0"/>
+          <a:ext cx="0" cy="0"/>
+          <a:chOff x="0" y="0"/>
+          <a:chExt cx="0" cy="0"/>
+        </a:xfrm>
+      </p:grpSpPr>
+      <p:sp>
+        <p:nvSpPr>
+          <p:cNvPr id="2" name="Espaço Reservado para Imagem de Slide 1">
+            <a:extLst>
+              <a:ext uri="{FF2B5EF4-FFF2-40B4-BE49-F238E27FC236}">
+                <a16:creationId xmlns:a16="http://schemas.microsoft.com/office/drawing/2014/main" id="{4432F391-2563-7041-A001-314D2758423E}"/>
+              </a:ext>
+            </a:extLst>
+          </p:cNvPr>
+          <p:cNvSpPr>
+            <a:spLocks noGrp="1" noRot="1" noChangeAspect="1"/>
+          </p:cNvSpPr>
+          <p:nvPr>
+            <p:ph type="sldImg"/>
+          </p:nvPr>
+        </p:nvSpPr>
+        <p:spPr/>
+        <p:txBody>
+          <a:bodyPr/>
+          <a:lstStyle/>
+          <a:p>
+            <a:endParaRPr lang="pt-BR"/>
+          </a:p>
+        </p:txBody>
+      </p:sp>
+      <p:sp>
+        <p:nvSpPr>
+          <p:cNvPr id="3" name="Espaço Reservado para Anotações 2">
+            <a:extLst>
+              <a:ext uri="{FF2B5EF4-FFF2-40B4-BE49-F238E27FC236}">
+                <a16:creationId xmlns:a16="http://schemas.microsoft.com/office/drawing/2014/main" id="{BD7A20EC-1517-8ABA-9A72-F398BCF41CEC}"/>
+              </a:ext>
+            </a:extLst>
+          </p:cNvPr>
+          <p:cNvSpPr>
+            <a:spLocks noGrp="1"/>
+          </p:cNvSpPr>
+          <p:nvPr>
+            <p:ph type="body" idx="1"/>
+          </p:nvPr>
+        </p:nvSpPr>
+        <p:spPr/>
+        <p:txBody>
+          <a:bodyPr/>
+          <a:lstStyle/>
+          <a:p>
+            <a:endParaRPr lang="pt-BR" dirty="0"/>
+          </a:p>
+        </p:txBody>
+      </p:sp>
+      <p:sp>
+        <p:nvSpPr>
+          <p:cNvPr id="4" name="Espaço Reservado para Número de Slide 3">
+            <a:extLst>
+              <a:ext uri="{FF2B5EF4-FFF2-40B4-BE49-F238E27FC236}">
+                <a16:creationId xmlns:a16="http://schemas.microsoft.com/office/drawing/2014/main" id="{904DE3B9-4624-81DA-27D6-13377D6CCD4F}"/>
+              </a:ext>
+            </a:extLst>
+          </p:cNvPr>
+          <p:cNvSpPr>
+            <a:spLocks noGrp="1"/>
+          </p:cNvSpPr>
+          <p:nvPr>
+            <p:ph type="sldNum" sz="quarter" idx="5"/>
+          </p:nvPr>
+        </p:nvSpPr>
+        <p:spPr/>
+        <p:txBody>
+          <a:bodyPr/>
+          <a:lstStyle/>
+          <a:p>
+            <a:fld id="{80F36A49-A1DD-40F8-B8AD-E6F5365256CB}" type="slidenum">
+              <a:rPr lang="pt-BR" smtClean="0"/>
+              <a:t>42</a:t>
+            </a:fld>
+            <a:endParaRPr lang="pt-BR"/>
+          </a:p>
+        </p:txBody>
+      </p:sp>
+    </p:spTree>
+    <p:extLst>
+      <p:ext uri="{BB962C8B-B14F-4D97-AF65-F5344CB8AC3E}">
+        <p14:creationId xmlns:p14="http://schemas.microsoft.com/office/powerpoint/2010/main" val="642283960"/>
+      </p:ext>
+    </p:extLst>
+  </p:cSld>
+  <p:clrMapOvr>
+    <a:masterClrMapping/>
+  </p:clrMapOvr>
+</p:notes>
+</file>
+
+<file path=ppt/notesSlides/notesSlide43.xml><?xml version="1.0" encoding="utf-8"?>
+<p:notes xmlns:a="http://schemas.openxmlformats.org/drawingml/2006/main" xmlns:r="http://schemas.openxmlformats.org/officeDocument/2006/relationships" xmlns:p="http://schemas.openxmlformats.org/presentationml/2006/main">
+  <p:cSld>
+    <p:spTree>
+      <p:nvGrpSpPr>
+        <p:cNvPr id="1" name="">
+          <a:extLst>
+            <a:ext uri="{FF2B5EF4-FFF2-40B4-BE49-F238E27FC236}">
+              <a16:creationId xmlns:a16="http://schemas.microsoft.com/office/drawing/2014/main" id="{BA2B99CF-ECE7-C852-DDD3-CE5EE768F458}"/>
+            </a:ext>
+          </a:extLst>
+        </p:cNvPr>
+        <p:cNvGrpSpPr/>
+        <p:nvPr/>
+      </p:nvGrpSpPr>
+      <p:grpSpPr>
+        <a:xfrm>
+          <a:off x="0" y="0"/>
+          <a:ext cx="0" cy="0"/>
+          <a:chOff x="0" y="0"/>
+          <a:chExt cx="0" cy="0"/>
+        </a:xfrm>
+      </p:grpSpPr>
+      <p:sp>
+        <p:nvSpPr>
+          <p:cNvPr id="2" name="Espaço Reservado para Imagem de Slide 1">
+            <a:extLst>
+              <a:ext uri="{FF2B5EF4-FFF2-40B4-BE49-F238E27FC236}">
+                <a16:creationId xmlns:a16="http://schemas.microsoft.com/office/drawing/2014/main" id="{8232D8EF-CE7D-49A7-41A0-2BE2DE3D7AB0}"/>
+              </a:ext>
+            </a:extLst>
+          </p:cNvPr>
+          <p:cNvSpPr>
+            <a:spLocks noGrp="1" noRot="1" noChangeAspect="1"/>
+          </p:cNvSpPr>
+          <p:nvPr>
+            <p:ph type="sldImg"/>
+          </p:nvPr>
+        </p:nvSpPr>
+        <p:spPr/>
+        <p:txBody>
+          <a:bodyPr/>
+          <a:lstStyle/>
+          <a:p>
+            <a:endParaRPr lang="pt-BR"/>
+          </a:p>
+        </p:txBody>
+      </p:sp>
+      <p:sp>
+        <p:nvSpPr>
+          <p:cNvPr id="3" name="Espaço Reservado para Anotações 2">
+            <a:extLst>
+              <a:ext uri="{FF2B5EF4-FFF2-40B4-BE49-F238E27FC236}">
+                <a16:creationId xmlns:a16="http://schemas.microsoft.com/office/drawing/2014/main" id="{9A7C2474-776E-1BEC-FB1F-2CD647F9CCCA}"/>
+              </a:ext>
+            </a:extLst>
+          </p:cNvPr>
+          <p:cNvSpPr>
+            <a:spLocks noGrp="1"/>
+          </p:cNvSpPr>
+          <p:nvPr>
+            <p:ph type="body" idx="1"/>
+          </p:nvPr>
+        </p:nvSpPr>
+        <p:spPr/>
+        <p:txBody>
+          <a:bodyPr/>
+          <a:lstStyle/>
+          <a:p>
+            <a:pPr marL="0" indent="0">
+              <a:buFontTx/>
+              <a:buNone/>
+            </a:pPr>
+            <a:endParaRPr lang="pt-BR" b="0" dirty="0"/>
+          </a:p>
+        </p:txBody>
+      </p:sp>
+      <p:sp>
+        <p:nvSpPr>
+          <p:cNvPr id="4" name="Espaço Reservado para Número de Slide 3">
+            <a:extLst>
+              <a:ext uri="{FF2B5EF4-FFF2-40B4-BE49-F238E27FC236}">
+                <a16:creationId xmlns:a16="http://schemas.microsoft.com/office/drawing/2014/main" id="{34695F6D-26AE-394E-9C4C-E41B4281EBE5}"/>
+              </a:ext>
+            </a:extLst>
+          </p:cNvPr>
+          <p:cNvSpPr>
+            <a:spLocks noGrp="1"/>
+          </p:cNvSpPr>
+          <p:nvPr>
+            <p:ph type="sldNum" sz="quarter" idx="5"/>
+          </p:nvPr>
+        </p:nvSpPr>
+        <p:spPr/>
+        <p:txBody>
+          <a:bodyPr/>
+          <a:lstStyle/>
+          <a:p>
+            <a:fld id="{80F36A49-A1DD-40F8-B8AD-E6F5365256CB}" type="slidenum">
+              <a:rPr lang="pt-BR" smtClean="0"/>
+              <a:t>43</a:t>
+            </a:fld>
+            <a:endParaRPr lang="pt-BR"/>
+          </a:p>
+        </p:txBody>
+      </p:sp>
+    </p:spTree>
+    <p:extLst>
+      <p:ext uri="{BB962C8B-B14F-4D97-AF65-F5344CB8AC3E}">
+        <p14:creationId xmlns:p14="http://schemas.microsoft.com/office/powerpoint/2010/main" val="3247985561"/>
+      </p:ext>
+    </p:extLst>
+  </p:cSld>
+  <p:clrMapOvr>
+    <a:masterClrMapping/>
+  </p:clrMapOvr>
+</p:notes>
+</file>
+
+<file path=ppt/notesSlides/notesSlide44.xml><?xml version="1.0" encoding="utf-8"?>
 <p:notes xmlns:a="http://schemas.openxmlformats.org/drawingml/2006/main" xmlns:r="http://schemas.openxmlformats.org/officeDocument/2006/relationships" xmlns:p="http://schemas.openxmlformats.org/presentationml/2006/main">
   <p:cSld>
     <p:spTree>
@@ -4815,6 +5420,13 @@
           </p:nvPr>
         </p:nvSpPr>
         <p:spPr/>
+        <p:txBody>
+          <a:bodyPr/>
+          <a:lstStyle/>
+          <a:p>
+            <a:endParaRPr lang="pt-BR"/>
+          </a:p>
+        </p:txBody>
       </p:sp>
       <p:sp>
         <p:nvSpPr>
@@ -4868,7 +5480,7 @@
           <a:p>
             <a:fld id="{80F36A49-A1DD-40F8-B8AD-E6F5365256CB}" type="slidenum">
               <a:rPr lang="pt-BR" smtClean="0"/>
-              <a:t>41</a:t>
+              <a:t>44</a:t>
             </a:fld>
             <a:endParaRPr lang="pt-BR"/>
           </a:p>
@@ -4887,7 +5499,7 @@
 </p:notes>
 </file>
 
-<file path=ppt/notesSlides/notesSlide42.xml><?xml version="1.0" encoding="utf-8"?>
+<file path=ppt/notesSlides/notesSlide45.xml><?xml version="1.0" encoding="utf-8"?>
 <p:notes xmlns:a="http://schemas.openxmlformats.org/drawingml/2006/main" xmlns:r="http://schemas.openxmlformats.org/officeDocument/2006/relationships" xmlns:p="http://schemas.openxmlformats.org/presentationml/2006/main">
   <p:cSld>
     <p:spTree>
@@ -4895,7 +5507,7 @@
         <p:cNvPr id="1" name="">
           <a:extLst>
             <a:ext uri="{FF2B5EF4-FFF2-40B4-BE49-F238E27FC236}">
-              <a16:creationId xmlns:a16="http://schemas.microsoft.com/office/drawing/2014/main" id="{45B0221E-6368-1C7D-9593-484248ACF94E}"/>
+              <a16:creationId xmlns:a16="http://schemas.microsoft.com/office/drawing/2014/main" id="{C187AECF-DFC8-93FC-CB35-019C77E72C17}"/>
             </a:ext>
           </a:extLst>
         </p:cNvPr>
@@ -4915,7 +5527,7 @@
           <p:cNvPr id="2" name="Espaço Reservado para Imagem de Slide 1">
             <a:extLst>
               <a:ext uri="{FF2B5EF4-FFF2-40B4-BE49-F238E27FC236}">
-                <a16:creationId xmlns:a16="http://schemas.microsoft.com/office/drawing/2014/main" id="{CD60B933-EE74-A667-09B1-66F8CCC1F8E6}"/>
+                <a16:creationId xmlns:a16="http://schemas.microsoft.com/office/drawing/2014/main" id="{267179DB-577C-2938-EB44-73138DB40D73}"/>
               </a:ext>
             </a:extLst>
           </p:cNvPr>
@@ -4927,13 +5539,20 @@
           </p:nvPr>
         </p:nvSpPr>
         <p:spPr/>
+        <p:txBody>
+          <a:bodyPr/>
+          <a:lstStyle/>
+          <a:p>
+            <a:endParaRPr lang="pt-BR"/>
+          </a:p>
+        </p:txBody>
       </p:sp>
       <p:sp>
         <p:nvSpPr>
           <p:cNvPr id="3" name="Espaço Reservado para Anotações 2">
             <a:extLst>
               <a:ext uri="{FF2B5EF4-FFF2-40B4-BE49-F238E27FC236}">
-                <a16:creationId xmlns:a16="http://schemas.microsoft.com/office/drawing/2014/main" id="{C7F52DF8-BCEA-CDA9-5237-324EF1EE40C7}"/>
+                <a16:creationId xmlns:a16="http://schemas.microsoft.com/office/drawing/2014/main" id="{686D73F6-CE06-36C2-B437-2EAE233C1E68}"/>
               </a:ext>
             </a:extLst>
           </p:cNvPr>
@@ -4962,7 +5581,7 @@
           <p:cNvPr id="4" name="Espaço Reservado para Número de Slide 3">
             <a:extLst>
               <a:ext uri="{FF2B5EF4-FFF2-40B4-BE49-F238E27FC236}">
-                <a16:creationId xmlns:a16="http://schemas.microsoft.com/office/drawing/2014/main" id="{4A54C782-31C4-95EE-3CD4-D14A40A1035C}"/>
+                <a16:creationId xmlns:a16="http://schemas.microsoft.com/office/drawing/2014/main" id="{D71924B2-E1DE-87D5-99AE-1381EE0E557D}"/>
               </a:ext>
             </a:extLst>
           </p:cNvPr>
@@ -4980,7 +5599,7 @@
           <a:p>
             <a:fld id="{80F36A49-A1DD-40F8-B8AD-E6F5365256CB}" type="slidenum">
               <a:rPr lang="pt-BR" smtClean="0"/>
-              <a:t>42</a:t>
+              <a:t>45</a:t>
             </a:fld>
             <a:endParaRPr lang="pt-BR"/>
           </a:p>
@@ -4989,7 +5608,479 @@
     </p:spTree>
     <p:extLst>
       <p:ext uri="{BB962C8B-B14F-4D97-AF65-F5344CB8AC3E}">
-        <p14:creationId xmlns:p14="http://schemas.microsoft.com/office/powerpoint/2010/main" val="1969739803"/>
+        <p14:creationId xmlns:p14="http://schemas.microsoft.com/office/powerpoint/2010/main" val="3299407207"/>
+      </p:ext>
+    </p:extLst>
+  </p:cSld>
+  <p:clrMapOvr>
+    <a:masterClrMapping/>
+  </p:clrMapOvr>
+</p:notes>
+</file>
+
+<file path=ppt/notesSlides/notesSlide46.xml><?xml version="1.0" encoding="utf-8"?>
+<p:notes xmlns:a="http://schemas.openxmlformats.org/drawingml/2006/main" xmlns:r="http://schemas.openxmlformats.org/officeDocument/2006/relationships" xmlns:p="http://schemas.openxmlformats.org/presentationml/2006/main">
+  <p:cSld>
+    <p:spTree>
+      <p:nvGrpSpPr>
+        <p:cNvPr id="1" name="">
+          <a:extLst>
+            <a:ext uri="{FF2B5EF4-FFF2-40B4-BE49-F238E27FC236}">
+              <a16:creationId xmlns:a16="http://schemas.microsoft.com/office/drawing/2014/main" id="{CC1BF4F0-8AFD-3053-7D1F-4CD572817FCF}"/>
+            </a:ext>
+          </a:extLst>
+        </p:cNvPr>
+        <p:cNvGrpSpPr/>
+        <p:nvPr/>
+      </p:nvGrpSpPr>
+      <p:grpSpPr>
+        <a:xfrm>
+          <a:off x="0" y="0"/>
+          <a:ext cx="0" cy="0"/>
+          <a:chOff x="0" y="0"/>
+          <a:chExt cx="0" cy="0"/>
+        </a:xfrm>
+      </p:grpSpPr>
+      <p:sp>
+        <p:nvSpPr>
+          <p:cNvPr id="2" name="Espaço Reservado para Imagem de Slide 1">
+            <a:extLst>
+              <a:ext uri="{FF2B5EF4-FFF2-40B4-BE49-F238E27FC236}">
+                <a16:creationId xmlns:a16="http://schemas.microsoft.com/office/drawing/2014/main" id="{04152620-466D-2EDD-9767-03F8295873A8}"/>
+              </a:ext>
+            </a:extLst>
+          </p:cNvPr>
+          <p:cNvSpPr>
+            <a:spLocks noGrp="1" noRot="1" noChangeAspect="1"/>
+          </p:cNvSpPr>
+          <p:nvPr>
+            <p:ph type="sldImg"/>
+          </p:nvPr>
+        </p:nvSpPr>
+        <p:spPr/>
+        <p:txBody>
+          <a:bodyPr/>
+          <a:lstStyle/>
+          <a:p>
+            <a:endParaRPr lang="pt-BR"/>
+          </a:p>
+        </p:txBody>
+      </p:sp>
+      <p:sp>
+        <p:nvSpPr>
+          <p:cNvPr id="3" name="Espaço Reservado para Anotações 2">
+            <a:extLst>
+              <a:ext uri="{FF2B5EF4-FFF2-40B4-BE49-F238E27FC236}">
+                <a16:creationId xmlns:a16="http://schemas.microsoft.com/office/drawing/2014/main" id="{C96CCFEA-DA45-C9A2-0556-B9E7E4AB8538}"/>
+              </a:ext>
+            </a:extLst>
+          </p:cNvPr>
+          <p:cNvSpPr>
+            <a:spLocks noGrp="1"/>
+          </p:cNvSpPr>
+          <p:nvPr>
+            <p:ph type="body" idx="1"/>
+          </p:nvPr>
+        </p:nvSpPr>
+        <p:spPr/>
+        <p:txBody>
+          <a:bodyPr/>
+          <a:lstStyle/>
+          <a:p>
+            <a:endParaRPr lang="pt-BR" dirty="0"/>
+          </a:p>
+        </p:txBody>
+      </p:sp>
+      <p:sp>
+        <p:nvSpPr>
+          <p:cNvPr id="4" name="Espaço Reservado para Número de Slide 3">
+            <a:extLst>
+              <a:ext uri="{FF2B5EF4-FFF2-40B4-BE49-F238E27FC236}">
+                <a16:creationId xmlns:a16="http://schemas.microsoft.com/office/drawing/2014/main" id="{E739162D-B1B1-5317-5DE4-907C45386B25}"/>
+              </a:ext>
+            </a:extLst>
+          </p:cNvPr>
+          <p:cNvSpPr>
+            <a:spLocks noGrp="1"/>
+          </p:cNvSpPr>
+          <p:nvPr>
+            <p:ph type="sldNum" sz="quarter" idx="5"/>
+          </p:nvPr>
+        </p:nvSpPr>
+        <p:spPr/>
+        <p:txBody>
+          <a:bodyPr/>
+          <a:lstStyle/>
+          <a:p>
+            <a:fld id="{80F36A49-A1DD-40F8-B8AD-E6F5365256CB}" type="slidenum">
+              <a:rPr lang="pt-BR" smtClean="0"/>
+              <a:t>46</a:t>
+            </a:fld>
+            <a:endParaRPr lang="pt-BR"/>
+          </a:p>
+        </p:txBody>
+      </p:sp>
+    </p:spTree>
+    <p:extLst>
+      <p:ext uri="{BB962C8B-B14F-4D97-AF65-F5344CB8AC3E}">
+        <p14:creationId xmlns:p14="http://schemas.microsoft.com/office/powerpoint/2010/main" val="3714554999"/>
+      </p:ext>
+    </p:extLst>
+  </p:cSld>
+  <p:clrMapOvr>
+    <a:masterClrMapping/>
+  </p:clrMapOvr>
+</p:notes>
+</file>
+
+<file path=ppt/notesSlides/notesSlide47.xml><?xml version="1.0" encoding="utf-8"?>
+<p:notes xmlns:a="http://schemas.openxmlformats.org/drawingml/2006/main" xmlns:r="http://schemas.openxmlformats.org/officeDocument/2006/relationships" xmlns:p="http://schemas.openxmlformats.org/presentationml/2006/main">
+  <p:cSld>
+    <p:spTree>
+      <p:nvGrpSpPr>
+        <p:cNvPr id="1" name="">
+          <a:extLst>
+            <a:ext uri="{FF2B5EF4-FFF2-40B4-BE49-F238E27FC236}">
+              <a16:creationId xmlns:a16="http://schemas.microsoft.com/office/drawing/2014/main" id="{AAF74722-A35B-E998-54E4-CB81CA7E6C14}"/>
+            </a:ext>
+          </a:extLst>
+        </p:cNvPr>
+        <p:cNvGrpSpPr/>
+        <p:nvPr/>
+      </p:nvGrpSpPr>
+      <p:grpSpPr>
+        <a:xfrm>
+          <a:off x="0" y="0"/>
+          <a:ext cx="0" cy="0"/>
+          <a:chOff x="0" y="0"/>
+          <a:chExt cx="0" cy="0"/>
+        </a:xfrm>
+      </p:grpSpPr>
+      <p:sp>
+        <p:nvSpPr>
+          <p:cNvPr id="2" name="Espaço Reservado para Imagem de Slide 1">
+            <a:extLst>
+              <a:ext uri="{FF2B5EF4-FFF2-40B4-BE49-F238E27FC236}">
+                <a16:creationId xmlns:a16="http://schemas.microsoft.com/office/drawing/2014/main" id="{397A6050-CD4A-D551-5FB0-DF1927BCEA6C}"/>
+              </a:ext>
+            </a:extLst>
+          </p:cNvPr>
+          <p:cNvSpPr>
+            <a:spLocks noGrp="1" noRot="1" noChangeAspect="1"/>
+          </p:cNvSpPr>
+          <p:nvPr>
+            <p:ph type="sldImg"/>
+          </p:nvPr>
+        </p:nvSpPr>
+        <p:spPr/>
+        <p:txBody>
+          <a:bodyPr/>
+          <a:lstStyle/>
+          <a:p>
+            <a:endParaRPr lang="pt-BR"/>
+          </a:p>
+        </p:txBody>
+      </p:sp>
+      <p:sp>
+        <p:nvSpPr>
+          <p:cNvPr id="3" name="Espaço Reservado para Anotações 2">
+            <a:extLst>
+              <a:ext uri="{FF2B5EF4-FFF2-40B4-BE49-F238E27FC236}">
+                <a16:creationId xmlns:a16="http://schemas.microsoft.com/office/drawing/2014/main" id="{F9DFA74C-F51F-F5F4-55D9-8EFDE21C01AB}"/>
+              </a:ext>
+            </a:extLst>
+          </p:cNvPr>
+          <p:cNvSpPr>
+            <a:spLocks noGrp="1"/>
+          </p:cNvSpPr>
+          <p:nvPr>
+            <p:ph type="body" idx="1"/>
+          </p:nvPr>
+        </p:nvSpPr>
+        <p:spPr/>
+        <p:txBody>
+          <a:bodyPr/>
+          <a:lstStyle/>
+          <a:p>
+            <a:pPr marL="0" indent="0">
+              <a:buFontTx/>
+              <a:buNone/>
+            </a:pPr>
+            <a:endParaRPr lang="pt-BR" b="0" dirty="0"/>
+          </a:p>
+        </p:txBody>
+      </p:sp>
+      <p:sp>
+        <p:nvSpPr>
+          <p:cNvPr id="4" name="Espaço Reservado para Número de Slide 3">
+            <a:extLst>
+              <a:ext uri="{FF2B5EF4-FFF2-40B4-BE49-F238E27FC236}">
+                <a16:creationId xmlns:a16="http://schemas.microsoft.com/office/drawing/2014/main" id="{AA97C963-33A2-15C2-F4B4-C90A66889C68}"/>
+              </a:ext>
+            </a:extLst>
+          </p:cNvPr>
+          <p:cNvSpPr>
+            <a:spLocks noGrp="1"/>
+          </p:cNvSpPr>
+          <p:nvPr>
+            <p:ph type="sldNum" sz="quarter" idx="5"/>
+          </p:nvPr>
+        </p:nvSpPr>
+        <p:spPr/>
+        <p:txBody>
+          <a:bodyPr/>
+          <a:lstStyle/>
+          <a:p>
+            <a:fld id="{80F36A49-A1DD-40F8-B8AD-E6F5365256CB}" type="slidenum">
+              <a:rPr lang="pt-BR" smtClean="0"/>
+              <a:t>47</a:t>
+            </a:fld>
+            <a:endParaRPr lang="pt-BR"/>
+          </a:p>
+        </p:txBody>
+      </p:sp>
+    </p:spTree>
+    <p:extLst>
+      <p:ext uri="{BB962C8B-B14F-4D97-AF65-F5344CB8AC3E}">
+        <p14:creationId xmlns:p14="http://schemas.microsoft.com/office/powerpoint/2010/main" val="2204348867"/>
+      </p:ext>
+    </p:extLst>
+  </p:cSld>
+  <p:clrMapOvr>
+    <a:masterClrMapping/>
+  </p:clrMapOvr>
+</p:notes>
+</file>
+
+<file path=ppt/notesSlides/notesSlide48.xml><?xml version="1.0" encoding="utf-8"?>
+<p:notes xmlns:a="http://schemas.openxmlformats.org/drawingml/2006/main" xmlns:r="http://schemas.openxmlformats.org/officeDocument/2006/relationships" xmlns:p="http://schemas.openxmlformats.org/presentationml/2006/main">
+  <p:cSld>
+    <p:spTree>
+      <p:nvGrpSpPr>
+        <p:cNvPr id="1" name="">
+          <a:extLst>
+            <a:ext uri="{FF2B5EF4-FFF2-40B4-BE49-F238E27FC236}">
+              <a16:creationId xmlns:a16="http://schemas.microsoft.com/office/drawing/2014/main" id="{C1AC3E6D-254B-261D-4E37-F025B28D6246}"/>
+            </a:ext>
+          </a:extLst>
+        </p:cNvPr>
+        <p:cNvGrpSpPr/>
+        <p:nvPr/>
+      </p:nvGrpSpPr>
+      <p:grpSpPr>
+        <a:xfrm>
+          <a:off x="0" y="0"/>
+          <a:ext cx="0" cy="0"/>
+          <a:chOff x="0" y="0"/>
+          <a:chExt cx="0" cy="0"/>
+        </a:xfrm>
+      </p:grpSpPr>
+      <p:sp>
+        <p:nvSpPr>
+          <p:cNvPr id="2" name="Espaço Reservado para Imagem de Slide 1">
+            <a:extLst>
+              <a:ext uri="{FF2B5EF4-FFF2-40B4-BE49-F238E27FC236}">
+                <a16:creationId xmlns:a16="http://schemas.microsoft.com/office/drawing/2014/main" id="{DC0F3D6F-4A9D-D610-1A4B-E3F42AAA4FE1}"/>
+              </a:ext>
+            </a:extLst>
+          </p:cNvPr>
+          <p:cNvSpPr>
+            <a:spLocks noGrp="1" noRot="1" noChangeAspect="1"/>
+          </p:cNvSpPr>
+          <p:nvPr>
+            <p:ph type="sldImg"/>
+          </p:nvPr>
+        </p:nvSpPr>
+        <p:spPr/>
+        <p:txBody>
+          <a:bodyPr/>
+          <a:lstStyle/>
+          <a:p>
+            <a:endParaRPr lang="pt-BR"/>
+          </a:p>
+        </p:txBody>
+      </p:sp>
+      <p:sp>
+        <p:nvSpPr>
+          <p:cNvPr id="3" name="Espaço Reservado para Anotações 2">
+            <a:extLst>
+              <a:ext uri="{FF2B5EF4-FFF2-40B4-BE49-F238E27FC236}">
+                <a16:creationId xmlns:a16="http://schemas.microsoft.com/office/drawing/2014/main" id="{C2BF038D-647A-0CD9-30EE-062CF81E90E8}"/>
+              </a:ext>
+            </a:extLst>
+          </p:cNvPr>
+          <p:cNvSpPr>
+            <a:spLocks noGrp="1"/>
+          </p:cNvSpPr>
+          <p:nvPr>
+            <p:ph type="body" idx="1"/>
+          </p:nvPr>
+        </p:nvSpPr>
+        <p:spPr/>
+        <p:txBody>
+          <a:bodyPr/>
+          <a:lstStyle/>
+          <a:p>
+            <a:pPr marL="0" indent="0">
+              <a:buFontTx/>
+              <a:buNone/>
+            </a:pPr>
+            <a:endParaRPr lang="pt-BR" b="0" dirty="0"/>
+          </a:p>
+        </p:txBody>
+      </p:sp>
+      <p:sp>
+        <p:nvSpPr>
+          <p:cNvPr id="4" name="Espaço Reservado para Número de Slide 3">
+            <a:extLst>
+              <a:ext uri="{FF2B5EF4-FFF2-40B4-BE49-F238E27FC236}">
+                <a16:creationId xmlns:a16="http://schemas.microsoft.com/office/drawing/2014/main" id="{AC39DC4D-BCCC-0330-767E-C48A25B2E6F5}"/>
+              </a:ext>
+            </a:extLst>
+          </p:cNvPr>
+          <p:cNvSpPr>
+            <a:spLocks noGrp="1"/>
+          </p:cNvSpPr>
+          <p:nvPr>
+            <p:ph type="sldNum" sz="quarter" idx="5"/>
+          </p:nvPr>
+        </p:nvSpPr>
+        <p:spPr/>
+        <p:txBody>
+          <a:bodyPr/>
+          <a:lstStyle/>
+          <a:p>
+            <a:fld id="{80F36A49-A1DD-40F8-B8AD-E6F5365256CB}" type="slidenum">
+              <a:rPr lang="pt-BR" smtClean="0"/>
+              <a:t>48</a:t>
+            </a:fld>
+            <a:endParaRPr lang="pt-BR"/>
+          </a:p>
+        </p:txBody>
+      </p:sp>
+    </p:spTree>
+    <p:extLst>
+      <p:ext uri="{BB962C8B-B14F-4D97-AF65-F5344CB8AC3E}">
+        <p14:creationId xmlns:p14="http://schemas.microsoft.com/office/powerpoint/2010/main" val="1245065115"/>
+      </p:ext>
+    </p:extLst>
+  </p:cSld>
+  <p:clrMapOvr>
+    <a:masterClrMapping/>
+  </p:clrMapOvr>
+</p:notes>
+</file>
+
+<file path=ppt/notesSlides/notesSlide49.xml><?xml version="1.0" encoding="utf-8"?>
+<p:notes xmlns:a="http://schemas.openxmlformats.org/drawingml/2006/main" xmlns:r="http://schemas.openxmlformats.org/officeDocument/2006/relationships" xmlns:p="http://schemas.openxmlformats.org/presentationml/2006/main">
+  <p:cSld>
+    <p:spTree>
+      <p:nvGrpSpPr>
+        <p:cNvPr id="1" name="">
+          <a:extLst>
+            <a:ext uri="{FF2B5EF4-FFF2-40B4-BE49-F238E27FC236}">
+              <a16:creationId xmlns:a16="http://schemas.microsoft.com/office/drawing/2014/main" id="{A3C6CC6D-0F93-CA41-B711-1D0404B3FEB3}"/>
+            </a:ext>
+          </a:extLst>
+        </p:cNvPr>
+        <p:cNvGrpSpPr/>
+        <p:nvPr/>
+      </p:nvGrpSpPr>
+      <p:grpSpPr>
+        <a:xfrm>
+          <a:off x="0" y="0"/>
+          <a:ext cx="0" cy="0"/>
+          <a:chOff x="0" y="0"/>
+          <a:chExt cx="0" cy="0"/>
+        </a:xfrm>
+      </p:grpSpPr>
+      <p:sp>
+        <p:nvSpPr>
+          <p:cNvPr id="2" name="Espaço Reservado para Imagem de Slide 1">
+            <a:extLst>
+              <a:ext uri="{FF2B5EF4-FFF2-40B4-BE49-F238E27FC236}">
+                <a16:creationId xmlns:a16="http://schemas.microsoft.com/office/drawing/2014/main" id="{2106633D-1F54-8FAB-37ED-AA08C8A57042}"/>
+              </a:ext>
+            </a:extLst>
+          </p:cNvPr>
+          <p:cNvSpPr>
+            <a:spLocks noGrp="1" noRot="1" noChangeAspect="1"/>
+          </p:cNvSpPr>
+          <p:nvPr>
+            <p:ph type="sldImg"/>
+          </p:nvPr>
+        </p:nvSpPr>
+        <p:spPr/>
+        <p:txBody>
+          <a:bodyPr/>
+          <a:lstStyle/>
+          <a:p>
+            <a:endParaRPr lang="pt-BR"/>
+          </a:p>
+        </p:txBody>
+      </p:sp>
+      <p:sp>
+        <p:nvSpPr>
+          <p:cNvPr id="3" name="Espaço Reservado para Anotações 2">
+            <a:extLst>
+              <a:ext uri="{FF2B5EF4-FFF2-40B4-BE49-F238E27FC236}">
+                <a16:creationId xmlns:a16="http://schemas.microsoft.com/office/drawing/2014/main" id="{89181BB8-8B7B-16D8-D0DF-223F60DC3311}"/>
+              </a:ext>
+            </a:extLst>
+          </p:cNvPr>
+          <p:cNvSpPr>
+            <a:spLocks noGrp="1"/>
+          </p:cNvSpPr>
+          <p:nvPr>
+            <p:ph type="body" idx="1"/>
+          </p:nvPr>
+        </p:nvSpPr>
+        <p:spPr/>
+        <p:txBody>
+          <a:bodyPr/>
+          <a:lstStyle/>
+          <a:p>
+            <a:pPr marL="0" indent="0">
+              <a:buFontTx/>
+              <a:buNone/>
+            </a:pPr>
+            <a:endParaRPr lang="pt-BR" b="0" dirty="0"/>
+          </a:p>
+        </p:txBody>
+      </p:sp>
+      <p:sp>
+        <p:nvSpPr>
+          <p:cNvPr id="4" name="Espaço Reservado para Número de Slide 3">
+            <a:extLst>
+              <a:ext uri="{FF2B5EF4-FFF2-40B4-BE49-F238E27FC236}">
+                <a16:creationId xmlns:a16="http://schemas.microsoft.com/office/drawing/2014/main" id="{93357B66-B802-73F9-97C6-9409970A94B5}"/>
+              </a:ext>
+            </a:extLst>
+          </p:cNvPr>
+          <p:cNvSpPr>
+            <a:spLocks noGrp="1"/>
+          </p:cNvSpPr>
+          <p:nvPr>
+            <p:ph type="sldNum" sz="quarter" idx="5"/>
+          </p:nvPr>
+        </p:nvSpPr>
+        <p:spPr/>
+        <p:txBody>
+          <a:bodyPr/>
+          <a:lstStyle/>
+          <a:p>
+            <a:fld id="{80F36A49-A1DD-40F8-B8AD-E6F5365256CB}" type="slidenum">
+              <a:rPr lang="pt-BR" smtClean="0"/>
+              <a:t>49</a:t>
+            </a:fld>
+            <a:endParaRPr lang="pt-BR"/>
+          </a:p>
+        </p:txBody>
+      </p:sp>
+    </p:spTree>
+    <p:extLst>
+      <p:ext uri="{BB962C8B-B14F-4D97-AF65-F5344CB8AC3E}">
+        <p14:creationId xmlns:p14="http://schemas.microsoft.com/office/powerpoint/2010/main" val="872282824"/>
       </p:ext>
     </p:extLst>
   </p:cSld>
@@ -5039,6 +6130,13 @@
           </p:nvPr>
         </p:nvSpPr>
         <p:spPr/>
+        <p:txBody>
+          <a:bodyPr/>
+          <a:lstStyle/>
+          <a:p>
+            <a:endParaRPr lang="pt-BR"/>
+          </a:p>
+        </p:txBody>
       </p:sp>
       <p:sp>
         <p:nvSpPr>
@@ -5151,6 +6249,13 @@
           </p:nvPr>
         </p:nvSpPr>
         <p:spPr/>
+        <p:txBody>
+          <a:bodyPr/>
+          <a:lstStyle/>
+          <a:p>
+            <a:endParaRPr lang="pt-BR"/>
+          </a:p>
+        </p:txBody>
       </p:sp>
       <p:sp>
         <p:nvSpPr>
@@ -5263,6 +6368,13 @@
           </p:nvPr>
         </p:nvSpPr>
         <p:spPr/>
+        <p:txBody>
+          <a:bodyPr/>
+          <a:lstStyle/>
+          <a:p>
+            <a:endParaRPr lang="pt-BR"/>
+          </a:p>
+        </p:txBody>
       </p:sp>
       <p:sp>
         <p:nvSpPr>
@@ -5375,6 +6487,13 @@
           </p:nvPr>
         </p:nvSpPr>
         <p:spPr/>
+        <p:txBody>
+          <a:bodyPr/>
+          <a:lstStyle/>
+          <a:p>
+            <a:endParaRPr lang="pt-BR"/>
+          </a:p>
+        </p:txBody>
       </p:sp>
       <p:sp>
         <p:nvSpPr>
@@ -5522,6 +6641,13 @@
           </p:nvPr>
         </p:nvSpPr>
         <p:spPr/>
+        <p:txBody>
+          <a:bodyPr/>
+          <a:lstStyle/>
+          <a:p>
+            <a:endParaRPr lang="pt-BR"/>
+          </a:p>
+        </p:txBody>
       </p:sp>
       <p:sp>
         <p:nvSpPr>
@@ -5737,7 +6863,7 @@
           <a:p>
             <a:fld id="{A87E3B6E-8316-4A1C-BADA-DB7F3456EEF1}" type="datetimeFigureOut">
               <a:rPr lang="pt-BR" smtClean="0"/>
-              <a:t>11/08/2026</a:t>
+              <a:t>14/08/2026</a:t>
             </a:fld>
             <a:endParaRPr lang="pt-BR"/>
           </a:p>
@@ -5935,7 +7061,7 @@
           <a:p>
             <a:fld id="{A87E3B6E-8316-4A1C-BADA-DB7F3456EEF1}" type="datetimeFigureOut">
               <a:rPr lang="pt-BR" smtClean="0"/>
-              <a:t>11/08/2026</a:t>
+              <a:t>14/08/2026</a:t>
             </a:fld>
             <a:endParaRPr lang="pt-BR"/>
           </a:p>
@@ -6143,7 +7269,7 @@
           <a:p>
             <a:fld id="{A87E3B6E-8316-4A1C-BADA-DB7F3456EEF1}" type="datetimeFigureOut">
               <a:rPr lang="pt-BR" smtClean="0"/>
-              <a:t>11/08/2026</a:t>
+              <a:t>14/08/2026</a:t>
             </a:fld>
             <a:endParaRPr lang="pt-BR"/>
           </a:p>
@@ -6379,7 +7505,7 @@
           <a:p>
             <a:fld id="{A87E3B6E-8316-4A1C-BADA-DB7F3456EEF1}" type="datetimeFigureOut">
               <a:rPr lang="pt-BR" smtClean="0"/>
-              <a:t>11/08/2026</a:t>
+              <a:t>14/08/2026</a:t>
             </a:fld>
             <a:endParaRPr lang="pt-BR"/>
           </a:p>
@@ -6549,7 +7675,7 @@
           <a:p>
             <a:fld id="{A87E3B6E-8316-4A1C-BADA-DB7F3456EEF1}" type="datetimeFigureOut">
               <a:rPr lang="pt-BR" smtClean="0"/>
-              <a:t>11/08/2026</a:t>
+              <a:t>14/08/2026</a:t>
             </a:fld>
             <a:endParaRPr lang="pt-BR"/>
           </a:p>
@@ -6817,7 +7943,7 @@
           <a:p>
             <a:fld id="{A87E3B6E-8316-4A1C-BADA-DB7F3456EEF1}" type="datetimeFigureOut">
               <a:rPr lang="pt-BR" smtClean="0"/>
-              <a:t>11/08/2026</a:t>
+              <a:t>14/08/2026</a:t>
             </a:fld>
             <a:endParaRPr lang="pt-BR"/>
           </a:p>
@@ -7049,7 +8175,7 @@
           <a:p>
             <a:fld id="{A87E3B6E-8316-4A1C-BADA-DB7F3456EEF1}" type="datetimeFigureOut">
               <a:rPr lang="pt-BR" smtClean="0"/>
-              <a:t>11/08/2026</a:t>
+              <a:t>14/08/2026</a:t>
             </a:fld>
             <a:endParaRPr lang="pt-BR"/>
           </a:p>
@@ -7404,7 +8530,7 @@
           <a:p>
             <a:fld id="{A87E3B6E-8316-4A1C-BADA-DB7F3456EEF1}" type="datetimeFigureOut">
               <a:rPr lang="pt-BR" smtClean="0"/>
-              <a:t>11/08/2026</a:t>
+              <a:t>14/08/2026</a:t>
             </a:fld>
             <a:endParaRPr lang="pt-BR"/>
           </a:p>
@@ -7545,7 +8671,7 @@
           <a:p>
             <a:fld id="{A87E3B6E-8316-4A1C-BADA-DB7F3456EEF1}" type="datetimeFigureOut">
               <a:rPr lang="pt-BR" smtClean="0"/>
-              <a:t>11/08/2026</a:t>
+              <a:t>14/08/2026</a:t>
             </a:fld>
             <a:endParaRPr lang="pt-BR"/>
           </a:p>
@@ -7640,7 +8766,7 @@
           <a:p>
             <a:fld id="{A87E3B6E-8316-4A1C-BADA-DB7F3456EEF1}" type="datetimeFigureOut">
               <a:rPr lang="pt-BR" smtClean="0"/>
-              <a:t>11/08/2026</a:t>
+              <a:t>14/08/2026</a:t>
             </a:fld>
             <a:endParaRPr lang="pt-BR"/>
           </a:p>
@@ -7755,6 +8881,13 @@
             <a:schemeClr val="lt1"/>
           </a:fontRef>
         </p:style>
+        <p:txBody>
+          <a:bodyPr/>
+          <a:lstStyle/>
+          <a:p>
+            <a:endParaRPr lang="pt-BR"/>
+          </a:p>
+        </p:txBody>
       </p:sp>
       <p:sp>
         <p:nvSpPr>
@@ -7997,7 +9130,7 @@
           <a:p>
             <a:fld id="{A87E3B6E-8316-4A1C-BADA-DB7F3456EEF1}" type="datetimeFigureOut">
               <a:rPr lang="pt-BR" smtClean="0"/>
-              <a:t>11/08/2026</a:t>
+              <a:t>14/08/2026</a:t>
             </a:fld>
             <a:endParaRPr lang="pt-BR"/>
           </a:p>
@@ -8198,7 +9331,7 @@
           <a:p>
             <a:fld id="{A87E3B6E-8316-4A1C-BADA-DB7F3456EEF1}" type="datetimeFigureOut">
               <a:rPr lang="pt-BR" smtClean="0"/>
-              <a:t>11/08/2026</a:t>
+              <a:t>14/08/2026</a:t>
             </a:fld>
             <a:endParaRPr lang="pt-BR"/>
           </a:p>
@@ -8325,6 +9458,13 @@
             <a:schemeClr val="lt1"/>
           </a:fontRef>
         </p:style>
+        <p:txBody>
+          <a:bodyPr/>
+          <a:lstStyle/>
+          <a:p>
+            <a:endParaRPr lang="pt-BR"/>
+          </a:p>
+        </p:txBody>
       </p:sp>
       <p:sp>
         <p:nvSpPr>
@@ -8551,7 +9691,7 @@
           <a:p>
             <a:fld id="{A87E3B6E-8316-4A1C-BADA-DB7F3456EEF1}" type="datetimeFigureOut">
               <a:rPr lang="pt-BR" smtClean="0"/>
-              <a:t>11/08/2026</a:t>
+              <a:t>14/08/2026</a:t>
             </a:fld>
             <a:endParaRPr lang="pt-BR"/>
           </a:p>
@@ -8736,7 +9876,7 @@
           <a:p>
             <a:fld id="{A87E3B6E-8316-4A1C-BADA-DB7F3456EEF1}" type="datetimeFigureOut">
               <a:rPr lang="pt-BR" smtClean="0"/>
-              <a:t>11/08/2026</a:t>
+              <a:t>14/08/2026</a:t>
             </a:fld>
             <a:endParaRPr lang="pt-BR"/>
           </a:p>
@@ -8916,7 +10056,7 @@
           <a:p>
             <a:fld id="{A87E3B6E-8316-4A1C-BADA-DB7F3456EEF1}" type="datetimeFigureOut">
               <a:rPr lang="pt-BR" smtClean="0"/>
-              <a:t>11/08/2026</a:t>
+              <a:t>14/08/2026</a:t>
             </a:fld>
             <a:endParaRPr lang="pt-BR"/>
           </a:p>
@@ -9179,7 +10319,7 @@
           <a:p>
             <a:fld id="{A87E3B6E-8316-4A1C-BADA-DB7F3456EEF1}" type="datetimeFigureOut">
               <a:rPr lang="pt-BR" smtClean="0"/>
-              <a:t>11/08/2026</a:t>
+              <a:t>14/08/2026</a:t>
             </a:fld>
             <a:endParaRPr lang="pt-BR"/>
           </a:p>
@@ -9444,7 +10584,7 @@
           <a:p>
             <a:fld id="{A87E3B6E-8316-4A1C-BADA-DB7F3456EEF1}" type="datetimeFigureOut">
               <a:rPr lang="pt-BR" smtClean="0"/>
-              <a:t>11/08/2026</a:t>
+              <a:t>14/08/2026</a:t>
             </a:fld>
             <a:endParaRPr lang="pt-BR"/>
           </a:p>
@@ -9856,7 +10996,7 @@
           <a:p>
             <a:fld id="{A87E3B6E-8316-4A1C-BADA-DB7F3456EEF1}" type="datetimeFigureOut">
               <a:rPr lang="pt-BR" smtClean="0"/>
-              <a:t>11/08/2026</a:t>
+              <a:t>14/08/2026</a:t>
             </a:fld>
             <a:endParaRPr lang="pt-BR"/>
           </a:p>
@@ -9997,7 +11137,7 @@
           <a:p>
             <a:fld id="{A87E3B6E-8316-4A1C-BADA-DB7F3456EEF1}" type="datetimeFigureOut">
               <a:rPr lang="pt-BR" smtClean="0"/>
-              <a:t>11/08/2026</a:t>
+              <a:t>14/08/2026</a:t>
             </a:fld>
             <a:endParaRPr lang="pt-BR"/>
           </a:p>
@@ -10110,7 +11250,7 @@
           <a:p>
             <a:fld id="{A87E3B6E-8316-4A1C-BADA-DB7F3456EEF1}" type="datetimeFigureOut">
               <a:rPr lang="pt-BR" smtClean="0"/>
-              <a:t>11/08/2026</a:t>
+              <a:t>14/08/2026</a:t>
             </a:fld>
             <a:endParaRPr lang="pt-BR"/>
           </a:p>
@@ -10421,7 +11561,7 @@
           <a:p>
             <a:fld id="{A87E3B6E-8316-4A1C-BADA-DB7F3456EEF1}" type="datetimeFigureOut">
               <a:rPr lang="pt-BR" smtClean="0"/>
-              <a:t>11/08/2026</a:t>
+              <a:t>14/08/2026</a:t>
             </a:fld>
             <a:endParaRPr lang="pt-BR"/>
           </a:p>
@@ -10709,7 +11849,7 @@
           <a:p>
             <a:fld id="{A87E3B6E-8316-4A1C-BADA-DB7F3456EEF1}" type="datetimeFigureOut">
               <a:rPr lang="pt-BR" smtClean="0"/>
-              <a:t>11/08/2026</a:t>
+              <a:t>14/08/2026</a:t>
             </a:fld>
             <a:endParaRPr lang="pt-BR"/>
           </a:p>
@@ -10950,7 +12090,7 @@
           <a:p>
             <a:fld id="{A87E3B6E-8316-4A1C-BADA-DB7F3456EEF1}" type="datetimeFigureOut">
               <a:rPr lang="pt-BR" smtClean="0"/>
-              <a:t>11/08/2026</a:t>
+              <a:t>14/08/2026</a:t>
             </a:fld>
             <a:endParaRPr lang="pt-BR"/>
           </a:p>
@@ -11514,7 +12654,7 @@
           <a:p>
             <a:fld id="{A87E3B6E-8316-4A1C-BADA-DB7F3456EEF1}" type="datetimeFigureOut">
               <a:rPr lang="pt-BR" smtClean="0"/>
-              <a:t>11/08/2026</a:t>
+              <a:t>14/08/2026</a:t>
             </a:fld>
             <a:endParaRPr lang="pt-BR"/>
           </a:p>
@@ -26733,8 +27873,8 @@
           </a:p>
         </p:txBody>
       </p:sp>
-      <mc:AlternateContent xmlns:mc="http://schemas.openxmlformats.org/markup-compatibility/2006" xmlns:a14="http://schemas.microsoft.com/office/drawing/2010/main">
-        <mc:Choice Requires="a14">
+      <mc:AlternateContent xmlns:mc="http://schemas.openxmlformats.org/markup-compatibility/2006">
+        <mc:Choice xmlns:a14="http://schemas.microsoft.com/office/drawing/2010/main" Requires="a14">
           <p:sp>
             <p:nvSpPr>
               <p:cNvPr id="6" name="Espaço Reservado para Conteúdo 5">
@@ -26753,7 +27893,7 @@
             </p:nvSpPr>
             <p:spPr>
               <a:xfrm>
-                <a:off x="1946275" y="1703613"/>
+                <a:off x="678573" y="1962921"/>
                 <a:ext cx="4911724" cy="4480619"/>
               </a:xfrm>
             </p:spPr>
@@ -27202,7 +28342,7 @@
             </p:txBody>
           </p:sp>
         </mc:Choice>
-        <mc:Fallback xmlns="">
+        <mc:Fallback>
           <p:sp>
             <p:nvSpPr>
               <p:cNvPr id="6" name="Espaço Reservado para Conteúdo 5">
@@ -27221,7 +28361,7 @@
             </p:nvSpPr>
             <p:spPr>
               <a:xfrm>
-                <a:off x="1946275" y="1703613"/>
+                <a:off x="678573" y="1962921"/>
                 <a:ext cx="4911724" cy="4480619"/>
               </a:xfrm>
               <a:blipFill>
@@ -27246,570 +28386,315 @@
           </p:sp>
         </mc:Fallback>
       </mc:AlternateContent>
-      <mc:AlternateContent xmlns:mc="http://schemas.openxmlformats.org/markup-compatibility/2006" xmlns:a14="http://schemas.microsoft.com/office/drawing/2010/main">
-        <mc:Choice Requires="a14">
-          <p:sp>
-            <p:nvSpPr>
-              <p:cNvPr id="3" name="Espaço Reservado para Conteúdo 5">
-                <a:extLst>
-                  <a:ext uri="{FF2B5EF4-FFF2-40B4-BE49-F238E27FC236}">
-                    <a16:creationId xmlns:a16="http://schemas.microsoft.com/office/drawing/2014/main" id="{F816314F-90E0-3CB5-7E7D-FC0E8DB948C4}"/>
-                  </a:ext>
-                </a:extLst>
-              </p:cNvPr>
-              <p:cNvSpPr txBox="1">
-                <a:spLocks/>
-              </p:cNvSpPr>
-              <p:nvPr/>
-            </p:nvSpPr>
-            <p:spPr>
-              <a:xfrm>
-                <a:off x="7538619" y="2064560"/>
-                <a:ext cx="4162926" cy="3758724"/>
-              </a:xfrm>
-              <a:prstGeom prst="rect">
-                <a:avLst/>
-              </a:prstGeom>
-            </p:spPr>
-            <p:txBody>
-              <a:bodyPr vert="horz" lIns="91440" tIns="45720" rIns="91440" bIns="45720" rtlCol="0">
-                <a:normAutofit/>
-              </a:bodyPr>
-              <a:lstStyle>
-                <a:lvl1pPr marL="228600" indent="-228600" algn="l" defTabSz="914400" rtl="0" eaLnBrk="1" latinLnBrk="0" hangingPunct="1">
-                  <a:lnSpc>
-                    <a:spcPct val="90000"/>
-                  </a:lnSpc>
-                  <a:spcBef>
-                    <a:spcPts val="1000"/>
-                  </a:spcBef>
-                  <a:buFont typeface="Arial" panose="020B0604020202020204" pitchFamily="34" charset="0"/>
-                  <a:buChar char="•"/>
-                  <a:defRPr sz="2800" kern="1200">
-                    <a:solidFill>
-                      <a:schemeClr val="tx1"/>
-                    </a:solidFill>
-                    <a:latin typeface="+mn-lt"/>
-                    <a:ea typeface="+mn-ea"/>
-                    <a:cs typeface="+mn-cs"/>
-                  </a:defRPr>
-                </a:lvl1pPr>
-                <a:lvl2pPr marL="685800" indent="-228600" algn="l" defTabSz="914400" rtl="0" eaLnBrk="1" latinLnBrk="0" hangingPunct="1">
-                  <a:lnSpc>
-                    <a:spcPct val="90000"/>
-                  </a:lnSpc>
-                  <a:spcBef>
-                    <a:spcPts val="500"/>
-                  </a:spcBef>
-                  <a:buFont typeface="Arial" panose="020B0604020202020204" pitchFamily="34" charset="0"/>
-                  <a:buChar char="•"/>
-                  <a:defRPr sz="2400" kern="1200">
-                    <a:solidFill>
-                      <a:schemeClr val="tx1"/>
-                    </a:solidFill>
-                    <a:latin typeface="+mn-lt"/>
-                    <a:ea typeface="+mn-ea"/>
-                    <a:cs typeface="+mn-cs"/>
-                  </a:defRPr>
-                </a:lvl2pPr>
-                <a:lvl3pPr marL="1143000" indent="-228600" algn="l" defTabSz="914400" rtl="0" eaLnBrk="1" latinLnBrk="0" hangingPunct="1">
-                  <a:lnSpc>
-                    <a:spcPct val="90000"/>
-                  </a:lnSpc>
-                  <a:spcBef>
-                    <a:spcPts val="500"/>
-                  </a:spcBef>
-                  <a:buFont typeface="Arial" panose="020B0604020202020204" pitchFamily="34" charset="0"/>
-                  <a:buChar char="•"/>
-                  <a:defRPr sz="2000" kern="1200">
-                    <a:solidFill>
-                      <a:schemeClr val="tx1"/>
-                    </a:solidFill>
-                    <a:latin typeface="+mn-lt"/>
-                    <a:ea typeface="+mn-ea"/>
-                    <a:cs typeface="+mn-cs"/>
-                  </a:defRPr>
-                </a:lvl3pPr>
-                <a:lvl4pPr marL="1600200" indent="-228600" algn="l" defTabSz="914400" rtl="0" eaLnBrk="1" latinLnBrk="0" hangingPunct="1">
-                  <a:lnSpc>
-                    <a:spcPct val="90000"/>
-                  </a:lnSpc>
-                  <a:spcBef>
-                    <a:spcPts val="500"/>
-                  </a:spcBef>
-                  <a:buFont typeface="Arial" panose="020B0604020202020204" pitchFamily="34" charset="0"/>
-                  <a:buChar char="•"/>
-                  <a:defRPr sz="1800" kern="1200">
-                    <a:solidFill>
-                      <a:schemeClr val="tx1"/>
-                    </a:solidFill>
-                    <a:latin typeface="+mn-lt"/>
-                    <a:ea typeface="+mn-ea"/>
-                    <a:cs typeface="+mn-cs"/>
-                  </a:defRPr>
-                </a:lvl4pPr>
-                <a:lvl5pPr marL="2057400" indent="-228600" algn="l" defTabSz="914400" rtl="0" eaLnBrk="1" latinLnBrk="0" hangingPunct="1">
-                  <a:lnSpc>
-                    <a:spcPct val="90000"/>
-                  </a:lnSpc>
-                  <a:spcBef>
-                    <a:spcPts val="500"/>
-                  </a:spcBef>
-                  <a:buFont typeface="Arial" panose="020B0604020202020204" pitchFamily="34" charset="0"/>
-                  <a:buChar char="•"/>
-                  <a:defRPr sz="1800" kern="1200">
-                    <a:solidFill>
-                      <a:schemeClr val="tx1"/>
-                    </a:solidFill>
-                    <a:latin typeface="+mn-lt"/>
-                    <a:ea typeface="+mn-ea"/>
-                    <a:cs typeface="+mn-cs"/>
-                  </a:defRPr>
-                </a:lvl5pPr>
-                <a:lvl6pPr marL="2514600" indent="-228600" algn="l" defTabSz="914400" rtl="0" eaLnBrk="1" latinLnBrk="0" hangingPunct="1">
-                  <a:lnSpc>
-                    <a:spcPct val="90000"/>
-                  </a:lnSpc>
-                  <a:spcBef>
-                    <a:spcPts val="500"/>
-                  </a:spcBef>
-                  <a:buFont typeface="Arial" panose="020B0604020202020204" pitchFamily="34" charset="0"/>
-                  <a:buChar char="•"/>
-                  <a:defRPr sz="1800" kern="1200">
-                    <a:solidFill>
-                      <a:schemeClr val="tx1"/>
-                    </a:solidFill>
-                    <a:latin typeface="+mn-lt"/>
-                    <a:ea typeface="+mn-ea"/>
-                    <a:cs typeface="+mn-cs"/>
-                  </a:defRPr>
-                </a:lvl6pPr>
-                <a:lvl7pPr marL="2971800" indent="-228600" algn="l" defTabSz="914400" rtl="0" eaLnBrk="1" latinLnBrk="0" hangingPunct="1">
-                  <a:lnSpc>
-                    <a:spcPct val="90000"/>
-                  </a:lnSpc>
-                  <a:spcBef>
-                    <a:spcPts val="500"/>
-                  </a:spcBef>
-                  <a:buFont typeface="Arial" panose="020B0604020202020204" pitchFamily="34" charset="0"/>
-                  <a:buChar char="•"/>
-                  <a:defRPr sz="1800" kern="1200">
-                    <a:solidFill>
-                      <a:schemeClr val="tx1"/>
-                    </a:solidFill>
-                    <a:latin typeface="+mn-lt"/>
-                    <a:ea typeface="+mn-ea"/>
-                    <a:cs typeface="+mn-cs"/>
-                  </a:defRPr>
-                </a:lvl7pPr>
-                <a:lvl8pPr marL="3429000" indent="-228600" algn="l" defTabSz="914400" rtl="0" eaLnBrk="1" latinLnBrk="0" hangingPunct="1">
-                  <a:lnSpc>
-                    <a:spcPct val="90000"/>
-                  </a:lnSpc>
-                  <a:spcBef>
-                    <a:spcPts val="500"/>
-                  </a:spcBef>
-                  <a:buFont typeface="Arial" panose="020B0604020202020204" pitchFamily="34" charset="0"/>
-                  <a:buChar char="•"/>
-                  <a:defRPr sz="1800" kern="1200">
-                    <a:solidFill>
-                      <a:schemeClr val="tx1"/>
-                    </a:solidFill>
-                    <a:latin typeface="+mn-lt"/>
-                    <a:ea typeface="+mn-ea"/>
-                    <a:cs typeface="+mn-cs"/>
-                  </a:defRPr>
-                </a:lvl8pPr>
-                <a:lvl9pPr marL="3886200" indent="-228600" algn="l" defTabSz="914400" rtl="0" eaLnBrk="1" latinLnBrk="0" hangingPunct="1">
-                  <a:lnSpc>
-                    <a:spcPct val="90000"/>
-                  </a:lnSpc>
-                  <a:spcBef>
-                    <a:spcPts val="500"/>
-                  </a:spcBef>
-                  <a:buFont typeface="Arial" panose="020B0604020202020204" pitchFamily="34" charset="0"/>
-                  <a:buChar char="•"/>
-                  <a:defRPr sz="1800" kern="1200">
-                    <a:solidFill>
-                      <a:schemeClr val="tx1"/>
-                    </a:solidFill>
-                    <a:latin typeface="+mn-lt"/>
-                    <a:ea typeface="+mn-ea"/>
-                    <a:cs typeface="+mn-cs"/>
-                  </a:defRPr>
-                </a:lvl9pPr>
-              </a:lstStyle>
-              <a:p>
-                <a:pPr algn="just"/>
-                <a14:m>
-                  <m:oMath xmlns:m="http://schemas.openxmlformats.org/officeDocument/2006/math">
-                    <m:r>
-                      <a:rPr lang="pt-BR" sz="2400" b="0" i="1" smtClean="0">
-                        <a:latin typeface="Cambria Math" panose="02040503050406030204" pitchFamily="18" charset="0"/>
-                      </a:rPr>
-                      <m:t>𝑃</m:t>
-                    </m:r>
-                    <m:r>
-                      <a:rPr lang="pt-BR" sz="2400" b="0" i="1" smtClean="0">
-                        <a:latin typeface="Cambria Math" panose="02040503050406030204" pitchFamily="18" charset="0"/>
-                      </a:rPr>
-                      <m:t>∨0</m:t>
-                    </m:r>
-                  </m:oMath>
-                </a14:m>
-                <a:r>
-                  <a:rPr lang="pt-BR" sz="2400" dirty="0"/>
-                  <a:t> </a:t>
-                </a:r>
-                <a:r>
-                  <a:rPr lang="pt-BR" sz="2400" dirty="0">
-                    <a:sym typeface="Wingdings" panose="05000000000000000000" pitchFamily="2" charset="2"/>
-                  </a:rPr>
-                  <a:t> </a:t>
-                </a:r>
-                <a14:m>
-                  <m:oMath xmlns:m="http://schemas.openxmlformats.org/officeDocument/2006/math">
-                    <m:r>
-                      <a:rPr lang="pt-BR" sz="2400" b="0" i="1">
-                        <a:latin typeface="Cambria Math" panose="02040503050406030204" pitchFamily="18" charset="0"/>
-                      </a:rPr>
-                      <m:t>𝑃</m:t>
-                    </m:r>
-                  </m:oMath>
-                </a14:m>
-                <a:endParaRPr lang="pt-BR" sz="2400" dirty="0"/>
-              </a:p>
-              <a:p>
-                <a:pPr algn="just"/>
-                <a14:m>
-                  <m:oMath xmlns:m="http://schemas.openxmlformats.org/officeDocument/2006/math">
-                    <m:r>
-                      <a:rPr lang="pt-BR" sz="2400" b="0" i="1">
-                        <a:latin typeface="Cambria Math" panose="02040503050406030204" pitchFamily="18" charset="0"/>
-                      </a:rPr>
-                      <m:t>𝑃</m:t>
-                    </m:r>
-                    <m:r>
-                      <a:rPr lang="pt-BR" sz="2400" b="0" i="1">
-                        <a:latin typeface="Cambria Math" panose="02040503050406030204" pitchFamily="18" charset="0"/>
-                      </a:rPr>
-                      <m:t>∨1</m:t>
-                    </m:r>
-                  </m:oMath>
-                </a14:m>
-                <a:r>
-                  <a:rPr lang="pt-BR" sz="2400" dirty="0"/>
-                  <a:t> </a:t>
-                </a:r>
-                <a:r>
-                  <a:rPr lang="pt-BR" sz="2400" dirty="0">
-                    <a:sym typeface="Wingdings" panose="05000000000000000000" pitchFamily="2" charset="2"/>
-                  </a:rPr>
-                  <a:t> </a:t>
-                </a:r>
-                <a14:m>
-                  <m:oMath xmlns:m="http://schemas.openxmlformats.org/officeDocument/2006/math">
-                    <m:r>
-                      <a:rPr lang="pt-BR" sz="2400" b="0" i="1">
-                        <a:latin typeface="Cambria Math" panose="02040503050406030204" pitchFamily="18" charset="0"/>
-                      </a:rPr>
-                      <m:t>1</m:t>
-                    </m:r>
-                  </m:oMath>
-                </a14:m>
-                <a:endParaRPr lang="pt-BR" sz="2400" dirty="0"/>
-              </a:p>
-              <a:p>
-                <a:pPr algn="just"/>
-                <a:endParaRPr lang="pt-BR" sz="2400" i="1" dirty="0">
-                  <a:latin typeface="Cambria Math" panose="02040503050406030204" pitchFamily="18" charset="0"/>
-                </a:endParaRPr>
-              </a:p>
-              <a:p>
-                <a:pPr algn="just"/>
-                <a14:m>
-                  <m:oMath xmlns:m="http://schemas.openxmlformats.org/officeDocument/2006/math">
-                    <m:r>
-                      <a:rPr lang="pt-BR" sz="2400" b="0" i="1">
-                        <a:latin typeface="Cambria Math" panose="02040503050406030204" pitchFamily="18" charset="0"/>
-                      </a:rPr>
-                      <m:t>𝑃</m:t>
-                    </m:r>
-                    <m:r>
-                      <a:rPr lang="pt-BR" sz="2400" b="0" i="1">
-                        <a:latin typeface="Cambria Math" panose="02040503050406030204" pitchFamily="18" charset="0"/>
-                      </a:rPr>
-                      <m:t>∧0</m:t>
-                    </m:r>
-                  </m:oMath>
-                </a14:m>
-                <a:r>
-                  <a:rPr lang="pt-BR" sz="2400" dirty="0"/>
-                  <a:t> </a:t>
-                </a:r>
-                <a:r>
-                  <a:rPr lang="pt-BR" sz="2400" dirty="0">
-                    <a:sym typeface="Wingdings" panose="05000000000000000000" pitchFamily="2" charset="2"/>
-                  </a:rPr>
-                  <a:t> </a:t>
-                </a:r>
-                <a14:m>
-                  <m:oMath xmlns:m="http://schemas.openxmlformats.org/officeDocument/2006/math">
-                    <m:r>
-                      <a:rPr lang="pt-BR" sz="2400" b="0" i="1" smtClean="0">
-                        <a:latin typeface="Cambria Math" panose="02040503050406030204" pitchFamily="18" charset="0"/>
-                        <a:sym typeface="Wingdings" panose="05000000000000000000" pitchFamily="2" charset="2"/>
-                      </a:rPr>
-                      <m:t>0</m:t>
-                    </m:r>
-                  </m:oMath>
-                </a14:m>
-                <a:endParaRPr lang="pt-BR" sz="2400" dirty="0"/>
-              </a:p>
-              <a:p>
-                <a:pPr algn="just"/>
-                <a14:m>
-                  <m:oMath xmlns:m="http://schemas.openxmlformats.org/officeDocument/2006/math">
-                    <m:r>
-                      <a:rPr lang="pt-BR" sz="2400" b="0" i="1">
-                        <a:latin typeface="Cambria Math" panose="02040503050406030204" pitchFamily="18" charset="0"/>
-                      </a:rPr>
-                      <m:t>𝑃</m:t>
-                    </m:r>
-                    <m:r>
-                      <a:rPr lang="pt-BR" sz="2400" b="0" i="1">
-                        <a:latin typeface="Cambria Math" panose="02040503050406030204" pitchFamily="18" charset="0"/>
-                      </a:rPr>
-                      <m:t>∧1</m:t>
-                    </m:r>
-                  </m:oMath>
-                </a14:m>
-                <a:r>
-                  <a:rPr lang="pt-BR" sz="2400" dirty="0"/>
-                  <a:t> </a:t>
-                </a:r>
-                <a:r>
-                  <a:rPr lang="pt-BR" sz="2400" dirty="0">
-                    <a:sym typeface="Wingdings" panose="05000000000000000000" pitchFamily="2" charset="2"/>
-                  </a:rPr>
-                  <a:t> </a:t>
-                </a:r>
-                <a14:m>
-                  <m:oMath xmlns:m="http://schemas.openxmlformats.org/officeDocument/2006/math">
-                    <m:r>
-                      <a:rPr lang="pt-BR" sz="2400" b="0" i="1">
-                        <a:latin typeface="Cambria Math" panose="02040503050406030204" pitchFamily="18" charset="0"/>
-                      </a:rPr>
-                      <m:t>𝑃</m:t>
-                    </m:r>
-                  </m:oMath>
-                </a14:m>
-                <a:endParaRPr lang="pt-BR" sz="2400" dirty="0">
-                  <a:sym typeface="Wingdings" panose="05000000000000000000" pitchFamily="2" charset="2"/>
-                </a:endParaRPr>
-              </a:p>
-              <a:p>
-                <a:pPr algn="just"/>
-                <a:endParaRPr lang="pt-BR" sz="2400" i="1" dirty="0">
-                  <a:latin typeface="Cambria Math" panose="02040503050406030204" pitchFamily="18" charset="0"/>
-                </a:endParaRPr>
-              </a:p>
-              <a:p>
-                <a:pPr algn="just"/>
-                <a14:m>
-                  <m:oMath xmlns:m="http://schemas.openxmlformats.org/officeDocument/2006/math">
-                    <m:r>
-                      <a:rPr lang="pt-BR" sz="2400" b="0" i="1">
-                        <a:latin typeface="Cambria Math" panose="02040503050406030204" pitchFamily="18" charset="0"/>
-                      </a:rPr>
-                      <m:t>𝑃</m:t>
-                    </m:r>
-                    <m:r>
-                      <a:rPr lang="pt-BR" sz="2400" b="0" i="1">
-                        <a:latin typeface="Cambria Math" panose="02040503050406030204" pitchFamily="18" charset="0"/>
-                      </a:rPr>
-                      <m:t>∧</m:t>
-                    </m:r>
-                    <m:r>
-                      <a:rPr lang="pt-BR" sz="2400" b="0">
-                        <a:latin typeface="Cambria Math" panose="02040503050406030204" pitchFamily="18" charset="0"/>
-                      </a:rPr>
-                      <m:t>¬</m:t>
-                    </m:r>
-                    <m:r>
-                      <m:rPr>
-                        <m:sty m:val="p"/>
-                      </m:rPr>
-                      <a:rPr lang="pt-BR" sz="2400" b="0" i="1">
-                        <a:latin typeface="Cambria Math" panose="02040503050406030204" pitchFamily="18" charset="0"/>
-                      </a:rPr>
-                      <m:t>P</m:t>
-                    </m:r>
-                  </m:oMath>
-                </a14:m>
-                <a:r>
-                  <a:rPr lang="pt-BR" sz="2400" dirty="0"/>
-                  <a:t> </a:t>
-                </a:r>
-                <a:r>
-                  <a:rPr lang="pt-BR" sz="2400" dirty="0">
-                    <a:sym typeface="Wingdings" panose="05000000000000000000" pitchFamily="2" charset="2"/>
-                  </a:rPr>
-                  <a:t> </a:t>
-                </a:r>
-                <a14:m>
-                  <m:oMath xmlns:m="http://schemas.openxmlformats.org/officeDocument/2006/math">
-                    <m:r>
-                      <a:rPr lang="pt-BR" sz="2400" b="0" i="1">
-                        <a:latin typeface="Cambria Math" panose="02040503050406030204" pitchFamily="18" charset="0"/>
-                        <a:sym typeface="Wingdings" panose="05000000000000000000" pitchFamily="2" charset="2"/>
-                      </a:rPr>
-                      <m:t>0</m:t>
-                    </m:r>
-                  </m:oMath>
-                </a14:m>
-                <a:r>
-                  <a:rPr lang="pt-BR" sz="2400" dirty="0">
-                    <a:sym typeface="Wingdings" panose="05000000000000000000" pitchFamily="2" charset="2"/>
-                  </a:rPr>
-                  <a:t> </a:t>
-                </a:r>
-                <a:endParaRPr lang="pt-BR" sz="2400" dirty="0"/>
-              </a:p>
-              <a:p>
-                <a:pPr algn="just"/>
-                <a14:m>
-                  <m:oMath xmlns:m="http://schemas.openxmlformats.org/officeDocument/2006/math">
-                    <m:r>
-                      <a:rPr lang="pt-BR" sz="2400" b="0" i="1">
-                        <a:latin typeface="Cambria Math" panose="02040503050406030204" pitchFamily="18" charset="0"/>
-                      </a:rPr>
-                      <m:t>𝑃</m:t>
-                    </m:r>
-                    <m:r>
-                      <a:rPr lang="pt-BR" sz="2400" b="0" i="1">
-                        <a:latin typeface="Cambria Math" panose="02040503050406030204" pitchFamily="18" charset="0"/>
-                      </a:rPr>
-                      <m:t>∨</m:t>
-                    </m:r>
-                    <m:r>
-                      <a:rPr lang="pt-BR" sz="2400" b="0">
-                        <a:latin typeface="Cambria Math" panose="02040503050406030204" pitchFamily="18" charset="0"/>
-                      </a:rPr>
-                      <m:t>¬</m:t>
-                    </m:r>
-                    <m:r>
-                      <m:rPr>
-                        <m:sty m:val="p"/>
-                      </m:rPr>
-                      <a:rPr lang="pt-BR" sz="2400" b="0" i="1">
-                        <a:latin typeface="Cambria Math" panose="02040503050406030204" pitchFamily="18" charset="0"/>
-                      </a:rPr>
-                      <m:t>P</m:t>
-                    </m:r>
-                  </m:oMath>
-                </a14:m>
-                <a:r>
-                  <a:rPr lang="pt-BR" sz="2400" dirty="0"/>
-                  <a:t> </a:t>
-                </a:r>
-                <a:r>
-                  <a:rPr lang="pt-BR" sz="2400" dirty="0">
-                    <a:sym typeface="Wingdings" panose="05000000000000000000" pitchFamily="2" charset="2"/>
-                  </a:rPr>
-                  <a:t> </a:t>
-                </a:r>
-                <a14:m>
-                  <m:oMath xmlns:m="http://schemas.openxmlformats.org/officeDocument/2006/math">
-                    <m:r>
-                      <a:rPr lang="pt-BR" sz="2400" b="0" i="1">
-                        <a:latin typeface="Cambria Math" panose="02040503050406030204" pitchFamily="18" charset="0"/>
-                      </a:rPr>
-                      <m:t>1</m:t>
-                    </m:r>
-                  </m:oMath>
-                </a14:m>
-                <a:endParaRPr lang="pt-BR" sz="2400" dirty="0"/>
-              </a:p>
-              <a:p>
-                <a:pPr algn="just"/>
-                <a:endParaRPr lang="pt-BR" sz="2200" dirty="0"/>
-              </a:p>
-              <a:p>
-                <a:pPr lvl="1" algn="just"/>
-                <a:endParaRPr lang="pt-BR" sz="2000" dirty="0"/>
-              </a:p>
-              <a:p>
-                <a:pPr marL="914400" lvl="1" indent="-457200" algn="just">
-                  <a:buFont typeface="+mj-lt"/>
-                  <a:buAutoNum type="arabicPeriod"/>
-                </a:pPr>
-                <a:endParaRPr lang="pt-BR" b="1" i="1" dirty="0">
-                  <a:latin typeface="Cambria Math" panose="02040503050406030204" pitchFamily="18" charset="0"/>
-                </a:endParaRPr>
-              </a:p>
-              <a:p>
-                <a:pPr marL="457200" lvl="1" indent="0" algn="just">
-                  <a:buFont typeface="Arial" panose="020B0604020202020204" pitchFamily="34" charset="0"/>
-                  <a:buNone/>
-                </a:pPr>
-                <a:endParaRPr lang="pt-BR" b="1" dirty="0"/>
-              </a:p>
-              <a:p>
-                <a:pPr marL="457200" lvl="1" indent="0" algn="just">
-                  <a:buFont typeface="Arial" panose="020B0604020202020204" pitchFamily="34" charset="0"/>
-                  <a:buNone/>
-                </a:pPr>
-                <a:endParaRPr lang="pt-BR" b="1" dirty="0"/>
-              </a:p>
-            </p:txBody>
-          </p:sp>
-        </mc:Choice>
-        <mc:Fallback xmlns="">
-          <p:sp>
-            <p:nvSpPr>
-              <p:cNvPr id="3" name="Espaço Reservado para Conteúdo 5">
-                <a:extLst>
-                  <a:ext uri="{FF2B5EF4-FFF2-40B4-BE49-F238E27FC236}">
-                    <a16:creationId xmlns:a16="http://schemas.microsoft.com/office/drawing/2014/main" id="{F816314F-90E0-3CB5-7E7D-FC0E8DB948C4}"/>
-                  </a:ext>
-                </a:extLst>
-              </p:cNvPr>
-              <p:cNvSpPr txBox="1">
-                <a:spLocks noRot="1" noChangeAspect="1" noMove="1" noResize="1" noEditPoints="1" noAdjustHandles="1" noChangeArrowheads="1" noChangeShapeType="1" noTextEdit="1"/>
-              </p:cNvSpPr>
-              <p:nvPr/>
-            </p:nvSpPr>
-            <p:spPr>
-              <a:xfrm>
-                <a:off x="7538619" y="2064560"/>
-                <a:ext cx="4162926" cy="3758724"/>
-              </a:xfrm>
-              <a:prstGeom prst="rect">
-                <a:avLst/>
-              </a:prstGeom>
-              <a:blipFill>
-                <a:blip r:embed="rId4"/>
-                <a:stretch>
-                  <a:fillRect l="-2050" t="-2435"/>
-                </a:stretch>
-              </a:blipFill>
-            </p:spPr>
-            <p:txBody>
-              <a:bodyPr/>
-              <a:lstStyle/>
-              <a:p>
-                <a:r>
-                  <a:rPr lang="pt-BR">
-                    <a:noFill/>
-                  </a:rPr>
-                  <a:t> </a:t>
-                </a:r>
-              </a:p>
-            </p:txBody>
-          </p:sp>
-        </mc:Fallback>
-      </mc:AlternateContent>
+      <p:pic>
+        <p:nvPicPr>
+          <p:cNvPr id="8" name="Imagem 7">
+            <a:extLst>
+              <a:ext uri="{FF2B5EF4-FFF2-40B4-BE49-F238E27FC236}">
+                <a16:creationId xmlns:a16="http://schemas.microsoft.com/office/drawing/2014/main" id="{1A6C2CA2-410E-9D1C-58C2-D6FA4EF02FD3}"/>
+              </a:ext>
+            </a:extLst>
+          </p:cNvPr>
+          <p:cNvPicPr>
+            <a:picLocks noChangeAspect="1"/>
+          </p:cNvPicPr>
+          <p:nvPr/>
+        </p:nvPicPr>
+        <p:blipFill>
+          <a:blip r:embed="rId4"/>
+          <a:stretch>
+            <a:fillRect/>
+          </a:stretch>
+        </p:blipFill>
+        <p:spPr>
+          <a:xfrm>
+            <a:off x="6096000" y="1545666"/>
+            <a:ext cx="5011026" cy="822706"/>
+          </a:xfrm>
+          <a:prstGeom prst="rect">
+            <a:avLst/>
+          </a:prstGeom>
+        </p:spPr>
+      </p:pic>
+      <p:pic>
+        <p:nvPicPr>
+          <p:cNvPr id="10" name="Imagem 9">
+            <a:extLst>
+              <a:ext uri="{FF2B5EF4-FFF2-40B4-BE49-F238E27FC236}">
+                <a16:creationId xmlns:a16="http://schemas.microsoft.com/office/drawing/2014/main" id="{33D4AF6E-1127-DDFF-3300-8EFF1113AE56}"/>
+              </a:ext>
+            </a:extLst>
+          </p:cNvPr>
+          <p:cNvPicPr>
+            <a:picLocks noChangeAspect="1"/>
+          </p:cNvPicPr>
+          <p:nvPr/>
+        </p:nvPicPr>
+        <p:blipFill>
+          <a:blip r:embed="rId5"/>
+          <a:stretch>
+            <a:fillRect/>
+          </a:stretch>
+        </p:blipFill>
+        <p:spPr>
+          <a:xfrm>
+            <a:off x="6096000" y="2411419"/>
+            <a:ext cx="5011026" cy="886908"/>
+          </a:xfrm>
+          <a:prstGeom prst="rect">
+            <a:avLst/>
+          </a:prstGeom>
+        </p:spPr>
+      </p:pic>
+      <p:pic>
+        <p:nvPicPr>
+          <p:cNvPr id="12" name="Imagem 11">
+            <a:extLst>
+              <a:ext uri="{FF2B5EF4-FFF2-40B4-BE49-F238E27FC236}">
+                <a16:creationId xmlns:a16="http://schemas.microsoft.com/office/drawing/2014/main" id="{FA298A5E-AC2D-2761-8034-9D8F3B782EC4}"/>
+              </a:ext>
+            </a:extLst>
+          </p:cNvPr>
+          <p:cNvPicPr>
+            <a:picLocks noChangeAspect="1"/>
+          </p:cNvPicPr>
+          <p:nvPr/>
+        </p:nvPicPr>
+        <p:blipFill>
+          <a:blip r:embed="rId6"/>
+          <a:stretch>
+            <a:fillRect/>
+          </a:stretch>
+        </p:blipFill>
+        <p:spPr>
+          <a:xfrm>
+            <a:off x="4924425" y="5472868"/>
+            <a:ext cx="7089961" cy="1138930"/>
+          </a:xfrm>
+          <a:prstGeom prst="rect">
+            <a:avLst/>
+          </a:prstGeom>
+        </p:spPr>
+      </p:pic>
+      <p:pic>
+        <p:nvPicPr>
+          <p:cNvPr id="14" name="Imagem 13">
+            <a:extLst>
+              <a:ext uri="{FF2B5EF4-FFF2-40B4-BE49-F238E27FC236}">
+                <a16:creationId xmlns:a16="http://schemas.microsoft.com/office/drawing/2014/main" id="{855A01C9-91A1-DD56-5649-0C31130CDB34}"/>
+              </a:ext>
+            </a:extLst>
+          </p:cNvPr>
+          <p:cNvPicPr>
+            <a:picLocks noChangeAspect="1"/>
+          </p:cNvPicPr>
+          <p:nvPr/>
+        </p:nvPicPr>
+        <p:blipFill>
+          <a:blip r:embed="rId7"/>
+          <a:stretch>
+            <a:fillRect/>
+          </a:stretch>
+        </p:blipFill>
+        <p:spPr>
+          <a:xfrm>
+            <a:off x="4993481" y="4057243"/>
+            <a:ext cx="7020906" cy="1255091"/>
+          </a:xfrm>
+          <a:prstGeom prst="rect">
+            <a:avLst/>
+          </a:prstGeom>
+        </p:spPr>
+      </p:pic>
+      <p:pic>
+        <p:nvPicPr>
+          <p:cNvPr id="15" name="Imagem 14">
+            <a:extLst>
+              <a:ext uri="{FF2B5EF4-FFF2-40B4-BE49-F238E27FC236}">
+                <a16:creationId xmlns:a16="http://schemas.microsoft.com/office/drawing/2014/main" id="{19367E0F-02EF-8221-82C6-782C5FEB06BF}"/>
+              </a:ext>
+            </a:extLst>
+          </p:cNvPr>
+          <p:cNvPicPr>
+            <a:picLocks noChangeAspect="1"/>
+          </p:cNvPicPr>
+          <p:nvPr/>
+        </p:nvPicPr>
+        <p:blipFill>
+          <a:blip r:embed="rId8">
+            <a:extLst>
+              <a:ext uri="{BEBA8EAE-BF5A-486C-A8C5-ECC9F3942E4B}">
+                <a14:imgProps xmlns:a14="http://schemas.microsoft.com/office/drawing/2010/main">
+                  <a14:imgLayer r:embed="rId9">
+                    <a14:imgEffect>
+                      <a14:backgroundRemoval t="10000" b="90000" l="10000" r="90000"/>
+                    </a14:imgEffect>
+                  </a14:imgLayer>
+                </a14:imgProps>
+              </a:ext>
+            </a:extLst>
+          </a:blip>
+          <a:stretch>
+            <a:fillRect/>
+          </a:stretch>
+        </p:blipFill>
+        <p:spPr>
+          <a:xfrm rot="19772497" flipV="1">
+            <a:off x="3285721" y="4663838"/>
+            <a:ext cx="1474746" cy="1405138"/>
+          </a:xfrm>
+          <a:prstGeom prst="rect">
+            <a:avLst/>
+          </a:prstGeom>
+        </p:spPr>
+      </p:pic>
+      <p:pic>
+        <p:nvPicPr>
+          <p:cNvPr id="17" name="Imagem 16">
+            <a:extLst>
+              <a:ext uri="{FF2B5EF4-FFF2-40B4-BE49-F238E27FC236}">
+                <a16:creationId xmlns:a16="http://schemas.microsoft.com/office/drawing/2014/main" id="{940850DB-9C6A-C29D-F2AB-6D4D81349CB2}"/>
+              </a:ext>
+            </a:extLst>
+          </p:cNvPr>
+          <p:cNvPicPr>
+            <a:picLocks noChangeAspect="1"/>
+          </p:cNvPicPr>
+          <p:nvPr/>
+        </p:nvPicPr>
+        <p:blipFill>
+          <a:blip r:embed="rId8">
+            <a:extLst>
+              <a:ext uri="{BEBA8EAE-BF5A-486C-A8C5-ECC9F3942E4B}">
+                <a14:imgProps xmlns:a14="http://schemas.microsoft.com/office/drawing/2010/main">
+                  <a14:imgLayer r:embed="rId9">
+                    <a14:imgEffect>
+                      <a14:backgroundRemoval t="10000" b="90000" l="10000" r="90000"/>
+                    </a14:imgEffect>
+                  </a14:imgLayer>
+                </a14:imgProps>
+              </a:ext>
+            </a:extLst>
+          </a:blip>
+          <a:srcRect l="46407" b="58569"/>
+          <a:stretch>
+            <a:fillRect/>
+          </a:stretch>
+        </p:blipFill>
+        <p:spPr>
+          <a:xfrm rot="19974542" flipV="1">
+            <a:off x="4769152" y="2444771"/>
+            <a:ext cx="790360" cy="582163"/>
+          </a:xfrm>
+          <a:prstGeom prst="rect">
+            <a:avLst/>
+          </a:prstGeom>
+        </p:spPr>
+      </p:pic>
+      <p:sp>
+        <p:nvSpPr>
+          <p:cNvPr id="18" name="Retângulo 17">
+            <a:extLst>
+              <a:ext uri="{FF2B5EF4-FFF2-40B4-BE49-F238E27FC236}">
+                <a16:creationId xmlns:a16="http://schemas.microsoft.com/office/drawing/2014/main" id="{E1160EC5-3DDE-ABC4-C059-3F441EE88385}"/>
+              </a:ext>
+            </a:extLst>
+          </p:cNvPr>
+          <p:cNvSpPr/>
+          <p:nvPr/>
+        </p:nvSpPr>
+        <p:spPr>
+          <a:xfrm>
+            <a:off x="3996531" y="2701925"/>
+            <a:ext cx="996950" cy="136525"/>
+          </a:xfrm>
+          <a:prstGeom prst="rect">
+            <a:avLst/>
+          </a:prstGeom>
+          <a:solidFill>
+            <a:schemeClr val="tx1"/>
+          </a:solidFill>
+          <a:ln>
+            <a:noFill/>
+          </a:ln>
+        </p:spPr>
+        <p:style>
+          <a:lnRef idx="2">
+            <a:schemeClr val="accent1">
+              <a:shade val="15000"/>
+            </a:schemeClr>
+          </a:lnRef>
+          <a:fillRef idx="1">
+            <a:schemeClr val="accent1"/>
+          </a:fillRef>
+          <a:effectRef idx="0">
+            <a:schemeClr val="accent1"/>
+          </a:effectRef>
+          <a:fontRef idx="minor">
+            <a:schemeClr val="lt1"/>
+          </a:fontRef>
+        </p:style>
+        <p:txBody>
+          <a:bodyPr rtlCol="0" anchor="ctr"/>
+          <a:lstStyle/>
+          <a:p>
+            <a:pPr algn="ctr"/>
+            <a:endParaRPr lang="pt-BR"/>
+          </a:p>
+        </p:txBody>
+      </p:sp>
+      <p:sp>
+        <p:nvSpPr>
+          <p:cNvPr id="19" name="Retângulo 18">
+            <a:extLst>
+              <a:ext uri="{FF2B5EF4-FFF2-40B4-BE49-F238E27FC236}">
+                <a16:creationId xmlns:a16="http://schemas.microsoft.com/office/drawing/2014/main" id="{CA7F896D-5226-E617-5BB9-2BB3B7ADF6E5}"/>
+              </a:ext>
+            </a:extLst>
+          </p:cNvPr>
+          <p:cNvSpPr/>
+          <p:nvPr/>
+        </p:nvSpPr>
+        <p:spPr>
+          <a:xfrm>
+            <a:off x="4813300" y="5016500"/>
+            <a:ext cx="180181" cy="1756807"/>
+          </a:xfrm>
+          <a:prstGeom prst="rect">
+            <a:avLst/>
+          </a:prstGeom>
+          <a:solidFill>
+            <a:schemeClr val="bg1"/>
+          </a:solidFill>
+          <a:ln>
+            <a:noFill/>
+          </a:ln>
+        </p:spPr>
+        <p:style>
+          <a:lnRef idx="2">
+            <a:schemeClr val="accent1">
+              <a:shade val="15000"/>
+            </a:schemeClr>
+          </a:lnRef>
+          <a:fillRef idx="1">
+            <a:schemeClr val="accent1"/>
+          </a:fillRef>
+          <a:effectRef idx="0">
+            <a:schemeClr val="accent1"/>
+          </a:effectRef>
+          <a:fontRef idx="minor">
+            <a:schemeClr val="lt1"/>
+          </a:fontRef>
+        </p:style>
+        <p:txBody>
+          <a:bodyPr rtlCol="0" anchor="ctr"/>
+          <a:lstStyle/>
+          <a:p>
+            <a:pPr algn="ctr"/>
+            <a:endParaRPr lang="pt-BR"/>
+          </a:p>
+        </p:txBody>
+      </p:sp>
     </p:spTree>
     <p:extLst>
       <p:ext uri="{BB962C8B-B14F-4D97-AF65-F5344CB8AC3E}">
@@ -29174,7 +30059,7 @@
         <p:cNvPr id="1" name="">
           <a:extLst>
             <a:ext uri="{FF2B5EF4-FFF2-40B4-BE49-F238E27FC236}">
-              <a16:creationId xmlns:a16="http://schemas.microsoft.com/office/drawing/2014/main" id="{B01657AE-307F-BF7B-83B5-E5EEE20D7C6E}"/>
+              <a16:creationId xmlns:a16="http://schemas.microsoft.com/office/drawing/2014/main" id="{247ACADE-A840-3BE9-33C2-2379B4027FDA}"/>
             </a:ext>
           </a:extLst>
         </p:cNvPr>
@@ -29194,7 +30079,7 @@
           <p:cNvPr id="5" name="Retângulo 4">
             <a:extLst>
               <a:ext uri="{FF2B5EF4-FFF2-40B4-BE49-F238E27FC236}">
-                <a16:creationId xmlns:a16="http://schemas.microsoft.com/office/drawing/2014/main" id="{C7AABB55-32D7-5660-1B7B-37FCB61F6EFF}"/>
+                <a16:creationId xmlns:a16="http://schemas.microsoft.com/office/drawing/2014/main" id="{5D6F4223-B114-1B64-C5A5-94547D50A986}"/>
               </a:ext>
             </a:extLst>
           </p:cNvPr>
@@ -29248,7 +30133,7 @@
           <p:cNvPr id="2" name="Título 1">
             <a:extLst>
               <a:ext uri="{FF2B5EF4-FFF2-40B4-BE49-F238E27FC236}">
-                <a16:creationId xmlns:a16="http://schemas.microsoft.com/office/drawing/2014/main" id="{AD1260A6-3C07-1BE4-AB53-24D1107EAA53}"/>
+                <a16:creationId xmlns:a16="http://schemas.microsoft.com/office/drawing/2014/main" id="{A8DB634D-98C2-7C53-CE8C-88718DA1DEDA}"/>
               </a:ext>
             </a:extLst>
           </p:cNvPr>
@@ -29276,13 +30161,720 @@
                   <a:schemeClr val="bg1"/>
                 </a:solidFill>
               </a:rPr>
-              <a:t>ALGEBRA BOOLEANA (INTRO)</a:t>
-            </a:r>
-          </a:p>
-        </p:txBody>
-      </p:sp>
-      <mc:AlternateContent xmlns:mc="http://schemas.openxmlformats.org/markup-compatibility/2006" xmlns:a14="http://schemas.microsoft.com/office/drawing/2010/main">
-        <mc:Choice Requires="a14">
+              <a:t>FIXAÇÃO - DESAFIO</a:t>
+            </a:r>
+          </a:p>
+        </p:txBody>
+      </p:sp>
+      <p:sp>
+        <p:nvSpPr>
+          <p:cNvPr id="6" name="Espaço Reservado para Conteúdo 5">
+            <a:extLst>
+              <a:ext uri="{FF2B5EF4-FFF2-40B4-BE49-F238E27FC236}">
+                <a16:creationId xmlns:a16="http://schemas.microsoft.com/office/drawing/2014/main" id="{D169E136-FFE4-8C03-85FE-9C8A6D6859BD}"/>
+              </a:ext>
+            </a:extLst>
+          </p:cNvPr>
+          <p:cNvSpPr>
+            <a:spLocks noGrp="1"/>
+          </p:cNvSpPr>
+          <p:nvPr>
+            <p:ph idx="1"/>
+          </p:nvPr>
+        </p:nvSpPr>
+        <p:spPr>
+          <a:xfrm>
+            <a:off x="1758950" y="1817914"/>
+            <a:ext cx="8888997" cy="4669971"/>
+          </a:xfrm>
+        </p:spPr>
+        <p:txBody>
+          <a:bodyPr>
+            <a:normAutofit/>
+          </a:bodyPr>
+          <a:lstStyle/>
+          <a:p>
+            <a:pPr marL="457200" indent="-457200" algn="just">
+              <a:buFont typeface="+mj-lt"/>
+              <a:buAutoNum type="arabicPeriod"/>
+            </a:pPr>
+            <a:r>
+              <a:rPr lang="pt-BR" sz="2400" dirty="0"/>
+              <a:t>Considerando que a logica proposicional trabalha essencialmente com conjunções, disjunções e negações. Como poderíamos representar a </a:t>
+            </a:r>
+            <a:r>
+              <a:rPr lang="pt-BR" sz="2400" b="1" dirty="0"/>
+              <a:t>condicional</a:t>
+            </a:r>
+            <a:r>
+              <a:rPr lang="pt-BR" sz="2400" dirty="0"/>
+              <a:t>, a </a:t>
+            </a:r>
+            <a:r>
+              <a:rPr lang="pt-BR" sz="2400" b="1" dirty="0" err="1"/>
+              <a:t>bi-condicional</a:t>
+            </a:r>
+            <a:r>
+              <a:rPr lang="pt-BR" sz="2400" dirty="0"/>
+              <a:t> e a </a:t>
+            </a:r>
+            <a:r>
+              <a:rPr lang="pt-BR" sz="2400" b="1" dirty="0"/>
+              <a:t>disjunção exclusiva</a:t>
+            </a:r>
+            <a:r>
+              <a:rPr lang="pt-BR" sz="2400" dirty="0"/>
+              <a:t>, dentro das formas normais?</a:t>
+            </a:r>
+          </a:p>
+          <a:p>
+            <a:pPr marL="457200" indent="-457200" algn="just">
+              <a:buFont typeface="+mj-lt"/>
+              <a:buAutoNum type="arabicPeriod"/>
+            </a:pPr>
+            <a:endParaRPr lang="pt-BR" sz="2400" dirty="0"/>
+          </a:p>
+          <a:p>
+            <a:pPr marL="457200" indent="-457200" algn="just">
+              <a:buFont typeface="+mj-lt"/>
+              <a:buAutoNum type="arabicPeriod"/>
+            </a:pPr>
+            <a:r>
+              <a:rPr lang="pt-BR" sz="2400" dirty="0"/>
+              <a:t>Simplifique as expressões:</a:t>
+            </a:r>
+          </a:p>
+          <a:p>
+            <a:pPr marL="0" indent="0" algn="just">
+              <a:buNone/>
+            </a:pPr>
+            <a:r>
+              <a:rPr lang="pt-BR" sz="2400" dirty="0"/>
+              <a:t> </a:t>
+            </a:r>
+          </a:p>
+        </p:txBody>
+      </p:sp>
+      <p:pic>
+        <p:nvPicPr>
+          <p:cNvPr id="3" name="Imagem 2">
+            <a:extLst>
+              <a:ext uri="{FF2B5EF4-FFF2-40B4-BE49-F238E27FC236}">
+                <a16:creationId xmlns:a16="http://schemas.microsoft.com/office/drawing/2014/main" id="{47F2354F-9002-B04F-3F3B-CD5583E0DED6}"/>
+              </a:ext>
+            </a:extLst>
+          </p:cNvPr>
+          <p:cNvPicPr>
+            <a:picLocks noChangeAspect="1"/>
+          </p:cNvPicPr>
+          <p:nvPr/>
+        </p:nvPicPr>
+        <p:blipFill>
+          <a:blip r:embed="rId3"/>
+          <a:stretch>
+            <a:fillRect/>
+          </a:stretch>
+        </p:blipFill>
+        <p:spPr>
+          <a:xfrm>
+            <a:off x="2455673" y="4412643"/>
+            <a:ext cx="7495550" cy="2445357"/>
+          </a:xfrm>
+          <a:prstGeom prst="rect">
+            <a:avLst/>
+          </a:prstGeom>
+        </p:spPr>
+      </p:pic>
+    </p:spTree>
+    <p:extLst>
+      <p:ext uri="{BB962C8B-B14F-4D97-AF65-F5344CB8AC3E}">
+        <p14:creationId xmlns:p14="http://schemas.microsoft.com/office/powerpoint/2010/main" val="3630648018"/>
+      </p:ext>
+    </p:extLst>
+  </p:cSld>
+  <p:clrMapOvr>
+    <a:masterClrMapping/>
+  </p:clrMapOvr>
+</p:sld>
+</file>
+
+<file path=ppt/slides/slide42.xml><?xml version="1.0" encoding="utf-8"?>
+<p:sld xmlns:a="http://schemas.openxmlformats.org/drawingml/2006/main" xmlns:r="http://schemas.openxmlformats.org/officeDocument/2006/relationships" xmlns:p="http://schemas.openxmlformats.org/presentationml/2006/main">
+  <p:cSld>
+    <p:spTree>
+      <p:nvGrpSpPr>
+        <p:cNvPr id="1" name="">
+          <a:extLst>
+            <a:ext uri="{FF2B5EF4-FFF2-40B4-BE49-F238E27FC236}">
+              <a16:creationId xmlns:a16="http://schemas.microsoft.com/office/drawing/2014/main" id="{CB27649F-24B5-B038-2AAF-C9E9027A5692}"/>
+            </a:ext>
+          </a:extLst>
+        </p:cNvPr>
+        <p:cNvGrpSpPr/>
+        <p:nvPr/>
+      </p:nvGrpSpPr>
+      <p:grpSpPr>
+        <a:xfrm>
+          <a:off x="0" y="0"/>
+          <a:ext cx="0" cy="0"/>
+          <a:chOff x="0" y="0"/>
+          <a:chExt cx="0" cy="0"/>
+        </a:xfrm>
+      </p:grpSpPr>
+      <p:sp>
+        <p:nvSpPr>
+          <p:cNvPr id="2" name="Título 1">
+            <a:extLst>
+              <a:ext uri="{FF2B5EF4-FFF2-40B4-BE49-F238E27FC236}">
+                <a16:creationId xmlns:a16="http://schemas.microsoft.com/office/drawing/2014/main" id="{E8E02440-68B0-28B7-4A80-0BCABD0107A8}"/>
+              </a:ext>
+            </a:extLst>
+          </p:cNvPr>
+          <p:cNvSpPr>
+            <a:spLocks noGrp="1"/>
+          </p:cNvSpPr>
+          <p:nvPr>
+            <p:ph type="ctrTitle"/>
+          </p:nvPr>
+        </p:nvSpPr>
+        <p:spPr>
+          <a:xfrm>
+            <a:off x="0" y="2524919"/>
+            <a:ext cx="12192000" cy="1808162"/>
+          </a:xfrm>
+          <a:ln>
+            <a:noFill/>
+          </a:ln>
+        </p:spPr>
+        <p:txBody>
+          <a:bodyPr/>
+          <a:lstStyle/>
+          <a:p>
+            <a:r>
+              <a:rPr lang="pt-BR" dirty="0">
+                <a:solidFill>
+                  <a:schemeClr val="bg1"/>
+                </a:solidFill>
+              </a:rPr>
+              <a:t>módulo 4 – Introdução à álgebra booleana</a:t>
+            </a:r>
+          </a:p>
+        </p:txBody>
+      </p:sp>
+      <p:sp>
+        <p:nvSpPr>
+          <p:cNvPr id="3" name="Subtítulo 2">
+            <a:extLst>
+              <a:ext uri="{FF2B5EF4-FFF2-40B4-BE49-F238E27FC236}">
+                <a16:creationId xmlns:a16="http://schemas.microsoft.com/office/drawing/2014/main" id="{21DA732B-E7EB-C9FF-271B-66E9EE18C415}"/>
+              </a:ext>
+            </a:extLst>
+          </p:cNvPr>
+          <p:cNvSpPr>
+            <a:spLocks noGrp="1"/>
+          </p:cNvSpPr>
+          <p:nvPr>
+            <p:ph type="subTitle" idx="1"/>
+          </p:nvPr>
+        </p:nvSpPr>
+        <p:spPr>
+          <a:xfrm>
+            <a:off x="2695192" y="5207000"/>
+            <a:ext cx="6801612" cy="1651000"/>
+          </a:xfrm>
+        </p:spPr>
+        <p:txBody>
+          <a:bodyPr/>
+          <a:lstStyle/>
+          <a:p>
+            <a:r>
+              <a:rPr lang="pt-BR" dirty="0"/>
+              <a:t>Universidade de Uberaba</a:t>
+            </a:r>
+          </a:p>
+          <a:p>
+            <a:r>
+              <a:rPr lang="pt-BR" dirty="0"/>
+              <a:t>Marcio Salmazo Ramos</a:t>
+            </a:r>
+          </a:p>
+        </p:txBody>
+      </p:sp>
+      <p:pic>
+        <p:nvPicPr>
+          <p:cNvPr id="8194" name="Picture 2">
+            <a:extLst>
+              <a:ext uri="{FF2B5EF4-FFF2-40B4-BE49-F238E27FC236}">
+                <a16:creationId xmlns:a16="http://schemas.microsoft.com/office/drawing/2014/main" id="{40A5B6D4-9FCD-B25F-1D65-9BAABF823C20}"/>
+              </a:ext>
+            </a:extLst>
+          </p:cNvPr>
+          <p:cNvPicPr>
+            <a:picLocks noChangeAspect="1" noChangeArrowheads="1"/>
+          </p:cNvPicPr>
+          <p:nvPr/>
+        </p:nvPicPr>
+        <p:blipFill>
+          <a:blip r:embed="rId3">
+            <a:extLst>
+              <a:ext uri="{28A0092B-C50C-407E-A947-70E740481C1C}">
+                <a14:useLocalDpi xmlns:a14="http://schemas.microsoft.com/office/drawing/2010/main" val="0"/>
+              </a:ext>
+            </a:extLst>
+          </a:blip>
+          <a:srcRect/>
+          <a:stretch>
+            <a:fillRect/>
+          </a:stretch>
+        </p:blipFill>
+        <p:spPr bwMode="auto">
+          <a:xfrm>
+            <a:off x="4337048" y="447153"/>
+            <a:ext cx="3517900" cy="972919"/>
+          </a:xfrm>
+          <a:prstGeom prst="rect">
+            <a:avLst/>
+          </a:prstGeom>
+          <a:noFill/>
+          <a:extLst>
+            <a:ext uri="{909E8E84-426E-40DD-AFC4-6F175D3DCCD1}">
+              <a14:hiddenFill xmlns:a14="http://schemas.microsoft.com/office/drawing/2010/main">
+                <a:solidFill>
+                  <a:srgbClr val="FFFFFF"/>
+                </a:solidFill>
+              </a14:hiddenFill>
+            </a:ext>
+          </a:extLst>
+        </p:spPr>
+      </p:pic>
+    </p:spTree>
+    <p:extLst>
+      <p:ext uri="{BB962C8B-B14F-4D97-AF65-F5344CB8AC3E}">
+        <p14:creationId xmlns:p14="http://schemas.microsoft.com/office/powerpoint/2010/main" val="759652083"/>
+      </p:ext>
+    </p:extLst>
+  </p:cSld>
+  <p:clrMapOvr>
+    <a:masterClrMapping/>
+  </p:clrMapOvr>
+</p:sld>
+</file>
+
+<file path=ppt/slides/slide43.xml><?xml version="1.0" encoding="utf-8"?>
+<p:sld xmlns:a="http://schemas.openxmlformats.org/drawingml/2006/main" xmlns:r="http://schemas.openxmlformats.org/officeDocument/2006/relationships" xmlns:p="http://schemas.openxmlformats.org/presentationml/2006/main">
+  <p:cSld>
+    <p:spTree>
+      <p:nvGrpSpPr>
+        <p:cNvPr id="1" name="">
+          <a:extLst>
+            <a:ext uri="{FF2B5EF4-FFF2-40B4-BE49-F238E27FC236}">
+              <a16:creationId xmlns:a16="http://schemas.microsoft.com/office/drawing/2014/main" id="{E50EAA3B-2C01-F295-2C01-AF45DFBFCB7C}"/>
+            </a:ext>
+          </a:extLst>
+        </p:cNvPr>
+        <p:cNvGrpSpPr/>
+        <p:nvPr/>
+      </p:nvGrpSpPr>
+      <p:grpSpPr>
+        <a:xfrm>
+          <a:off x="0" y="0"/>
+          <a:ext cx="0" cy="0"/>
+          <a:chOff x="0" y="0"/>
+          <a:chExt cx="0" cy="0"/>
+        </a:xfrm>
+      </p:grpSpPr>
+      <p:sp>
+        <p:nvSpPr>
+          <p:cNvPr id="5" name="Retângulo 4">
+            <a:extLst>
+              <a:ext uri="{FF2B5EF4-FFF2-40B4-BE49-F238E27FC236}">
+                <a16:creationId xmlns:a16="http://schemas.microsoft.com/office/drawing/2014/main" id="{F38D72F3-CE05-A213-B32A-A572BF706693}"/>
+              </a:ext>
+            </a:extLst>
+          </p:cNvPr>
+          <p:cNvSpPr/>
+          <p:nvPr/>
+        </p:nvSpPr>
+        <p:spPr>
+          <a:xfrm>
+            <a:off x="0" y="-2"/>
+            <a:ext cx="12192000" cy="1325563"/>
+          </a:xfrm>
+          <a:prstGeom prst="rect">
+            <a:avLst/>
+          </a:prstGeom>
+          <a:solidFill>
+            <a:schemeClr val="accent2"/>
+          </a:solidFill>
+          <a:ln>
+            <a:solidFill>
+              <a:srgbClr val="418AB3"/>
+            </a:solidFill>
+          </a:ln>
+        </p:spPr>
+        <p:style>
+          <a:lnRef idx="2">
+            <a:schemeClr val="accent1">
+              <a:shade val="15000"/>
+            </a:schemeClr>
+          </a:lnRef>
+          <a:fillRef idx="1">
+            <a:schemeClr val="accent1"/>
+          </a:fillRef>
+          <a:effectRef idx="0">
+            <a:schemeClr val="accent1"/>
+          </a:effectRef>
+          <a:fontRef idx="minor">
+            <a:schemeClr val="lt1"/>
+          </a:fontRef>
+        </p:style>
+        <p:txBody>
+          <a:bodyPr rtlCol="0" anchor="ctr"/>
+          <a:lstStyle/>
+          <a:p>
+            <a:pPr algn="ctr"/>
+            <a:endParaRPr lang="pt-BR" dirty="0"/>
+          </a:p>
+        </p:txBody>
+      </p:sp>
+      <p:sp>
+        <p:nvSpPr>
+          <p:cNvPr id="2" name="Título 1">
+            <a:extLst>
+              <a:ext uri="{FF2B5EF4-FFF2-40B4-BE49-F238E27FC236}">
+                <a16:creationId xmlns:a16="http://schemas.microsoft.com/office/drawing/2014/main" id="{9D6C1FC8-0F93-EEE7-D1B6-8D7CFE6C4DF9}"/>
+              </a:ext>
+            </a:extLst>
+          </p:cNvPr>
+          <p:cNvSpPr>
+            <a:spLocks noGrp="1"/>
+          </p:cNvSpPr>
+          <p:nvPr>
+            <p:ph type="title"/>
+          </p:nvPr>
+        </p:nvSpPr>
+        <p:spPr>
+          <a:xfrm>
+            <a:off x="0" y="-1"/>
+            <a:ext cx="12192000" cy="1325563"/>
+          </a:xfrm>
+        </p:spPr>
+        <p:txBody>
+          <a:bodyPr/>
+          <a:lstStyle/>
+          <a:p>
+            <a:pPr algn="ctr"/>
+            <a:r>
+              <a:rPr lang="pt-BR" dirty="0">
+                <a:solidFill>
+                  <a:schemeClr val="bg1"/>
+                </a:solidFill>
+              </a:rPr>
+              <a:t>ALGEBRA BOOLEANA</a:t>
+            </a:r>
+          </a:p>
+        </p:txBody>
+      </p:sp>
+      <p:sp>
+        <p:nvSpPr>
+          <p:cNvPr id="6" name="Espaço Reservado para Conteúdo 5">
+            <a:extLst>
+              <a:ext uri="{FF2B5EF4-FFF2-40B4-BE49-F238E27FC236}">
+                <a16:creationId xmlns:a16="http://schemas.microsoft.com/office/drawing/2014/main" id="{635AB691-ABF9-4383-8E85-3569CF5352C6}"/>
+              </a:ext>
+            </a:extLst>
+          </p:cNvPr>
+          <p:cNvSpPr>
+            <a:spLocks noGrp="1"/>
+          </p:cNvSpPr>
+          <p:nvPr>
+            <p:ph idx="1"/>
+          </p:nvPr>
+        </p:nvSpPr>
+        <p:spPr>
+          <a:xfrm>
+            <a:off x="1674394" y="1672390"/>
+            <a:ext cx="9298406" cy="4872789"/>
+          </a:xfrm>
+        </p:spPr>
+        <p:txBody>
+          <a:bodyPr>
+            <a:normAutofit/>
+          </a:bodyPr>
+          <a:lstStyle/>
+          <a:p>
+            <a:r>
+              <a:rPr lang="pt-BR" sz="2400" dirty="0"/>
+              <a:t>A álgebra booleana é um sistema matemático criado por </a:t>
+            </a:r>
+            <a:r>
+              <a:rPr lang="pt-BR" sz="2400" i="1" dirty="0"/>
+              <a:t>George </a:t>
+            </a:r>
+            <a:r>
+              <a:rPr lang="pt-BR" sz="2400" i="1" dirty="0" err="1"/>
+              <a:t>Boole</a:t>
+            </a:r>
+            <a:r>
+              <a:rPr lang="pt-BR" sz="2400" dirty="0"/>
+              <a:t> </a:t>
+            </a:r>
+          </a:p>
+          <a:p>
+            <a:endParaRPr lang="pt-BR" sz="2400" dirty="0"/>
+          </a:p>
+          <a:p>
+            <a:r>
+              <a:rPr lang="pt-BR" sz="2400" dirty="0"/>
+              <a:t>Serve de base para a </a:t>
+            </a:r>
+            <a:r>
+              <a:rPr lang="pt-BR" sz="2400" b="1" dirty="0"/>
+              <a:t>lógica digital</a:t>
+            </a:r>
+            <a:r>
+              <a:rPr lang="pt-BR" sz="2400" dirty="0"/>
+              <a:t>, a </a:t>
+            </a:r>
+            <a:r>
+              <a:rPr lang="pt-BR" sz="2400" b="1" dirty="0"/>
+              <a:t>programação</a:t>
+            </a:r>
+            <a:r>
+              <a:rPr lang="pt-BR" sz="2400" dirty="0"/>
+              <a:t> e o funcionamento dos computadores modernos.</a:t>
+            </a:r>
+          </a:p>
+          <a:p>
+            <a:endParaRPr lang="pt-BR" sz="2400" dirty="0">
+              <a:sym typeface="Wingdings" panose="05000000000000000000" pitchFamily="2" charset="2"/>
+            </a:endParaRPr>
+          </a:p>
+          <a:p>
+            <a:r>
+              <a:rPr lang="pt-BR" sz="2400" dirty="0">
+                <a:sym typeface="Wingdings" panose="05000000000000000000" pitchFamily="2" charset="2"/>
+              </a:rPr>
+              <a:t>A álgebra booleana utiliza 3 operadores básicos (Análogos aos conectivos da lógica proposicional):</a:t>
+            </a:r>
+          </a:p>
+          <a:p>
+            <a:endParaRPr lang="pt-BR" sz="2400" dirty="0">
+              <a:sym typeface="Wingdings" panose="05000000000000000000" pitchFamily="2" charset="2"/>
+            </a:endParaRPr>
+          </a:p>
+          <a:p>
+            <a:pPr lvl="1">
+              <a:buFont typeface="Courier New" panose="02070309020205020404" pitchFamily="49" charset="0"/>
+              <a:buChar char="o"/>
+            </a:pPr>
+            <a:r>
+              <a:rPr lang="pt-BR" sz="2000" dirty="0">
+                <a:sym typeface="Wingdings" panose="05000000000000000000" pitchFamily="2" charset="2"/>
+              </a:rPr>
+              <a:t>AND (E / ⋅): O resultado é 1 apenas se todas as entradas forem 1.</a:t>
+            </a:r>
+          </a:p>
+          <a:p>
+            <a:pPr lvl="1">
+              <a:buFont typeface="Courier New" panose="02070309020205020404" pitchFamily="49" charset="0"/>
+              <a:buChar char="o"/>
+            </a:pPr>
+            <a:r>
+              <a:rPr lang="pt-BR" sz="2000" dirty="0">
+                <a:sym typeface="Wingdings" panose="05000000000000000000" pitchFamily="2" charset="2"/>
+              </a:rPr>
+              <a:t>OR (OU / +): O resultado é 1 se pelo menos uma entrada for 1.</a:t>
+            </a:r>
+          </a:p>
+          <a:p>
+            <a:pPr lvl="1">
+              <a:buFont typeface="Courier New" panose="02070309020205020404" pitchFamily="49" charset="0"/>
+              <a:buChar char="o"/>
+            </a:pPr>
+            <a:r>
+              <a:rPr lang="pt-BR" sz="2000" dirty="0">
+                <a:sym typeface="Wingdings" panose="05000000000000000000" pitchFamily="2" charset="2"/>
+              </a:rPr>
+              <a:t>NOT (NÃO / Ā): Inverte o valor da entrada (de 0 para 1, ou de 1 para 0).</a:t>
+            </a:r>
+          </a:p>
+          <a:p>
+            <a:pPr marL="0" indent="0" algn="just">
+              <a:buNone/>
+            </a:pPr>
+            <a:r>
+              <a:rPr lang="pt-BR" sz="2400" dirty="0"/>
+              <a:t>	</a:t>
+            </a:r>
+          </a:p>
+          <a:p>
+            <a:pPr marL="0" indent="0" algn="just">
+              <a:buNone/>
+            </a:pPr>
+            <a:endParaRPr lang="pt-BR" sz="2400" dirty="0"/>
+          </a:p>
+          <a:p>
+            <a:pPr algn="just"/>
+            <a:endParaRPr lang="pt-BR" sz="2200" dirty="0"/>
+          </a:p>
+          <a:p>
+            <a:pPr lvl="1" algn="just"/>
+            <a:endParaRPr lang="pt-BR" sz="2000" dirty="0"/>
+          </a:p>
+          <a:p>
+            <a:pPr marL="914400" lvl="1" indent="-457200" algn="just">
+              <a:buFont typeface="+mj-lt"/>
+              <a:buAutoNum type="arabicPeriod"/>
+            </a:pPr>
+            <a:endParaRPr lang="pt-BR" b="1" i="1" dirty="0">
+              <a:latin typeface="Cambria Math" panose="02040503050406030204" pitchFamily="18" charset="0"/>
+            </a:endParaRPr>
+          </a:p>
+          <a:p>
+            <a:pPr marL="457200" lvl="1" indent="0" algn="just">
+              <a:buNone/>
+            </a:pPr>
+            <a:endParaRPr lang="pt-BR" b="1" dirty="0"/>
+          </a:p>
+          <a:p>
+            <a:pPr marL="457200" lvl="1" indent="0" algn="just">
+              <a:buNone/>
+            </a:pPr>
+            <a:endParaRPr lang="pt-BR" b="1" dirty="0"/>
+          </a:p>
+        </p:txBody>
+      </p:sp>
+    </p:spTree>
+    <p:extLst>
+      <p:ext uri="{BB962C8B-B14F-4D97-AF65-F5344CB8AC3E}">
+        <p14:creationId xmlns:p14="http://schemas.microsoft.com/office/powerpoint/2010/main" val="3796939288"/>
+      </p:ext>
+    </p:extLst>
+  </p:cSld>
+  <p:clrMapOvr>
+    <a:masterClrMapping/>
+  </p:clrMapOvr>
+</p:sld>
+</file>
+
+<file path=ppt/slides/slide44.xml><?xml version="1.0" encoding="utf-8"?>
+<p:sld xmlns:a="http://schemas.openxmlformats.org/drawingml/2006/main" xmlns:r="http://schemas.openxmlformats.org/officeDocument/2006/relationships" xmlns:p="http://schemas.openxmlformats.org/presentationml/2006/main">
+  <p:cSld>
+    <p:spTree>
+      <p:nvGrpSpPr>
+        <p:cNvPr id="1" name="">
+          <a:extLst>
+            <a:ext uri="{FF2B5EF4-FFF2-40B4-BE49-F238E27FC236}">
+              <a16:creationId xmlns:a16="http://schemas.microsoft.com/office/drawing/2014/main" id="{B01657AE-307F-BF7B-83B5-E5EEE20D7C6E}"/>
+            </a:ext>
+          </a:extLst>
+        </p:cNvPr>
+        <p:cNvGrpSpPr/>
+        <p:nvPr/>
+      </p:nvGrpSpPr>
+      <p:grpSpPr>
+        <a:xfrm>
+          <a:off x="0" y="0"/>
+          <a:ext cx="0" cy="0"/>
+          <a:chOff x="0" y="0"/>
+          <a:chExt cx="0" cy="0"/>
+        </a:xfrm>
+      </p:grpSpPr>
+      <p:sp>
+        <p:nvSpPr>
+          <p:cNvPr id="5" name="Retângulo 4">
+            <a:extLst>
+              <a:ext uri="{FF2B5EF4-FFF2-40B4-BE49-F238E27FC236}">
+                <a16:creationId xmlns:a16="http://schemas.microsoft.com/office/drawing/2014/main" id="{C7AABB55-32D7-5660-1B7B-37FCB61F6EFF}"/>
+              </a:ext>
+            </a:extLst>
+          </p:cNvPr>
+          <p:cNvSpPr/>
+          <p:nvPr/>
+        </p:nvSpPr>
+        <p:spPr>
+          <a:xfrm>
+            <a:off x="0" y="-2"/>
+            <a:ext cx="12192000" cy="1325563"/>
+          </a:xfrm>
+          <a:prstGeom prst="rect">
+            <a:avLst/>
+          </a:prstGeom>
+          <a:solidFill>
+            <a:schemeClr val="accent2"/>
+          </a:solidFill>
+          <a:ln>
+            <a:solidFill>
+              <a:srgbClr val="418AB3"/>
+            </a:solidFill>
+          </a:ln>
+        </p:spPr>
+        <p:style>
+          <a:lnRef idx="2">
+            <a:schemeClr val="accent1">
+              <a:shade val="15000"/>
+            </a:schemeClr>
+          </a:lnRef>
+          <a:fillRef idx="1">
+            <a:schemeClr val="accent1"/>
+          </a:fillRef>
+          <a:effectRef idx="0">
+            <a:schemeClr val="accent1"/>
+          </a:effectRef>
+          <a:fontRef idx="minor">
+            <a:schemeClr val="lt1"/>
+          </a:fontRef>
+        </p:style>
+        <p:txBody>
+          <a:bodyPr rtlCol="0" anchor="ctr"/>
+          <a:lstStyle/>
+          <a:p>
+            <a:pPr algn="ctr"/>
+            <a:endParaRPr lang="pt-BR" dirty="0"/>
+          </a:p>
+        </p:txBody>
+      </p:sp>
+      <p:sp>
+        <p:nvSpPr>
+          <p:cNvPr id="2" name="Título 1">
+            <a:extLst>
+              <a:ext uri="{FF2B5EF4-FFF2-40B4-BE49-F238E27FC236}">
+                <a16:creationId xmlns:a16="http://schemas.microsoft.com/office/drawing/2014/main" id="{AD1260A6-3C07-1BE4-AB53-24D1107EAA53}"/>
+              </a:ext>
+            </a:extLst>
+          </p:cNvPr>
+          <p:cNvSpPr>
+            <a:spLocks noGrp="1"/>
+          </p:cNvSpPr>
+          <p:nvPr>
+            <p:ph type="title"/>
+          </p:nvPr>
+        </p:nvSpPr>
+        <p:spPr>
+          <a:xfrm>
+            <a:off x="0" y="-1"/>
+            <a:ext cx="12192000" cy="1325563"/>
+          </a:xfrm>
+        </p:spPr>
+        <p:txBody>
+          <a:bodyPr/>
+          <a:lstStyle/>
+          <a:p>
+            <a:pPr algn="ctr"/>
+            <a:r>
+              <a:rPr lang="pt-BR" dirty="0">
+                <a:solidFill>
+                  <a:schemeClr val="bg1"/>
+                </a:solidFill>
+              </a:rPr>
+              <a:t>ALGEBRA BOOLEANA</a:t>
+            </a:r>
+          </a:p>
+        </p:txBody>
+      </p:sp>
+      <mc:AlternateContent xmlns:mc="http://schemas.openxmlformats.org/markup-compatibility/2006">
+        <mc:Choice xmlns:a14="http://schemas.microsoft.com/office/drawing/2010/main" Requires="a14">
           <p:sp>
             <p:nvSpPr>
               <p:cNvPr id="6" name="Espaço Reservado para Conteúdo 5">
@@ -29302,7 +30894,7 @@
             <p:spPr>
               <a:xfrm>
                 <a:off x="1674394" y="1672390"/>
-                <a:ext cx="8843212" cy="4872789"/>
+                <a:ext cx="9298406" cy="4872789"/>
               </a:xfrm>
             </p:spPr>
             <p:txBody>
@@ -29313,35 +30905,7 @@
               <a:p>
                 <a:r>
                   <a:rPr lang="pt-BR" sz="2400" dirty="0"/>
-                  <a:t>A álgebra booleana é um sistema matemático criado por </a:t>
-                </a:r>
-                <a:r>
-                  <a:rPr lang="pt-BR" sz="2400" i="1" dirty="0"/>
-                  <a:t>George </a:t>
-                </a:r>
-                <a:r>
-                  <a:rPr lang="pt-BR" sz="2400" i="1" dirty="0" err="1"/>
-                  <a:t>Boole</a:t>
-                </a:r>
-                <a:r>
-                  <a:rPr lang="pt-BR" sz="2400" dirty="0"/>
-                  <a:t>, que serve de base para a </a:t>
-                </a:r>
-                <a:r>
-                  <a:rPr lang="pt-BR" sz="2400" b="1" dirty="0"/>
-                  <a:t>lógica digital</a:t>
-                </a:r>
-                <a:r>
-                  <a:rPr lang="pt-BR" sz="2400" dirty="0"/>
-                  <a:t>, a </a:t>
-                </a:r>
-                <a:r>
-                  <a:rPr lang="pt-BR" sz="2400" b="1" dirty="0"/>
-                  <a:t>programação</a:t>
-                </a:r>
-                <a:r>
-                  <a:rPr lang="pt-BR" sz="2400" dirty="0"/>
-                  <a:t> e o funcionamento dos computadores modernos.</a:t>
+                  <a:t>Assim como na lógica proposicional, a álgebra booleana trabalha apenas com dois valores para resultados:</a:t>
                 </a:r>
               </a:p>
               <a:p>
@@ -29353,16 +30917,16 @@
                   <a:buChar char="o"/>
                 </a:pPr>
                 <a:r>
-                  <a:rPr lang="pt-BR" sz="2000" dirty="0"/>
+                  <a:rPr lang="pt-BR" sz="2200" dirty="0"/>
                   <a:t>Verdadeiro </a:t>
                 </a:r>
                 <a:r>
-                  <a:rPr lang="pt-BR" sz="2000" dirty="0">
+                  <a:rPr lang="pt-BR" sz="2200" dirty="0">
                     <a:sym typeface="Wingdings" panose="05000000000000000000" pitchFamily="2" charset="2"/>
                   </a:rPr>
                   <a:t> 1</a:t>
                 </a:r>
-                <a:endParaRPr lang="pt-BR" sz="2000" dirty="0"/>
+                <a:endParaRPr lang="pt-BR" sz="2200" dirty="0"/>
               </a:p>
               <a:p>
                 <a:pPr lvl="1">
@@ -29370,55 +30934,10 @@
                   <a:buChar char="o"/>
                 </a:pPr>
                 <a:r>
-                  <a:rPr lang="pt-BR" sz="2000" dirty="0">
+                  <a:rPr lang="pt-BR" sz="2200" dirty="0">
                     <a:sym typeface="Wingdings" panose="05000000000000000000" pitchFamily="2" charset="2"/>
                   </a:rPr>
                   <a:t>Falso  0</a:t>
-                </a:r>
-              </a:p>
-              <a:p>
-                <a:pPr lvl="1">
-                  <a:buFont typeface="Courier New" panose="02070309020205020404" pitchFamily="49" charset="0"/>
-                  <a:buChar char="o"/>
-                </a:pPr>
-                <a:r>
-                  <a:rPr lang="pt-BR" sz="2000" dirty="0">
-                    <a:sym typeface="Wingdings" panose="05000000000000000000" pitchFamily="2" charset="2"/>
-                  </a:rPr>
-                  <a:t>Conjunção   + (Soma)</a:t>
-                </a:r>
-              </a:p>
-              <a:p>
-                <a:pPr lvl="1">
-                  <a:buFont typeface="Courier New" panose="02070309020205020404" pitchFamily="49" charset="0"/>
-                  <a:buChar char="o"/>
-                </a:pPr>
-                <a:r>
-                  <a:rPr lang="pt-BR" sz="2000" dirty="0">
-                    <a:sym typeface="Wingdings" panose="05000000000000000000" pitchFamily="2" charset="2"/>
-                  </a:rPr>
-                  <a:t>Disjunção  * (Multiplicação)</a:t>
-                </a:r>
-              </a:p>
-              <a:p>
-                <a:pPr lvl="1">
-                  <a:buFont typeface="Courier New" panose="02070309020205020404" pitchFamily="49" charset="0"/>
-                  <a:buChar char="o"/>
-                </a:pPr>
-                <a:r>
-                  <a:rPr lang="pt-BR" sz="2000" dirty="0">
-                    <a:sym typeface="Wingdings" panose="05000000000000000000" pitchFamily="2" charset="2"/>
-                  </a:rPr>
-                  <a:t>Negação   </a:t>
-                </a:r>
-                <a:r>
-                  <a:rPr lang="pt-BR" sz="2000" dirty="0">
-                    <a:latin typeface="Calibri" panose="020F0502020204030204" pitchFamily="34" charset="0"/>
-                    <a:ea typeface="Calibri" panose="020F0502020204030204" pitchFamily="34" charset="0"/>
-                    <a:cs typeface="Calibri" panose="020F0502020204030204" pitchFamily="34" charset="0"/>
-                    <a:sym typeface="Wingdings" panose="05000000000000000000" pitchFamily="2" charset="2"/>
-                  </a:rPr>
-                  <a:t>─ (Barrado)</a:t>
                 </a:r>
               </a:p>
               <a:p>
@@ -29434,47 +30953,43 @@
                 </a:endParaRPr>
               </a:p>
               <a:p>
-                <a:pPr lvl="1">
-                  <a:buFont typeface="Courier New" panose="02070309020205020404" pitchFamily="49" charset="0"/>
-                  <a:buChar char="o"/>
-                </a:pPr>
                 <a:r>
-                  <a:rPr lang="pt-BR" sz="2000" dirty="0">
+                  <a:rPr lang="pt-BR" sz="2400" dirty="0">
                     <a:latin typeface="Calibri" panose="020F0502020204030204" pitchFamily="34" charset="0"/>
                     <a:ea typeface="Calibri" panose="020F0502020204030204" pitchFamily="34" charset="0"/>
                     <a:cs typeface="Calibri" panose="020F0502020204030204" pitchFamily="34" charset="0"/>
                     <a:sym typeface="Wingdings" panose="05000000000000000000" pitchFamily="2" charset="2"/>
                   </a:rPr>
-                  <a:t>Exemplo: </a:t>
+                  <a:t>Exemplo de equivalência entre uma sentença lógica e a escrita na Álgebra Booleana: </a:t>
                 </a:r>
                 <a14:m>
                   <m:oMath xmlns:m="http://schemas.openxmlformats.org/officeDocument/2006/math">
                     <m:r>
-                      <a:rPr lang="pt-BR" sz="2000" b="1" i="1" dirty="0" smtClean="0">
+                      <a:rPr lang="pt-BR" sz="2400" b="1" i="1" dirty="0" smtClean="0">
                         <a:latin typeface="Cambria Math" panose="02040503050406030204" pitchFamily="18" charset="0"/>
                       </a:rPr>
                       <m:t>𝑷</m:t>
                     </m:r>
                     <m:r>
-                      <a:rPr lang="pt-BR" sz="2000" b="1" i="1" dirty="0">
+                      <a:rPr lang="pt-BR" sz="2400" b="1" i="1" dirty="0">
                         <a:latin typeface="Cambria Math" panose="02040503050406030204" pitchFamily="18" charset="0"/>
                       </a:rPr>
                       <m:t>∧¬</m:t>
                     </m:r>
                     <m:r>
-                      <a:rPr lang="pt-BR" sz="2000" b="1" i="1" dirty="0">
+                      <a:rPr lang="pt-BR" sz="2400" b="1" i="1" dirty="0">
                         <a:latin typeface="Cambria Math" panose="02040503050406030204" pitchFamily="18" charset="0"/>
                       </a:rPr>
                       <m:t>𝑸</m:t>
                     </m:r>
                     <m:r>
-                      <a:rPr lang="pt-BR" sz="2000" b="1" i="1" dirty="0" smtClean="0">
+                      <a:rPr lang="pt-BR" sz="2400" b="1" i="1" dirty="0" smtClean="0">
                         <a:latin typeface="Cambria Math" panose="02040503050406030204" pitchFamily="18" charset="0"/>
                       </a:rPr>
                       <m:t>=</m:t>
                     </m:r>
                     <m:r>
-                      <a:rPr lang="pt-BR" sz="2000" b="1" i="1" dirty="0" smtClean="0">
+                      <a:rPr lang="pt-BR" sz="2400" b="1" i="1" dirty="0" smtClean="0">
                         <a:latin typeface="Cambria Math" panose="02040503050406030204" pitchFamily="18" charset="0"/>
                       </a:rPr>
                       <m:t>𝑨</m:t>
@@ -29483,14 +30998,14 @@
                       <m:accPr>
                         <m:chr m:val="̅"/>
                         <m:ctrlPr>
-                          <a:rPr lang="pt-BR" sz="2000" b="1" i="1" dirty="0" smtClean="0">
+                          <a:rPr lang="pt-BR" sz="2400" b="1" i="1" dirty="0" smtClean="0">
                             <a:latin typeface="Cambria Math" panose="02040503050406030204" pitchFamily="18" charset="0"/>
                           </a:rPr>
                         </m:ctrlPr>
                       </m:accPr>
                       <m:e>
                         <m:r>
-                          <a:rPr lang="pt-BR" sz="2000" b="1" i="1" dirty="0" smtClean="0">
+                          <a:rPr lang="pt-BR" sz="2400" b="1" i="1" dirty="0" smtClean="0">
                             <a:latin typeface="Cambria Math" panose="02040503050406030204" pitchFamily="18" charset="0"/>
                           </a:rPr>
                           <m:t>𝑩</m:t>
@@ -29499,7 +31014,7 @@
                     </m:acc>
                   </m:oMath>
                 </a14:m>
-                <a:endParaRPr lang="pt-BR" sz="2200" dirty="0">
+                <a:endParaRPr lang="pt-BR" sz="2600" dirty="0">
                   <a:sym typeface="Wingdings" panose="05000000000000000000" pitchFamily="2" charset="2"/>
                 </a:endParaRPr>
               </a:p>
@@ -29513,10 +31028,11 @@
                 </a:r>
               </a:p>
               <a:p>
-                <a:pPr marL="0" indent="0" algn="just">
-                  <a:buNone/>
-                </a:pPr>
-                <a:endParaRPr lang="pt-BR" sz="2400" dirty="0"/>
+                <a:pPr algn="just"/>
+                <a:r>
+                  <a:rPr lang="pt-BR" sz="2400" dirty="0"/>
+                  <a:t>O uso deste sistema facilita a simplificação de expressões lógicas, sendo particularmente útil no contexto de sistemas eletrônicos lógicos.</a:t>
+                </a:r>
               </a:p>
               <a:p>
                 <a:pPr algn="just"/>
@@ -29550,7 +31066,7 @@
             </p:txBody>
           </p:sp>
         </mc:Choice>
-        <mc:Fallback xmlns="">
+        <mc:Fallback>
           <p:sp>
             <p:nvSpPr>
               <p:cNvPr id="6" name="Espaço Reservado para Conteúdo 5">
@@ -29570,12 +31086,12 @@
             <p:spPr>
               <a:xfrm>
                 <a:off x="1674394" y="1672390"/>
-                <a:ext cx="8843212" cy="4872789"/>
+                <a:ext cx="9298406" cy="4872789"/>
               </a:xfrm>
               <a:blipFill>
                 <a:blip r:embed="rId3"/>
                 <a:stretch>
-                  <a:fillRect l="-966" t="-1750"/>
+                  <a:fillRect l="-918" t="-1750" r="-984"/>
                 </a:stretch>
               </a:blipFill>
             </p:spPr>
@@ -29607,7 +31123,7 @@
 </p:sld>
 </file>
 
-<file path=ppt/slides/slide42.xml><?xml version="1.0" encoding="utf-8"?>
+<file path=ppt/slides/slide45.xml><?xml version="1.0" encoding="utf-8"?>
 <p:sld xmlns:a="http://schemas.openxmlformats.org/drawingml/2006/main" xmlns:r="http://schemas.openxmlformats.org/officeDocument/2006/relationships" xmlns:p="http://schemas.openxmlformats.org/presentationml/2006/main">
   <p:cSld>
     <p:spTree>
@@ -29615,7 +31131,7 @@
         <p:cNvPr id="1" name="">
           <a:extLst>
             <a:ext uri="{FF2B5EF4-FFF2-40B4-BE49-F238E27FC236}">
-              <a16:creationId xmlns:a16="http://schemas.microsoft.com/office/drawing/2014/main" id="{247ACADE-A840-3BE9-33C2-2379B4027FDA}"/>
+              <a16:creationId xmlns:a16="http://schemas.microsoft.com/office/drawing/2014/main" id="{CAF22364-CE4F-53F7-1CED-9B12D009F61D}"/>
             </a:ext>
           </a:extLst>
         </p:cNvPr>
@@ -29635,7 +31151,7 @@
           <p:cNvPr id="5" name="Retângulo 4">
             <a:extLst>
               <a:ext uri="{FF2B5EF4-FFF2-40B4-BE49-F238E27FC236}">
-                <a16:creationId xmlns:a16="http://schemas.microsoft.com/office/drawing/2014/main" id="{5D6F4223-B114-1B64-C5A5-94547D50A986}"/>
+                <a16:creationId xmlns:a16="http://schemas.microsoft.com/office/drawing/2014/main" id="{0B77802D-59C3-5687-98E5-A6B11F70B9A2}"/>
               </a:ext>
             </a:extLst>
           </p:cNvPr>
@@ -29689,7 +31205,7 @@
           <p:cNvPr id="2" name="Título 1">
             <a:extLst>
               <a:ext uri="{FF2B5EF4-FFF2-40B4-BE49-F238E27FC236}">
-                <a16:creationId xmlns:a16="http://schemas.microsoft.com/office/drawing/2014/main" id="{A8DB634D-98C2-7C53-CE8C-88718DA1DEDA}"/>
+                <a16:creationId xmlns:a16="http://schemas.microsoft.com/office/drawing/2014/main" id="{A605C12C-41E5-56BD-2CD5-0E25CB724BE2}"/>
               </a:ext>
             </a:extLst>
           </p:cNvPr>
@@ -29717,7 +31233,7 @@
                   <a:schemeClr val="bg1"/>
                 </a:solidFill>
               </a:rPr>
-              <a:t>FIXAÇÃO - DESAFIO</a:t>
+              <a:t>LEIS E POSTULADOS PADRÃO</a:t>
             </a:r>
           </a:p>
         </p:txBody>
@@ -29727,7 +31243,7 @@
           <p:cNvPr id="6" name="Espaço Reservado para Conteúdo 5">
             <a:extLst>
               <a:ext uri="{FF2B5EF4-FFF2-40B4-BE49-F238E27FC236}">
-                <a16:creationId xmlns:a16="http://schemas.microsoft.com/office/drawing/2014/main" id="{D169E136-FFE4-8C03-85FE-9C8A6D6859BD}"/>
+                <a16:creationId xmlns:a16="http://schemas.microsoft.com/office/drawing/2014/main" id="{F3BB1B94-3017-A8A4-E92D-8576D759EA79}"/>
               </a:ext>
             </a:extLst>
           </p:cNvPr>
@@ -29740,8 +31256,8 @@
         </p:nvSpPr>
         <p:spPr>
           <a:xfrm>
-            <a:off x="1758950" y="1817914"/>
-            <a:ext cx="8888997" cy="4669971"/>
+            <a:off x="1446797" y="1607076"/>
+            <a:ext cx="9298406" cy="4872789"/>
           </a:xfrm>
         </p:spPr>
         <p:txBody>
@@ -29750,101 +31266,968 @@
           </a:bodyPr>
           <a:lstStyle/>
           <a:p>
-            <a:pPr marL="457200" indent="-457200" algn="just">
+            <a:pPr algn="ctr"/>
+            <a:r>
+              <a:rPr lang="pt-BR" sz="2200" b="1" dirty="0"/>
+              <a:t>Identidade</a:t>
+            </a:r>
+            <a:r>
+              <a:rPr lang="pt-BR" sz="2200" dirty="0"/>
+              <a:t>: A + 0 = A e A ⋅ 1 = A</a:t>
+            </a:r>
+          </a:p>
+          <a:p>
+            <a:pPr algn="ctr"/>
+            <a:endParaRPr lang="pt-BR" sz="2200" b="1" dirty="0"/>
+          </a:p>
+          <a:p>
+            <a:pPr algn="ctr"/>
+            <a:r>
+              <a:rPr lang="pt-BR" sz="2200" b="1" dirty="0"/>
+              <a:t>Anulação</a:t>
+            </a:r>
+            <a:r>
+              <a:rPr lang="pt-BR" sz="2200" dirty="0"/>
+              <a:t>: A + 1 = 1 e A ⋅ 0 = 0</a:t>
+            </a:r>
+          </a:p>
+          <a:p>
+            <a:pPr algn="ctr"/>
+            <a:endParaRPr lang="pt-BR" sz="2200" b="1" dirty="0"/>
+          </a:p>
+          <a:p>
+            <a:pPr algn="ctr"/>
+            <a:r>
+              <a:rPr lang="pt-BR" sz="2200" b="1" dirty="0"/>
+              <a:t>Idempotência</a:t>
+            </a:r>
+            <a:r>
+              <a:rPr lang="pt-BR" sz="2200" dirty="0"/>
+              <a:t>: A + A = A e A ⋅ A = A</a:t>
+            </a:r>
+          </a:p>
+          <a:p>
+            <a:pPr algn="ctr"/>
+            <a:endParaRPr lang="pt-BR" sz="2200" b="1" dirty="0"/>
+          </a:p>
+          <a:p>
+            <a:pPr algn="ctr"/>
+            <a:r>
+              <a:rPr lang="pt-BR" sz="2200" b="1" dirty="0"/>
+              <a:t>Complementaridade</a:t>
+            </a:r>
+            <a:r>
+              <a:rPr lang="pt-BR" sz="2200" dirty="0"/>
+              <a:t>: A + A' = 1 e A ⋅ A' = 0</a:t>
+            </a:r>
+          </a:p>
+          <a:p>
+            <a:pPr algn="ctr"/>
+            <a:endParaRPr lang="pt-BR" sz="2200" b="1" dirty="0"/>
+          </a:p>
+          <a:p>
+            <a:pPr algn="ctr"/>
+            <a:r>
+              <a:rPr lang="pt-BR" sz="2200" b="1" dirty="0"/>
+              <a:t>Dupla Negação</a:t>
+            </a:r>
+            <a:r>
+              <a:rPr lang="pt-BR" sz="2200" dirty="0"/>
+              <a:t>: (A')' = A</a:t>
+            </a:r>
+          </a:p>
+          <a:p>
+            <a:pPr algn="ctr"/>
+            <a:endParaRPr lang="pt-BR" sz="2200" b="1" dirty="0"/>
+          </a:p>
+          <a:p>
+            <a:pPr algn="ctr"/>
+            <a:r>
+              <a:rPr lang="pt-BR" sz="2200" b="1" dirty="0"/>
+              <a:t>Leis de </a:t>
+            </a:r>
+            <a:r>
+              <a:rPr lang="pt-BR" sz="2200" b="1" dirty="0" err="1"/>
+              <a:t>De</a:t>
+            </a:r>
+            <a:r>
+              <a:rPr lang="pt-BR" sz="2200" b="1" dirty="0"/>
+              <a:t> Morgan: </a:t>
+            </a:r>
+            <a:r>
+              <a:rPr lang="pt-BR" sz="2200" dirty="0"/>
+              <a:t>(A + B)' = A' ⋅ B’ e (AB)’ = A' + B'</a:t>
+            </a:r>
+          </a:p>
+          <a:p>
+            <a:pPr lvl="1" algn="just"/>
+            <a:endParaRPr lang="pt-BR" sz="2000" dirty="0"/>
+          </a:p>
+          <a:p>
+            <a:pPr marL="914400" lvl="1" indent="-457200" algn="just">
               <a:buFont typeface="+mj-lt"/>
               <a:buAutoNum type="arabicPeriod"/>
             </a:pPr>
-            <a:r>
-              <a:rPr lang="pt-BR" sz="2400" dirty="0"/>
-              <a:t>Considerando que a logica proposicional trabalha essencialmente com conjunções, disjunções e negações. Como poderíamos representar a </a:t>
-            </a:r>
-            <a:r>
-              <a:rPr lang="pt-BR" sz="2400" b="1" dirty="0"/>
-              <a:t>condicional</a:t>
-            </a:r>
-            <a:r>
-              <a:rPr lang="pt-BR" sz="2400" dirty="0"/>
-              <a:t>, a </a:t>
-            </a:r>
-            <a:r>
-              <a:rPr lang="pt-BR" sz="2400" b="1" dirty="0" err="1"/>
-              <a:t>bi-condicional</a:t>
-            </a:r>
-            <a:r>
-              <a:rPr lang="pt-BR" sz="2400" dirty="0"/>
-              <a:t> e a </a:t>
-            </a:r>
-            <a:r>
-              <a:rPr lang="pt-BR" sz="2400" b="1" dirty="0"/>
-              <a:t>disjunção exclusiva</a:t>
-            </a:r>
-            <a:r>
-              <a:rPr lang="pt-BR" sz="2400" dirty="0"/>
-              <a:t>, dentro das formas normais?</a:t>
-            </a:r>
-          </a:p>
-          <a:p>
-            <a:pPr marL="457200" indent="-457200" algn="just">
-              <a:buFont typeface="+mj-lt"/>
-              <a:buAutoNum type="arabicPeriod"/>
-            </a:pPr>
-            <a:endParaRPr lang="pt-BR" sz="2400" dirty="0"/>
-          </a:p>
-          <a:p>
-            <a:pPr marL="457200" indent="-457200" algn="just">
-              <a:buFont typeface="+mj-lt"/>
-              <a:buAutoNum type="arabicPeriod"/>
-            </a:pPr>
-            <a:r>
-              <a:rPr lang="pt-BR" sz="2400" dirty="0"/>
-              <a:t>Simplifique as expressões:</a:t>
-            </a:r>
-          </a:p>
-          <a:p>
-            <a:pPr marL="0" indent="0" algn="just">
+            <a:endParaRPr lang="pt-BR" b="1" i="1" dirty="0">
+              <a:latin typeface="Cambria Math" panose="02040503050406030204" pitchFamily="18" charset="0"/>
+            </a:endParaRPr>
+          </a:p>
+          <a:p>
+            <a:pPr marL="457200" lvl="1" indent="0" algn="ctr">
               <a:buNone/>
             </a:pPr>
-            <a:r>
-              <a:rPr lang="pt-BR" sz="2400" dirty="0"/>
-              <a:t> </a:t>
+            <a:endParaRPr lang="pt-BR" b="1" dirty="0"/>
+          </a:p>
+          <a:p>
+            <a:pPr marL="457200" lvl="1" indent="0" algn="just">
+              <a:buNone/>
+            </a:pPr>
+            <a:endParaRPr lang="pt-BR" b="1" dirty="0"/>
+          </a:p>
+        </p:txBody>
+      </p:sp>
+    </p:spTree>
+    <p:extLst>
+      <p:ext uri="{BB962C8B-B14F-4D97-AF65-F5344CB8AC3E}">
+        <p14:creationId xmlns:p14="http://schemas.microsoft.com/office/powerpoint/2010/main" val="1704924192"/>
+      </p:ext>
+    </p:extLst>
+  </p:cSld>
+  <p:clrMapOvr>
+    <a:masterClrMapping/>
+  </p:clrMapOvr>
+</p:sld>
+</file>
+
+<file path=ppt/slides/slide46.xml><?xml version="1.0" encoding="utf-8"?>
+<p:sld xmlns:a="http://schemas.openxmlformats.org/drawingml/2006/main" xmlns:r="http://schemas.openxmlformats.org/officeDocument/2006/relationships" xmlns:p="http://schemas.openxmlformats.org/presentationml/2006/main">
+  <p:cSld>
+    <p:spTree>
+      <p:nvGrpSpPr>
+        <p:cNvPr id="1" name="">
+          <a:extLst>
+            <a:ext uri="{FF2B5EF4-FFF2-40B4-BE49-F238E27FC236}">
+              <a16:creationId xmlns:a16="http://schemas.microsoft.com/office/drawing/2014/main" id="{4C4D4808-FAC2-5E6B-6EAA-D0BE8DD3A90A}"/>
+            </a:ext>
+          </a:extLst>
+        </p:cNvPr>
+        <p:cNvGrpSpPr/>
+        <p:nvPr/>
+      </p:nvGrpSpPr>
+      <p:grpSpPr>
+        <a:xfrm>
+          <a:off x="0" y="0"/>
+          <a:ext cx="0" cy="0"/>
+          <a:chOff x="0" y="0"/>
+          <a:chExt cx="0" cy="0"/>
+        </a:xfrm>
+      </p:grpSpPr>
+      <p:sp>
+        <p:nvSpPr>
+          <p:cNvPr id="2" name="Título 1">
+            <a:extLst>
+              <a:ext uri="{FF2B5EF4-FFF2-40B4-BE49-F238E27FC236}">
+                <a16:creationId xmlns:a16="http://schemas.microsoft.com/office/drawing/2014/main" id="{906418A5-5376-7BBF-9F35-806702DDB96C}"/>
+              </a:ext>
+            </a:extLst>
+          </p:cNvPr>
+          <p:cNvSpPr>
+            <a:spLocks noGrp="1"/>
+          </p:cNvSpPr>
+          <p:nvPr>
+            <p:ph type="ctrTitle"/>
+          </p:nvPr>
+        </p:nvSpPr>
+        <p:spPr>
+          <a:xfrm>
+            <a:off x="0" y="2524919"/>
+            <a:ext cx="12192000" cy="1808162"/>
+          </a:xfrm>
+          <a:ln>
+            <a:noFill/>
+          </a:ln>
+        </p:spPr>
+        <p:txBody>
+          <a:bodyPr/>
+          <a:lstStyle/>
+          <a:p>
+            <a:r>
+              <a:rPr lang="pt-BR" dirty="0">
+                <a:solidFill>
+                  <a:schemeClr val="bg1"/>
+                </a:solidFill>
+              </a:rPr>
+              <a:t>módulo 5 – Argumentos e inferência</a:t>
+            </a:r>
+          </a:p>
+        </p:txBody>
+      </p:sp>
+      <p:sp>
+        <p:nvSpPr>
+          <p:cNvPr id="3" name="Subtítulo 2">
+            <a:extLst>
+              <a:ext uri="{FF2B5EF4-FFF2-40B4-BE49-F238E27FC236}">
+                <a16:creationId xmlns:a16="http://schemas.microsoft.com/office/drawing/2014/main" id="{47839367-DBBC-0929-46C0-38B5C30CF807}"/>
+              </a:ext>
+            </a:extLst>
+          </p:cNvPr>
+          <p:cNvSpPr>
+            <a:spLocks noGrp="1"/>
+          </p:cNvSpPr>
+          <p:nvPr>
+            <p:ph type="subTitle" idx="1"/>
+          </p:nvPr>
+        </p:nvSpPr>
+        <p:spPr>
+          <a:xfrm>
+            <a:off x="2695192" y="5207000"/>
+            <a:ext cx="6801612" cy="1651000"/>
+          </a:xfrm>
+        </p:spPr>
+        <p:txBody>
+          <a:bodyPr/>
+          <a:lstStyle/>
+          <a:p>
+            <a:r>
+              <a:rPr lang="pt-BR" dirty="0"/>
+              <a:t>Universidade de Uberaba</a:t>
+            </a:r>
+          </a:p>
+          <a:p>
+            <a:r>
+              <a:rPr lang="pt-BR" dirty="0"/>
+              <a:t>Marcio Salmazo Ramos</a:t>
             </a:r>
           </a:p>
         </p:txBody>
       </p:sp>
       <p:pic>
         <p:nvPicPr>
-          <p:cNvPr id="3" name="Imagem 2">
-            <a:extLst>
-              <a:ext uri="{FF2B5EF4-FFF2-40B4-BE49-F238E27FC236}">
-                <a16:creationId xmlns:a16="http://schemas.microsoft.com/office/drawing/2014/main" id="{47F2354F-9002-B04F-3F3B-CD5583E0DED6}"/>
+          <p:cNvPr id="8194" name="Picture 2">
+            <a:extLst>
+              <a:ext uri="{FF2B5EF4-FFF2-40B4-BE49-F238E27FC236}">
+                <a16:creationId xmlns:a16="http://schemas.microsoft.com/office/drawing/2014/main" id="{F9792D5E-A143-C9FA-F3E6-E3670686329E}"/>
               </a:ext>
             </a:extLst>
           </p:cNvPr>
           <p:cNvPicPr>
-            <a:picLocks noChangeAspect="1"/>
+            <a:picLocks noChangeAspect="1" noChangeArrowheads="1"/>
           </p:cNvPicPr>
           <p:nvPr/>
         </p:nvPicPr>
         <p:blipFill>
-          <a:blip r:embed="rId3"/>
+          <a:blip r:embed="rId3">
+            <a:extLst>
+              <a:ext uri="{28A0092B-C50C-407E-A947-70E740481C1C}">
+                <a14:useLocalDpi xmlns:a14="http://schemas.microsoft.com/office/drawing/2010/main" val="0"/>
+              </a:ext>
+            </a:extLst>
+          </a:blip>
+          <a:srcRect/>
           <a:stretch>
             <a:fillRect/>
           </a:stretch>
         </p:blipFill>
-        <p:spPr>
+        <p:spPr bwMode="auto">
           <a:xfrm>
-            <a:off x="2455673" y="4412643"/>
-            <a:ext cx="7495550" cy="2445357"/>
+            <a:off x="4337048" y="447153"/>
+            <a:ext cx="3517900" cy="972919"/>
           </a:xfrm>
           <a:prstGeom prst="rect">
             <a:avLst/>
           </a:prstGeom>
+          <a:noFill/>
+          <a:extLst>
+            <a:ext uri="{909E8E84-426E-40DD-AFC4-6F175D3DCCD1}">
+              <a14:hiddenFill xmlns:a14="http://schemas.microsoft.com/office/drawing/2010/main">
+                <a:solidFill>
+                  <a:srgbClr val="FFFFFF"/>
+                </a:solidFill>
+              </a14:hiddenFill>
+            </a:ext>
+          </a:extLst>
         </p:spPr>
       </p:pic>
     </p:spTree>
     <p:extLst>
       <p:ext uri="{BB962C8B-B14F-4D97-AF65-F5344CB8AC3E}">
-        <p14:creationId xmlns:p14="http://schemas.microsoft.com/office/powerpoint/2010/main" val="3630648018"/>
+        <p14:creationId xmlns:p14="http://schemas.microsoft.com/office/powerpoint/2010/main" val="3052628347"/>
+      </p:ext>
+    </p:extLst>
+  </p:cSld>
+  <p:clrMapOvr>
+    <a:masterClrMapping/>
+  </p:clrMapOvr>
+</p:sld>
+</file>
+
+<file path=ppt/slides/slide47.xml><?xml version="1.0" encoding="utf-8"?>
+<p:sld xmlns:a="http://schemas.openxmlformats.org/drawingml/2006/main" xmlns:r="http://schemas.openxmlformats.org/officeDocument/2006/relationships" xmlns:p="http://schemas.openxmlformats.org/presentationml/2006/main">
+  <p:cSld>
+    <p:spTree>
+      <p:nvGrpSpPr>
+        <p:cNvPr id="1" name="">
+          <a:extLst>
+            <a:ext uri="{FF2B5EF4-FFF2-40B4-BE49-F238E27FC236}">
+              <a16:creationId xmlns:a16="http://schemas.microsoft.com/office/drawing/2014/main" id="{EAB86C0B-3819-7E72-25A2-90A8275368DA}"/>
+            </a:ext>
+          </a:extLst>
+        </p:cNvPr>
+        <p:cNvGrpSpPr/>
+        <p:nvPr/>
+      </p:nvGrpSpPr>
+      <p:grpSpPr>
+        <a:xfrm>
+          <a:off x="0" y="0"/>
+          <a:ext cx="0" cy="0"/>
+          <a:chOff x="0" y="0"/>
+          <a:chExt cx="0" cy="0"/>
+        </a:xfrm>
+      </p:grpSpPr>
+      <p:sp>
+        <p:nvSpPr>
+          <p:cNvPr id="5" name="Retângulo 4">
+            <a:extLst>
+              <a:ext uri="{FF2B5EF4-FFF2-40B4-BE49-F238E27FC236}">
+                <a16:creationId xmlns:a16="http://schemas.microsoft.com/office/drawing/2014/main" id="{89333410-68F3-ED49-AF26-E642CBF1A45E}"/>
+              </a:ext>
+            </a:extLst>
+          </p:cNvPr>
+          <p:cNvSpPr/>
+          <p:nvPr/>
+        </p:nvSpPr>
+        <p:spPr>
+          <a:xfrm>
+            <a:off x="0" y="-2"/>
+            <a:ext cx="12192000" cy="1325563"/>
+          </a:xfrm>
+          <a:prstGeom prst="rect">
+            <a:avLst/>
+          </a:prstGeom>
+          <a:solidFill>
+            <a:schemeClr val="accent2"/>
+          </a:solidFill>
+          <a:ln>
+            <a:solidFill>
+              <a:srgbClr val="418AB3"/>
+            </a:solidFill>
+          </a:ln>
+        </p:spPr>
+        <p:style>
+          <a:lnRef idx="2">
+            <a:schemeClr val="accent1">
+              <a:shade val="15000"/>
+            </a:schemeClr>
+          </a:lnRef>
+          <a:fillRef idx="1">
+            <a:schemeClr val="accent1"/>
+          </a:fillRef>
+          <a:effectRef idx="0">
+            <a:schemeClr val="accent1"/>
+          </a:effectRef>
+          <a:fontRef idx="minor">
+            <a:schemeClr val="lt1"/>
+          </a:fontRef>
+        </p:style>
+        <p:txBody>
+          <a:bodyPr rtlCol="0" anchor="ctr"/>
+          <a:lstStyle/>
+          <a:p>
+            <a:pPr algn="ctr"/>
+            <a:endParaRPr lang="pt-BR" dirty="0"/>
+          </a:p>
+        </p:txBody>
+      </p:sp>
+      <p:sp>
+        <p:nvSpPr>
+          <p:cNvPr id="2" name="Título 1">
+            <a:extLst>
+              <a:ext uri="{FF2B5EF4-FFF2-40B4-BE49-F238E27FC236}">
+                <a16:creationId xmlns:a16="http://schemas.microsoft.com/office/drawing/2014/main" id="{B791E590-08C9-E152-C803-4903EAB2C254}"/>
+              </a:ext>
+            </a:extLst>
+          </p:cNvPr>
+          <p:cNvSpPr>
+            <a:spLocks noGrp="1"/>
+          </p:cNvSpPr>
+          <p:nvPr>
+            <p:ph type="title"/>
+          </p:nvPr>
+        </p:nvSpPr>
+        <p:spPr>
+          <a:xfrm>
+            <a:off x="0" y="-1"/>
+            <a:ext cx="12192000" cy="1325563"/>
+          </a:xfrm>
+        </p:spPr>
+        <p:txBody>
+          <a:bodyPr/>
+          <a:lstStyle/>
+          <a:p>
+            <a:pPr algn="ctr"/>
+            <a:r>
+              <a:rPr lang="pt-BR" dirty="0">
+                <a:solidFill>
+                  <a:schemeClr val="bg1"/>
+                </a:solidFill>
+              </a:rPr>
+              <a:t>INFERÊNCIA LÓGICA</a:t>
+            </a:r>
+          </a:p>
+        </p:txBody>
+      </p:sp>
+      <p:sp>
+        <p:nvSpPr>
+          <p:cNvPr id="6" name="Espaço Reservado para Conteúdo 5">
+            <a:extLst>
+              <a:ext uri="{FF2B5EF4-FFF2-40B4-BE49-F238E27FC236}">
+                <a16:creationId xmlns:a16="http://schemas.microsoft.com/office/drawing/2014/main" id="{F4777E57-674A-1D72-B62D-0951C250757F}"/>
+              </a:ext>
+            </a:extLst>
+          </p:cNvPr>
+          <p:cNvSpPr>
+            <a:spLocks noGrp="1"/>
+          </p:cNvSpPr>
+          <p:nvPr>
+            <p:ph idx="1"/>
+          </p:nvPr>
+        </p:nvSpPr>
+        <p:spPr>
+          <a:xfrm>
+            <a:off x="1446797" y="2271104"/>
+            <a:ext cx="9298406" cy="3258839"/>
+          </a:xfrm>
+        </p:spPr>
+        <p:txBody>
+          <a:bodyPr>
+            <a:normAutofit/>
+          </a:bodyPr>
+          <a:lstStyle/>
+          <a:p>
+            <a:r>
+              <a:rPr lang="pt-BR" sz="2400" dirty="0"/>
+              <a:t>Aqui a lógica deixa de ser apenas "calcular o valor de uma expressão" e passa a responder à seguinte pergunta:</a:t>
+            </a:r>
+          </a:p>
+          <a:p>
+            <a:pPr lvl="1"/>
+            <a:endParaRPr lang="pt-BR" sz="2200" dirty="0"/>
+          </a:p>
+          <a:p>
+            <a:pPr lvl="1"/>
+            <a:r>
+              <a:rPr lang="pt-BR" sz="2200" i="1" dirty="0"/>
+              <a:t>A partir de algumas afirmações que sabemos serem verdadeiras, podemos concluir que outra afirmação também é verdadeira?</a:t>
+            </a:r>
+          </a:p>
+          <a:p>
+            <a:pPr lvl="1"/>
+            <a:endParaRPr lang="pt-BR" sz="2200" i="1" dirty="0"/>
+          </a:p>
+          <a:p>
+            <a:r>
+              <a:rPr lang="pt-BR" sz="2400" dirty="0"/>
+              <a:t>Com isso, a inferência lógica consiste no processo de </a:t>
+            </a:r>
+            <a:r>
+              <a:rPr lang="pt-BR" sz="2400" b="1" dirty="0"/>
+              <a:t>obter uma conclusão a partir de informações previamente conhecidas</a:t>
+            </a:r>
+            <a:r>
+              <a:rPr lang="pt-BR" sz="2400" dirty="0"/>
+              <a:t>.</a:t>
+            </a:r>
+          </a:p>
+          <a:p>
+            <a:pPr lvl="1" algn="just"/>
+            <a:endParaRPr lang="pt-BR" sz="2000" dirty="0"/>
+          </a:p>
+          <a:p>
+            <a:pPr marL="0" indent="0" algn="just">
+              <a:buNone/>
+            </a:pPr>
+            <a:endParaRPr lang="pt-BR" sz="2400" dirty="0">
+              <a:latin typeface="Cambria Math" panose="02040503050406030204" pitchFamily="18" charset="0"/>
+            </a:endParaRPr>
+          </a:p>
+          <a:p>
+            <a:pPr marL="457200" lvl="1" indent="0" algn="just">
+              <a:buNone/>
+            </a:pPr>
+            <a:endParaRPr lang="pt-BR" b="1" dirty="0"/>
+          </a:p>
+          <a:p>
+            <a:pPr marL="457200" lvl="1" indent="0" algn="just">
+              <a:buNone/>
+            </a:pPr>
+            <a:endParaRPr lang="pt-BR" b="1" dirty="0"/>
+          </a:p>
+        </p:txBody>
+      </p:sp>
+    </p:spTree>
+    <p:extLst>
+      <p:ext uri="{BB962C8B-B14F-4D97-AF65-F5344CB8AC3E}">
+        <p14:creationId xmlns:p14="http://schemas.microsoft.com/office/powerpoint/2010/main" val="1180920932"/>
+      </p:ext>
+    </p:extLst>
+  </p:cSld>
+  <p:clrMapOvr>
+    <a:masterClrMapping/>
+  </p:clrMapOvr>
+</p:sld>
+</file>
+
+<file path=ppt/slides/slide48.xml><?xml version="1.0" encoding="utf-8"?>
+<p:sld xmlns:a="http://schemas.openxmlformats.org/drawingml/2006/main" xmlns:r="http://schemas.openxmlformats.org/officeDocument/2006/relationships" xmlns:p="http://schemas.openxmlformats.org/presentationml/2006/main">
+  <p:cSld>
+    <p:spTree>
+      <p:nvGrpSpPr>
+        <p:cNvPr id="1" name="">
+          <a:extLst>
+            <a:ext uri="{FF2B5EF4-FFF2-40B4-BE49-F238E27FC236}">
+              <a16:creationId xmlns:a16="http://schemas.microsoft.com/office/drawing/2014/main" id="{2EE8CD13-1C29-E7A2-D293-4072DA8BAD9F}"/>
+            </a:ext>
+          </a:extLst>
+        </p:cNvPr>
+        <p:cNvGrpSpPr/>
+        <p:nvPr/>
+      </p:nvGrpSpPr>
+      <p:grpSpPr>
+        <a:xfrm>
+          <a:off x="0" y="0"/>
+          <a:ext cx="0" cy="0"/>
+          <a:chOff x="0" y="0"/>
+          <a:chExt cx="0" cy="0"/>
+        </a:xfrm>
+      </p:grpSpPr>
+      <p:sp>
+        <p:nvSpPr>
+          <p:cNvPr id="5" name="Retângulo 4">
+            <a:extLst>
+              <a:ext uri="{FF2B5EF4-FFF2-40B4-BE49-F238E27FC236}">
+                <a16:creationId xmlns:a16="http://schemas.microsoft.com/office/drawing/2014/main" id="{6423B9B0-4AFC-21AB-B19C-E39BA7D08CA7}"/>
+              </a:ext>
+            </a:extLst>
+          </p:cNvPr>
+          <p:cNvSpPr/>
+          <p:nvPr/>
+        </p:nvSpPr>
+        <p:spPr>
+          <a:xfrm>
+            <a:off x="0" y="-2"/>
+            <a:ext cx="12192000" cy="1325563"/>
+          </a:xfrm>
+          <a:prstGeom prst="rect">
+            <a:avLst/>
+          </a:prstGeom>
+          <a:solidFill>
+            <a:schemeClr val="accent2"/>
+          </a:solidFill>
+          <a:ln>
+            <a:solidFill>
+              <a:srgbClr val="418AB3"/>
+            </a:solidFill>
+          </a:ln>
+        </p:spPr>
+        <p:style>
+          <a:lnRef idx="2">
+            <a:schemeClr val="accent1">
+              <a:shade val="15000"/>
+            </a:schemeClr>
+          </a:lnRef>
+          <a:fillRef idx="1">
+            <a:schemeClr val="accent1"/>
+          </a:fillRef>
+          <a:effectRef idx="0">
+            <a:schemeClr val="accent1"/>
+          </a:effectRef>
+          <a:fontRef idx="minor">
+            <a:schemeClr val="lt1"/>
+          </a:fontRef>
+        </p:style>
+        <p:txBody>
+          <a:bodyPr rtlCol="0" anchor="ctr"/>
+          <a:lstStyle/>
+          <a:p>
+            <a:pPr algn="ctr"/>
+            <a:endParaRPr lang="pt-BR" dirty="0"/>
+          </a:p>
+        </p:txBody>
+      </p:sp>
+      <p:sp>
+        <p:nvSpPr>
+          <p:cNvPr id="2" name="Título 1">
+            <a:extLst>
+              <a:ext uri="{FF2B5EF4-FFF2-40B4-BE49-F238E27FC236}">
+                <a16:creationId xmlns:a16="http://schemas.microsoft.com/office/drawing/2014/main" id="{C3144840-C46E-CE0C-8247-D71295A85309}"/>
+              </a:ext>
+            </a:extLst>
+          </p:cNvPr>
+          <p:cNvSpPr>
+            <a:spLocks noGrp="1"/>
+          </p:cNvSpPr>
+          <p:nvPr>
+            <p:ph type="title"/>
+          </p:nvPr>
+        </p:nvSpPr>
+        <p:spPr>
+          <a:xfrm>
+            <a:off x="0" y="-1"/>
+            <a:ext cx="12192000" cy="1325563"/>
+          </a:xfrm>
+        </p:spPr>
+        <p:txBody>
+          <a:bodyPr/>
+          <a:lstStyle/>
+          <a:p>
+            <a:pPr algn="ctr"/>
+            <a:r>
+              <a:rPr lang="pt-BR" dirty="0">
+                <a:solidFill>
+                  <a:schemeClr val="bg1"/>
+                </a:solidFill>
+              </a:rPr>
+              <a:t>INFERÊNCIA LÓGICA</a:t>
+            </a:r>
+          </a:p>
+        </p:txBody>
+      </p:sp>
+      <p:sp>
+        <p:nvSpPr>
+          <p:cNvPr id="6" name="Espaço Reservado para Conteúdo 5">
+            <a:extLst>
+              <a:ext uri="{FF2B5EF4-FFF2-40B4-BE49-F238E27FC236}">
+                <a16:creationId xmlns:a16="http://schemas.microsoft.com/office/drawing/2014/main" id="{C396114B-E89B-0C00-0340-EAE46B390C95}"/>
+              </a:ext>
+            </a:extLst>
+          </p:cNvPr>
+          <p:cNvSpPr>
+            <a:spLocks noGrp="1"/>
+          </p:cNvSpPr>
+          <p:nvPr>
+            <p:ph idx="1"/>
+          </p:nvPr>
+        </p:nvSpPr>
+        <p:spPr>
+          <a:xfrm>
+            <a:off x="1446797" y="1905000"/>
+            <a:ext cx="9298406" cy="4332514"/>
+          </a:xfrm>
+        </p:spPr>
+        <p:txBody>
+          <a:bodyPr>
+            <a:normAutofit/>
+          </a:bodyPr>
+          <a:lstStyle/>
+          <a:p>
+            <a:r>
+              <a:rPr lang="pt-BR" sz="2400" dirty="0"/>
+              <a:t>Exemplo:</a:t>
+            </a:r>
+          </a:p>
+          <a:p>
+            <a:endParaRPr lang="pt-BR" sz="2400" dirty="0"/>
+          </a:p>
+          <a:p>
+            <a:pPr lvl="1">
+              <a:buFont typeface="Courier New" panose="02070309020205020404" pitchFamily="49" charset="0"/>
+              <a:buChar char="o"/>
+            </a:pPr>
+            <a:r>
+              <a:rPr lang="pt-BR" sz="2000" dirty="0"/>
+              <a:t>P – Está chovendo</a:t>
+            </a:r>
+          </a:p>
+          <a:p>
+            <a:pPr lvl="1">
+              <a:buFont typeface="Courier New" panose="02070309020205020404" pitchFamily="49" charset="0"/>
+              <a:buChar char="o"/>
+            </a:pPr>
+            <a:r>
+              <a:rPr lang="pt-BR" sz="2000" dirty="0"/>
+              <a:t>Q </a:t>
+            </a:r>
+            <a:r>
+              <a:rPr lang="pt-BR" sz="2000" dirty="0">
+                <a:sym typeface="Wingdings" panose="05000000000000000000" pitchFamily="2" charset="2"/>
+              </a:rPr>
+              <a:t>– A rua está molhada</a:t>
+            </a:r>
+            <a:endParaRPr lang="pt-BR" sz="2000" dirty="0"/>
+          </a:p>
+          <a:p>
+            <a:pPr lvl="1">
+              <a:buFont typeface="Courier New" panose="02070309020205020404" pitchFamily="49" charset="0"/>
+              <a:buChar char="o"/>
+            </a:pPr>
+            <a:r>
+              <a:rPr lang="pt-BR" sz="2000" dirty="0"/>
+              <a:t>Sentença: </a:t>
+            </a:r>
+            <a:r>
+              <a:rPr lang="pt-BR" sz="2000" i="1" dirty="0"/>
+              <a:t>“Se está chovendo, então a rua está molhada”</a:t>
+            </a:r>
+          </a:p>
+          <a:p>
+            <a:pPr lvl="1">
+              <a:buFont typeface="Courier New" panose="02070309020205020404" pitchFamily="49" charset="0"/>
+              <a:buChar char="o"/>
+            </a:pPr>
+            <a:endParaRPr lang="pt-BR" sz="2000" i="1" dirty="0"/>
+          </a:p>
+          <a:p>
+            <a:pPr lvl="1">
+              <a:buFont typeface="Courier New" panose="02070309020205020404" pitchFamily="49" charset="0"/>
+              <a:buChar char="o"/>
+            </a:pPr>
+            <a:r>
+              <a:rPr lang="pt-BR" sz="2000" u="sng" dirty="0"/>
+              <a:t>Considerando que temos o valor de P como verdadeiro, podemos </a:t>
+            </a:r>
+            <a:r>
+              <a:rPr lang="pt-BR" sz="2000" b="1" u="sng" dirty="0"/>
+              <a:t>inferir</a:t>
+            </a:r>
+            <a:r>
+              <a:rPr lang="pt-BR" sz="2000" u="sng" dirty="0"/>
+              <a:t> que Q também seja, uma vez que a rua fica molhada ao chover.</a:t>
+            </a:r>
+          </a:p>
+          <a:p>
+            <a:pPr lvl="1">
+              <a:buFont typeface="Courier New" panose="02070309020205020404" pitchFamily="49" charset="0"/>
+              <a:buChar char="o"/>
+            </a:pPr>
+            <a:endParaRPr lang="pt-BR" sz="2000" dirty="0"/>
+          </a:p>
+          <a:p>
+            <a:r>
+              <a:rPr lang="pt-BR" sz="2400" dirty="0"/>
+              <a:t>O processo de passar das premissas para a conclusão é uma inferência.</a:t>
+            </a:r>
+          </a:p>
+          <a:p>
+            <a:pPr>
+              <a:buFont typeface="Courier New" panose="02070309020205020404" pitchFamily="49" charset="0"/>
+              <a:buChar char="o"/>
+            </a:pPr>
+            <a:endParaRPr lang="pt-BR" sz="2400" dirty="0"/>
+          </a:p>
+          <a:p>
+            <a:pPr lvl="1" algn="just"/>
+            <a:endParaRPr lang="pt-BR" sz="2000" dirty="0"/>
+          </a:p>
+          <a:p>
+            <a:pPr marL="0" indent="0" algn="just">
+              <a:buNone/>
+            </a:pPr>
+            <a:endParaRPr lang="pt-BR" sz="2400" dirty="0">
+              <a:latin typeface="Cambria Math" panose="02040503050406030204" pitchFamily="18" charset="0"/>
+            </a:endParaRPr>
+          </a:p>
+          <a:p>
+            <a:pPr marL="457200" lvl="1" indent="0" algn="just">
+              <a:buNone/>
+            </a:pPr>
+            <a:endParaRPr lang="pt-BR" b="1" dirty="0"/>
+          </a:p>
+          <a:p>
+            <a:pPr marL="457200" lvl="1" indent="0" algn="just">
+              <a:buNone/>
+            </a:pPr>
+            <a:endParaRPr lang="pt-BR" b="1" dirty="0"/>
+          </a:p>
+        </p:txBody>
+      </p:sp>
+    </p:spTree>
+    <p:extLst>
+      <p:ext uri="{BB962C8B-B14F-4D97-AF65-F5344CB8AC3E}">
+        <p14:creationId xmlns:p14="http://schemas.microsoft.com/office/powerpoint/2010/main" val="3816638370"/>
+      </p:ext>
+    </p:extLst>
+  </p:cSld>
+  <p:clrMapOvr>
+    <a:masterClrMapping/>
+  </p:clrMapOvr>
+</p:sld>
+</file>
+
+<file path=ppt/slides/slide49.xml><?xml version="1.0" encoding="utf-8"?>
+<p:sld xmlns:a="http://schemas.openxmlformats.org/drawingml/2006/main" xmlns:r="http://schemas.openxmlformats.org/officeDocument/2006/relationships" xmlns:p="http://schemas.openxmlformats.org/presentationml/2006/main">
+  <p:cSld>
+    <p:spTree>
+      <p:nvGrpSpPr>
+        <p:cNvPr id="1" name="">
+          <a:extLst>
+            <a:ext uri="{FF2B5EF4-FFF2-40B4-BE49-F238E27FC236}">
+              <a16:creationId xmlns:a16="http://schemas.microsoft.com/office/drawing/2014/main" id="{CDDC8225-CB7C-D8E4-6B39-81C86F128712}"/>
+            </a:ext>
+          </a:extLst>
+        </p:cNvPr>
+        <p:cNvGrpSpPr/>
+        <p:nvPr/>
+      </p:nvGrpSpPr>
+      <p:grpSpPr>
+        <a:xfrm>
+          <a:off x="0" y="0"/>
+          <a:ext cx="0" cy="0"/>
+          <a:chOff x="0" y="0"/>
+          <a:chExt cx="0" cy="0"/>
+        </a:xfrm>
+      </p:grpSpPr>
+      <p:sp>
+        <p:nvSpPr>
+          <p:cNvPr id="5" name="Retângulo 4">
+            <a:extLst>
+              <a:ext uri="{FF2B5EF4-FFF2-40B4-BE49-F238E27FC236}">
+                <a16:creationId xmlns:a16="http://schemas.microsoft.com/office/drawing/2014/main" id="{C4E2E90F-C942-6A3A-08A4-1F32163D1B2F}"/>
+              </a:ext>
+            </a:extLst>
+          </p:cNvPr>
+          <p:cNvSpPr/>
+          <p:nvPr/>
+        </p:nvSpPr>
+        <p:spPr>
+          <a:xfrm>
+            <a:off x="0" y="-2"/>
+            <a:ext cx="12192000" cy="1325563"/>
+          </a:xfrm>
+          <a:prstGeom prst="rect">
+            <a:avLst/>
+          </a:prstGeom>
+          <a:solidFill>
+            <a:schemeClr val="accent2"/>
+          </a:solidFill>
+          <a:ln>
+            <a:solidFill>
+              <a:srgbClr val="418AB3"/>
+            </a:solidFill>
+          </a:ln>
+        </p:spPr>
+        <p:style>
+          <a:lnRef idx="2">
+            <a:schemeClr val="accent1">
+              <a:shade val="15000"/>
+            </a:schemeClr>
+          </a:lnRef>
+          <a:fillRef idx="1">
+            <a:schemeClr val="accent1"/>
+          </a:fillRef>
+          <a:effectRef idx="0">
+            <a:schemeClr val="accent1"/>
+          </a:effectRef>
+          <a:fontRef idx="minor">
+            <a:schemeClr val="lt1"/>
+          </a:fontRef>
+        </p:style>
+        <p:txBody>
+          <a:bodyPr rtlCol="0" anchor="ctr"/>
+          <a:lstStyle/>
+          <a:p>
+            <a:pPr algn="ctr"/>
+            <a:endParaRPr lang="pt-BR" dirty="0"/>
+          </a:p>
+        </p:txBody>
+      </p:sp>
+      <p:sp>
+        <p:nvSpPr>
+          <p:cNvPr id="2" name="Título 1">
+            <a:extLst>
+              <a:ext uri="{FF2B5EF4-FFF2-40B4-BE49-F238E27FC236}">
+                <a16:creationId xmlns:a16="http://schemas.microsoft.com/office/drawing/2014/main" id="{CE817FEA-2591-A19F-DE91-A7599886F6F7}"/>
+              </a:ext>
+            </a:extLst>
+          </p:cNvPr>
+          <p:cNvSpPr>
+            <a:spLocks noGrp="1"/>
+          </p:cNvSpPr>
+          <p:nvPr>
+            <p:ph type="title"/>
+          </p:nvPr>
+        </p:nvSpPr>
+        <p:spPr>
+          <a:xfrm>
+            <a:off x="0" y="-1"/>
+            <a:ext cx="12192000" cy="1325563"/>
+          </a:xfrm>
+        </p:spPr>
+        <p:txBody>
+          <a:bodyPr/>
+          <a:lstStyle/>
+          <a:p>
+            <a:pPr algn="ctr"/>
+            <a:r>
+              <a:rPr lang="pt-BR" dirty="0">
+                <a:solidFill>
+                  <a:schemeClr val="bg1"/>
+                </a:solidFill>
+              </a:rPr>
+              <a:t>ARGUMENTOS LÓGICOS</a:t>
+            </a:r>
+          </a:p>
+        </p:txBody>
+      </p:sp>
+      <p:sp>
+        <p:nvSpPr>
+          <p:cNvPr id="6" name="Espaço Reservado para Conteúdo 5">
+            <a:extLst>
+              <a:ext uri="{FF2B5EF4-FFF2-40B4-BE49-F238E27FC236}">
+                <a16:creationId xmlns:a16="http://schemas.microsoft.com/office/drawing/2014/main" id="{E4D97BB6-A782-DFE3-7183-433201FDCA59}"/>
+              </a:ext>
+            </a:extLst>
+          </p:cNvPr>
+          <p:cNvSpPr>
+            <a:spLocks noGrp="1"/>
+          </p:cNvSpPr>
+          <p:nvPr>
+            <p:ph idx="1"/>
+          </p:nvPr>
+        </p:nvSpPr>
+        <p:spPr>
+          <a:xfrm>
+            <a:off x="1446797" y="1905000"/>
+            <a:ext cx="9298406" cy="4332514"/>
+          </a:xfrm>
+        </p:spPr>
+        <p:txBody>
+          <a:bodyPr>
+            <a:normAutofit/>
+          </a:bodyPr>
+          <a:lstStyle/>
+          <a:p>
+            <a:endParaRPr lang="pt-BR" sz="2400" dirty="0"/>
+          </a:p>
+          <a:p>
+            <a:pPr lvl="1" algn="just"/>
+            <a:endParaRPr lang="pt-BR" sz="2000" dirty="0"/>
+          </a:p>
+          <a:p>
+            <a:pPr marL="0" indent="0" algn="just">
+              <a:buNone/>
+            </a:pPr>
+            <a:endParaRPr lang="pt-BR" sz="2400" dirty="0">
+              <a:latin typeface="Cambria Math" panose="02040503050406030204" pitchFamily="18" charset="0"/>
+            </a:endParaRPr>
+          </a:p>
+          <a:p>
+            <a:pPr marL="457200" lvl="1" indent="0" algn="just">
+              <a:buNone/>
+            </a:pPr>
+            <a:endParaRPr lang="pt-BR" b="1" dirty="0"/>
+          </a:p>
+          <a:p>
+            <a:pPr marL="457200" lvl="1" indent="0" algn="just">
+              <a:buNone/>
+            </a:pPr>
+            <a:endParaRPr lang="pt-BR" b="1" dirty="0"/>
+          </a:p>
+        </p:txBody>
+      </p:sp>
+    </p:spTree>
+    <p:extLst>
+      <p:ext uri="{BB962C8B-B14F-4D97-AF65-F5344CB8AC3E}">
+        <p14:creationId xmlns:p14="http://schemas.microsoft.com/office/powerpoint/2010/main" val="2462127983"/>
       </p:ext>
     </p:extLst>
   </p:cSld>

</xml_diff>

<commit_message>
Atualização de aulas PDI 15/08
</commit_message>
<xml_diff>
--- a/UNIUBE-MD/Teoria_MD.pptx
+++ b/UNIUBE-MD/Teoria_MD.pptx
@@ -6,7 +6,7 @@
     <p:sldMasterId id="2147483684" r:id="rId2"/>
   </p:sldMasterIdLst>
   <p:notesMasterIdLst>
-    <p:notesMasterId r:id="rId52"/>
+    <p:notesMasterId r:id="rId51"/>
   </p:notesMasterIdLst>
   <p:sldIdLst>
     <p:sldId id="256" r:id="rId3"/>
@@ -57,7 +57,6 @@
     <p:sldId id="336" r:id="rId48"/>
     <p:sldId id="337" r:id="rId49"/>
     <p:sldId id="338" r:id="rId50"/>
-    <p:sldId id="339" r:id="rId51"/>
   </p:sldIdLst>
   <p:sldSz cx="12192000" cy="6858000"/>
   <p:notesSz cx="6858000" cy="9144000"/>
@@ -246,7 +245,7 @@
           <a:p>
             <a:fld id="{6ED03497-8374-466E-85FA-95E1138D8F6E}" type="datetimeFigureOut">
               <a:rPr lang="pt-BR" smtClean="0"/>
-              <a:t>14/08/2026</a:t>
+              <a:t>15/08/2026</a:t>
             </a:fld>
             <a:endParaRPr lang="pt-BR"/>
           </a:p>
@@ -5971,125 +5970,6 @@
 </p:notes>
 </file>
 
-<file path=ppt/notesSlides/notesSlide49.xml><?xml version="1.0" encoding="utf-8"?>
-<p:notes xmlns:a="http://schemas.openxmlformats.org/drawingml/2006/main" xmlns:r="http://schemas.openxmlformats.org/officeDocument/2006/relationships" xmlns:p="http://schemas.openxmlformats.org/presentationml/2006/main">
-  <p:cSld>
-    <p:spTree>
-      <p:nvGrpSpPr>
-        <p:cNvPr id="1" name="">
-          <a:extLst>
-            <a:ext uri="{FF2B5EF4-FFF2-40B4-BE49-F238E27FC236}">
-              <a16:creationId xmlns:a16="http://schemas.microsoft.com/office/drawing/2014/main" id="{A3C6CC6D-0F93-CA41-B711-1D0404B3FEB3}"/>
-            </a:ext>
-          </a:extLst>
-        </p:cNvPr>
-        <p:cNvGrpSpPr/>
-        <p:nvPr/>
-      </p:nvGrpSpPr>
-      <p:grpSpPr>
-        <a:xfrm>
-          <a:off x="0" y="0"/>
-          <a:ext cx="0" cy="0"/>
-          <a:chOff x="0" y="0"/>
-          <a:chExt cx="0" cy="0"/>
-        </a:xfrm>
-      </p:grpSpPr>
-      <p:sp>
-        <p:nvSpPr>
-          <p:cNvPr id="2" name="Espaço Reservado para Imagem de Slide 1">
-            <a:extLst>
-              <a:ext uri="{FF2B5EF4-FFF2-40B4-BE49-F238E27FC236}">
-                <a16:creationId xmlns:a16="http://schemas.microsoft.com/office/drawing/2014/main" id="{2106633D-1F54-8FAB-37ED-AA08C8A57042}"/>
-              </a:ext>
-            </a:extLst>
-          </p:cNvPr>
-          <p:cNvSpPr>
-            <a:spLocks noGrp="1" noRot="1" noChangeAspect="1"/>
-          </p:cNvSpPr>
-          <p:nvPr>
-            <p:ph type="sldImg"/>
-          </p:nvPr>
-        </p:nvSpPr>
-        <p:spPr/>
-        <p:txBody>
-          <a:bodyPr/>
-          <a:lstStyle/>
-          <a:p>
-            <a:endParaRPr lang="pt-BR"/>
-          </a:p>
-        </p:txBody>
-      </p:sp>
-      <p:sp>
-        <p:nvSpPr>
-          <p:cNvPr id="3" name="Espaço Reservado para Anotações 2">
-            <a:extLst>
-              <a:ext uri="{FF2B5EF4-FFF2-40B4-BE49-F238E27FC236}">
-                <a16:creationId xmlns:a16="http://schemas.microsoft.com/office/drawing/2014/main" id="{89181BB8-8B7B-16D8-D0DF-223F60DC3311}"/>
-              </a:ext>
-            </a:extLst>
-          </p:cNvPr>
-          <p:cNvSpPr>
-            <a:spLocks noGrp="1"/>
-          </p:cNvSpPr>
-          <p:nvPr>
-            <p:ph type="body" idx="1"/>
-          </p:nvPr>
-        </p:nvSpPr>
-        <p:spPr/>
-        <p:txBody>
-          <a:bodyPr/>
-          <a:lstStyle/>
-          <a:p>
-            <a:pPr marL="0" indent="0">
-              <a:buFontTx/>
-              <a:buNone/>
-            </a:pPr>
-            <a:endParaRPr lang="pt-BR" b="0" dirty="0"/>
-          </a:p>
-        </p:txBody>
-      </p:sp>
-      <p:sp>
-        <p:nvSpPr>
-          <p:cNvPr id="4" name="Espaço Reservado para Número de Slide 3">
-            <a:extLst>
-              <a:ext uri="{FF2B5EF4-FFF2-40B4-BE49-F238E27FC236}">
-                <a16:creationId xmlns:a16="http://schemas.microsoft.com/office/drawing/2014/main" id="{93357B66-B802-73F9-97C6-9409970A94B5}"/>
-              </a:ext>
-            </a:extLst>
-          </p:cNvPr>
-          <p:cNvSpPr>
-            <a:spLocks noGrp="1"/>
-          </p:cNvSpPr>
-          <p:nvPr>
-            <p:ph type="sldNum" sz="quarter" idx="5"/>
-          </p:nvPr>
-        </p:nvSpPr>
-        <p:spPr/>
-        <p:txBody>
-          <a:bodyPr/>
-          <a:lstStyle/>
-          <a:p>
-            <a:fld id="{80F36A49-A1DD-40F8-B8AD-E6F5365256CB}" type="slidenum">
-              <a:rPr lang="pt-BR" smtClean="0"/>
-              <a:t>49</a:t>
-            </a:fld>
-            <a:endParaRPr lang="pt-BR"/>
-          </a:p>
-        </p:txBody>
-      </p:sp>
-    </p:spTree>
-    <p:extLst>
-      <p:ext uri="{BB962C8B-B14F-4D97-AF65-F5344CB8AC3E}">
-        <p14:creationId xmlns:p14="http://schemas.microsoft.com/office/powerpoint/2010/main" val="872282824"/>
-      </p:ext>
-    </p:extLst>
-  </p:cSld>
-  <p:clrMapOvr>
-    <a:masterClrMapping/>
-  </p:clrMapOvr>
-</p:notes>
-</file>
-
 <file path=ppt/notesSlides/notesSlide5.xml><?xml version="1.0" encoding="utf-8"?>
 <p:notes xmlns:a="http://schemas.openxmlformats.org/drawingml/2006/main" xmlns:r="http://schemas.openxmlformats.org/officeDocument/2006/relationships" xmlns:p="http://schemas.openxmlformats.org/presentationml/2006/main">
   <p:cSld>
@@ -6863,7 +6743,7 @@
           <a:p>
             <a:fld id="{A87E3B6E-8316-4A1C-BADA-DB7F3456EEF1}" type="datetimeFigureOut">
               <a:rPr lang="pt-BR" smtClean="0"/>
-              <a:t>14/08/2026</a:t>
+              <a:t>15/08/2026</a:t>
             </a:fld>
             <a:endParaRPr lang="pt-BR"/>
           </a:p>
@@ -7061,7 +6941,7 @@
           <a:p>
             <a:fld id="{A87E3B6E-8316-4A1C-BADA-DB7F3456EEF1}" type="datetimeFigureOut">
               <a:rPr lang="pt-BR" smtClean="0"/>
-              <a:t>14/08/2026</a:t>
+              <a:t>15/08/2026</a:t>
             </a:fld>
             <a:endParaRPr lang="pt-BR"/>
           </a:p>
@@ -7269,7 +7149,7 @@
           <a:p>
             <a:fld id="{A87E3B6E-8316-4A1C-BADA-DB7F3456EEF1}" type="datetimeFigureOut">
               <a:rPr lang="pt-BR" smtClean="0"/>
-              <a:t>14/08/2026</a:t>
+              <a:t>15/08/2026</a:t>
             </a:fld>
             <a:endParaRPr lang="pt-BR"/>
           </a:p>
@@ -7505,7 +7385,7 @@
           <a:p>
             <a:fld id="{A87E3B6E-8316-4A1C-BADA-DB7F3456EEF1}" type="datetimeFigureOut">
               <a:rPr lang="pt-BR" smtClean="0"/>
-              <a:t>14/08/2026</a:t>
+              <a:t>15/08/2026</a:t>
             </a:fld>
             <a:endParaRPr lang="pt-BR"/>
           </a:p>
@@ -7675,7 +7555,7 @@
           <a:p>
             <a:fld id="{A87E3B6E-8316-4A1C-BADA-DB7F3456EEF1}" type="datetimeFigureOut">
               <a:rPr lang="pt-BR" smtClean="0"/>
-              <a:t>14/08/2026</a:t>
+              <a:t>15/08/2026</a:t>
             </a:fld>
             <a:endParaRPr lang="pt-BR"/>
           </a:p>
@@ -7943,7 +7823,7 @@
           <a:p>
             <a:fld id="{A87E3B6E-8316-4A1C-BADA-DB7F3456EEF1}" type="datetimeFigureOut">
               <a:rPr lang="pt-BR" smtClean="0"/>
-              <a:t>14/08/2026</a:t>
+              <a:t>15/08/2026</a:t>
             </a:fld>
             <a:endParaRPr lang="pt-BR"/>
           </a:p>
@@ -8175,7 +8055,7 @@
           <a:p>
             <a:fld id="{A87E3B6E-8316-4A1C-BADA-DB7F3456EEF1}" type="datetimeFigureOut">
               <a:rPr lang="pt-BR" smtClean="0"/>
-              <a:t>14/08/2026</a:t>
+              <a:t>15/08/2026</a:t>
             </a:fld>
             <a:endParaRPr lang="pt-BR"/>
           </a:p>
@@ -8530,7 +8410,7 @@
           <a:p>
             <a:fld id="{A87E3B6E-8316-4A1C-BADA-DB7F3456EEF1}" type="datetimeFigureOut">
               <a:rPr lang="pt-BR" smtClean="0"/>
-              <a:t>14/08/2026</a:t>
+              <a:t>15/08/2026</a:t>
             </a:fld>
             <a:endParaRPr lang="pt-BR"/>
           </a:p>
@@ -8671,7 +8551,7 @@
           <a:p>
             <a:fld id="{A87E3B6E-8316-4A1C-BADA-DB7F3456EEF1}" type="datetimeFigureOut">
               <a:rPr lang="pt-BR" smtClean="0"/>
-              <a:t>14/08/2026</a:t>
+              <a:t>15/08/2026</a:t>
             </a:fld>
             <a:endParaRPr lang="pt-BR"/>
           </a:p>
@@ -8766,7 +8646,7 @@
           <a:p>
             <a:fld id="{A87E3B6E-8316-4A1C-BADA-DB7F3456EEF1}" type="datetimeFigureOut">
               <a:rPr lang="pt-BR" smtClean="0"/>
-              <a:t>14/08/2026</a:t>
+              <a:t>15/08/2026</a:t>
             </a:fld>
             <a:endParaRPr lang="pt-BR"/>
           </a:p>
@@ -9130,7 +9010,7 @@
           <a:p>
             <a:fld id="{A87E3B6E-8316-4A1C-BADA-DB7F3456EEF1}" type="datetimeFigureOut">
               <a:rPr lang="pt-BR" smtClean="0"/>
-              <a:t>14/08/2026</a:t>
+              <a:t>15/08/2026</a:t>
             </a:fld>
             <a:endParaRPr lang="pt-BR"/>
           </a:p>
@@ -9331,7 +9211,7 @@
           <a:p>
             <a:fld id="{A87E3B6E-8316-4A1C-BADA-DB7F3456EEF1}" type="datetimeFigureOut">
               <a:rPr lang="pt-BR" smtClean="0"/>
-              <a:t>14/08/2026</a:t>
+              <a:t>15/08/2026</a:t>
             </a:fld>
             <a:endParaRPr lang="pt-BR"/>
           </a:p>
@@ -9691,7 +9571,7 @@
           <a:p>
             <a:fld id="{A87E3B6E-8316-4A1C-BADA-DB7F3456EEF1}" type="datetimeFigureOut">
               <a:rPr lang="pt-BR" smtClean="0"/>
-              <a:t>14/08/2026</a:t>
+              <a:t>15/08/2026</a:t>
             </a:fld>
             <a:endParaRPr lang="pt-BR"/>
           </a:p>
@@ -9876,7 +9756,7 @@
           <a:p>
             <a:fld id="{A87E3B6E-8316-4A1C-BADA-DB7F3456EEF1}" type="datetimeFigureOut">
               <a:rPr lang="pt-BR" smtClean="0"/>
-              <a:t>14/08/2026</a:t>
+              <a:t>15/08/2026</a:t>
             </a:fld>
             <a:endParaRPr lang="pt-BR"/>
           </a:p>
@@ -10056,7 +9936,7 @@
           <a:p>
             <a:fld id="{A87E3B6E-8316-4A1C-BADA-DB7F3456EEF1}" type="datetimeFigureOut">
               <a:rPr lang="pt-BR" smtClean="0"/>
-              <a:t>14/08/2026</a:t>
+              <a:t>15/08/2026</a:t>
             </a:fld>
             <a:endParaRPr lang="pt-BR"/>
           </a:p>
@@ -10319,7 +10199,7 @@
           <a:p>
             <a:fld id="{A87E3B6E-8316-4A1C-BADA-DB7F3456EEF1}" type="datetimeFigureOut">
               <a:rPr lang="pt-BR" smtClean="0"/>
-              <a:t>14/08/2026</a:t>
+              <a:t>15/08/2026</a:t>
             </a:fld>
             <a:endParaRPr lang="pt-BR"/>
           </a:p>
@@ -10584,7 +10464,7 @@
           <a:p>
             <a:fld id="{A87E3B6E-8316-4A1C-BADA-DB7F3456EEF1}" type="datetimeFigureOut">
               <a:rPr lang="pt-BR" smtClean="0"/>
-              <a:t>14/08/2026</a:t>
+              <a:t>15/08/2026</a:t>
             </a:fld>
             <a:endParaRPr lang="pt-BR"/>
           </a:p>
@@ -10996,7 +10876,7 @@
           <a:p>
             <a:fld id="{A87E3B6E-8316-4A1C-BADA-DB7F3456EEF1}" type="datetimeFigureOut">
               <a:rPr lang="pt-BR" smtClean="0"/>
-              <a:t>14/08/2026</a:t>
+              <a:t>15/08/2026</a:t>
             </a:fld>
             <a:endParaRPr lang="pt-BR"/>
           </a:p>
@@ -11137,7 +11017,7 @@
           <a:p>
             <a:fld id="{A87E3B6E-8316-4A1C-BADA-DB7F3456EEF1}" type="datetimeFigureOut">
               <a:rPr lang="pt-BR" smtClean="0"/>
-              <a:t>14/08/2026</a:t>
+              <a:t>15/08/2026</a:t>
             </a:fld>
             <a:endParaRPr lang="pt-BR"/>
           </a:p>
@@ -11250,7 +11130,7 @@
           <a:p>
             <a:fld id="{A87E3B6E-8316-4A1C-BADA-DB7F3456EEF1}" type="datetimeFigureOut">
               <a:rPr lang="pt-BR" smtClean="0"/>
-              <a:t>14/08/2026</a:t>
+              <a:t>15/08/2026</a:t>
             </a:fld>
             <a:endParaRPr lang="pt-BR"/>
           </a:p>
@@ -11561,7 +11441,7 @@
           <a:p>
             <a:fld id="{A87E3B6E-8316-4A1C-BADA-DB7F3456EEF1}" type="datetimeFigureOut">
               <a:rPr lang="pt-BR" smtClean="0"/>
-              <a:t>14/08/2026</a:t>
+              <a:t>15/08/2026</a:t>
             </a:fld>
             <a:endParaRPr lang="pt-BR"/>
           </a:p>
@@ -11849,7 +11729,7 @@
           <a:p>
             <a:fld id="{A87E3B6E-8316-4A1C-BADA-DB7F3456EEF1}" type="datetimeFigureOut">
               <a:rPr lang="pt-BR" smtClean="0"/>
-              <a:t>14/08/2026</a:t>
+              <a:t>15/08/2026</a:t>
             </a:fld>
             <a:endParaRPr lang="pt-BR"/>
           </a:p>
@@ -12090,7 +11970,7 @@
           <a:p>
             <a:fld id="{A87E3B6E-8316-4A1C-BADA-DB7F3456EEF1}" type="datetimeFigureOut">
               <a:rPr lang="pt-BR" smtClean="0"/>
-              <a:t>14/08/2026</a:t>
+              <a:t>15/08/2026</a:t>
             </a:fld>
             <a:endParaRPr lang="pt-BR"/>
           </a:p>
@@ -12654,7 +12534,7 @@
           <a:p>
             <a:fld id="{A87E3B6E-8316-4A1C-BADA-DB7F3456EEF1}" type="datetimeFigureOut">
               <a:rPr lang="pt-BR" smtClean="0"/>
-              <a:t>14/08/2026</a:t>
+              <a:t>15/08/2026</a:t>
             </a:fld>
             <a:endParaRPr lang="pt-BR"/>
           </a:p>
@@ -27873,8 +27753,8 @@
           </a:p>
         </p:txBody>
       </p:sp>
-      <mc:AlternateContent xmlns:mc="http://schemas.openxmlformats.org/markup-compatibility/2006">
-        <mc:Choice xmlns:a14="http://schemas.microsoft.com/office/drawing/2010/main" Requires="a14">
+      <mc:AlternateContent xmlns:mc="http://schemas.openxmlformats.org/markup-compatibility/2006" xmlns:a14="http://schemas.microsoft.com/office/drawing/2010/main">
+        <mc:Choice Requires="a14">
           <p:sp>
             <p:nvSpPr>
               <p:cNvPr id="6" name="Espaço Reservado para Conteúdo 5">
@@ -28342,7 +28222,7 @@
             </p:txBody>
           </p:sp>
         </mc:Choice>
-        <mc:Fallback>
+        <mc:Fallback xmlns="">
           <p:sp>
             <p:nvSpPr>
               <p:cNvPr id="6" name="Espaço Reservado para Conteúdo 5">
@@ -30873,8 +30753,8 @@
           </a:p>
         </p:txBody>
       </p:sp>
-      <mc:AlternateContent xmlns:mc="http://schemas.openxmlformats.org/markup-compatibility/2006">
-        <mc:Choice xmlns:a14="http://schemas.microsoft.com/office/drawing/2010/main" Requires="a14">
+      <mc:AlternateContent xmlns:mc="http://schemas.openxmlformats.org/markup-compatibility/2006" xmlns:a14="http://schemas.microsoft.com/office/drawing/2010/main">
+        <mc:Choice Requires="a14">
           <p:sp>
             <p:nvSpPr>
               <p:cNvPr id="6" name="Espaço Reservado para Conteúdo 5">
@@ -31066,7 +30946,7 @@
             </p:txBody>
           </p:sp>
         </mc:Choice>
-        <mc:Fallback>
+        <mc:Fallback xmlns="">
           <p:sp>
             <p:nvSpPr>
               <p:cNvPr id="6" name="Espaço Reservado para Conteúdo 5">
@@ -32044,190 +31924,6 @@
     <p:extLst>
       <p:ext uri="{BB962C8B-B14F-4D97-AF65-F5344CB8AC3E}">
         <p14:creationId xmlns:p14="http://schemas.microsoft.com/office/powerpoint/2010/main" val="3816638370"/>
-      </p:ext>
-    </p:extLst>
-  </p:cSld>
-  <p:clrMapOvr>
-    <a:masterClrMapping/>
-  </p:clrMapOvr>
-</p:sld>
-</file>
-
-<file path=ppt/slides/slide49.xml><?xml version="1.0" encoding="utf-8"?>
-<p:sld xmlns:a="http://schemas.openxmlformats.org/drawingml/2006/main" xmlns:r="http://schemas.openxmlformats.org/officeDocument/2006/relationships" xmlns:p="http://schemas.openxmlformats.org/presentationml/2006/main">
-  <p:cSld>
-    <p:spTree>
-      <p:nvGrpSpPr>
-        <p:cNvPr id="1" name="">
-          <a:extLst>
-            <a:ext uri="{FF2B5EF4-FFF2-40B4-BE49-F238E27FC236}">
-              <a16:creationId xmlns:a16="http://schemas.microsoft.com/office/drawing/2014/main" id="{CDDC8225-CB7C-D8E4-6B39-81C86F128712}"/>
-            </a:ext>
-          </a:extLst>
-        </p:cNvPr>
-        <p:cNvGrpSpPr/>
-        <p:nvPr/>
-      </p:nvGrpSpPr>
-      <p:grpSpPr>
-        <a:xfrm>
-          <a:off x="0" y="0"/>
-          <a:ext cx="0" cy="0"/>
-          <a:chOff x="0" y="0"/>
-          <a:chExt cx="0" cy="0"/>
-        </a:xfrm>
-      </p:grpSpPr>
-      <p:sp>
-        <p:nvSpPr>
-          <p:cNvPr id="5" name="Retângulo 4">
-            <a:extLst>
-              <a:ext uri="{FF2B5EF4-FFF2-40B4-BE49-F238E27FC236}">
-                <a16:creationId xmlns:a16="http://schemas.microsoft.com/office/drawing/2014/main" id="{C4E2E90F-C942-6A3A-08A4-1F32163D1B2F}"/>
-              </a:ext>
-            </a:extLst>
-          </p:cNvPr>
-          <p:cNvSpPr/>
-          <p:nvPr/>
-        </p:nvSpPr>
-        <p:spPr>
-          <a:xfrm>
-            <a:off x="0" y="-2"/>
-            <a:ext cx="12192000" cy="1325563"/>
-          </a:xfrm>
-          <a:prstGeom prst="rect">
-            <a:avLst/>
-          </a:prstGeom>
-          <a:solidFill>
-            <a:schemeClr val="accent2"/>
-          </a:solidFill>
-          <a:ln>
-            <a:solidFill>
-              <a:srgbClr val="418AB3"/>
-            </a:solidFill>
-          </a:ln>
-        </p:spPr>
-        <p:style>
-          <a:lnRef idx="2">
-            <a:schemeClr val="accent1">
-              <a:shade val="15000"/>
-            </a:schemeClr>
-          </a:lnRef>
-          <a:fillRef idx="1">
-            <a:schemeClr val="accent1"/>
-          </a:fillRef>
-          <a:effectRef idx="0">
-            <a:schemeClr val="accent1"/>
-          </a:effectRef>
-          <a:fontRef idx="minor">
-            <a:schemeClr val="lt1"/>
-          </a:fontRef>
-        </p:style>
-        <p:txBody>
-          <a:bodyPr rtlCol="0" anchor="ctr"/>
-          <a:lstStyle/>
-          <a:p>
-            <a:pPr algn="ctr"/>
-            <a:endParaRPr lang="pt-BR" dirty="0"/>
-          </a:p>
-        </p:txBody>
-      </p:sp>
-      <p:sp>
-        <p:nvSpPr>
-          <p:cNvPr id="2" name="Título 1">
-            <a:extLst>
-              <a:ext uri="{FF2B5EF4-FFF2-40B4-BE49-F238E27FC236}">
-                <a16:creationId xmlns:a16="http://schemas.microsoft.com/office/drawing/2014/main" id="{CE817FEA-2591-A19F-DE91-A7599886F6F7}"/>
-              </a:ext>
-            </a:extLst>
-          </p:cNvPr>
-          <p:cNvSpPr>
-            <a:spLocks noGrp="1"/>
-          </p:cNvSpPr>
-          <p:nvPr>
-            <p:ph type="title"/>
-          </p:nvPr>
-        </p:nvSpPr>
-        <p:spPr>
-          <a:xfrm>
-            <a:off x="0" y="-1"/>
-            <a:ext cx="12192000" cy="1325563"/>
-          </a:xfrm>
-        </p:spPr>
-        <p:txBody>
-          <a:bodyPr/>
-          <a:lstStyle/>
-          <a:p>
-            <a:pPr algn="ctr"/>
-            <a:r>
-              <a:rPr lang="pt-BR" dirty="0">
-                <a:solidFill>
-                  <a:schemeClr val="bg1"/>
-                </a:solidFill>
-              </a:rPr>
-              <a:t>ARGUMENTOS LÓGICOS</a:t>
-            </a:r>
-          </a:p>
-        </p:txBody>
-      </p:sp>
-      <p:sp>
-        <p:nvSpPr>
-          <p:cNvPr id="6" name="Espaço Reservado para Conteúdo 5">
-            <a:extLst>
-              <a:ext uri="{FF2B5EF4-FFF2-40B4-BE49-F238E27FC236}">
-                <a16:creationId xmlns:a16="http://schemas.microsoft.com/office/drawing/2014/main" id="{E4D97BB6-A782-DFE3-7183-433201FDCA59}"/>
-              </a:ext>
-            </a:extLst>
-          </p:cNvPr>
-          <p:cNvSpPr>
-            <a:spLocks noGrp="1"/>
-          </p:cNvSpPr>
-          <p:nvPr>
-            <p:ph idx="1"/>
-          </p:nvPr>
-        </p:nvSpPr>
-        <p:spPr>
-          <a:xfrm>
-            <a:off x="1446797" y="1905000"/>
-            <a:ext cx="9298406" cy="4332514"/>
-          </a:xfrm>
-        </p:spPr>
-        <p:txBody>
-          <a:bodyPr>
-            <a:normAutofit/>
-          </a:bodyPr>
-          <a:lstStyle/>
-          <a:p>
-            <a:endParaRPr lang="pt-BR" sz="2400" dirty="0"/>
-          </a:p>
-          <a:p>
-            <a:pPr lvl="1" algn="just"/>
-            <a:endParaRPr lang="pt-BR" sz="2000" dirty="0"/>
-          </a:p>
-          <a:p>
-            <a:pPr marL="0" indent="0" algn="just">
-              <a:buNone/>
-            </a:pPr>
-            <a:endParaRPr lang="pt-BR" sz="2400" dirty="0">
-              <a:latin typeface="Cambria Math" panose="02040503050406030204" pitchFamily="18" charset="0"/>
-            </a:endParaRPr>
-          </a:p>
-          <a:p>
-            <a:pPr marL="457200" lvl="1" indent="0" algn="just">
-              <a:buNone/>
-            </a:pPr>
-            <a:endParaRPr lang="pt-BR" b="1" dirty="0"/>
-          </a:p>
-          <a:p>
-            <a:pPr marL="457200" lvl="1" indent="0" algn="just">
-              <a:buNone/>
-            </a:pPr>
-            <a:endParaRPr lang="pt-BR" b="1" dirty="0"/>
-          </a:p>
-        </p:txBody>
-      </p:sp>
-    </p:spTree>
-    <p:extLst>
-      <p:ext uri="{BB962C8B-B14F-4D97-AF65-F5344CB8AC3E}">
-        <p14:creationId xmlns:p14="http://schemas.microsoft.com/office/powerpoint/2010/main" val="2462127983"/>
       </p:ext>
     </p:extLst>
   </p:cSld>

</xml_diff>